<commit_message>
Speaker notes on every slide
Timing, the point each slide has to land, and the follow-up it tends to draw.
Presenter view only.

The two that matter: slide 2 has to plant representation collapse or slide 10
lands flat, and slide 8 says out loud that 54% vs 52% is noise rather than
waiting to be asked.
</commit_message>
<xml_diff>
--- a/slides/世界模型的两条路线.pptx
+++ b/slides/世界模型的两条路线.pptx
@@ -119,6 +119,1646 @@
     </a:lvl9pPr>
   </p:defaultTextStyle>
 </p:presentation>
+</file>
+
+<file path=ppt/notesMasters/notesMaster1.xml><?xml version="1.0" encoding="utf-8"?>
+<p:notesMaster xmlns:a="http://schemas.openxmlformats.org/drawingml/2006/main" xmlns:p="http://schemas.openxmlformats.org/presentationml/2006/main" xmlns:r="http://schemas.openxmlformats.org/officeDocument/2006/relationships">
+  <p:cSld>
+    <p:bg>
+      <p:bgRef idx="1001">
+        <a:schemeClr val="bg1"/>
+      </p:bgRef>
+    </p:bg>
+    <p:spTree>
+      <p:nvGrpSpPr>
+        <p:cNvPr id="1" name=""/>
+        <p:cNvGrpSpPr/>
+        <p:nvPr/>
+      </p:nvGrpSpPr>
+      <p:grpSpPr>
+        <a:xfrm>
+          <a:off x="0" y="0"/>
+          <a:ext cx="0" cy="0"/>
+          <a:chOff x="0" y="0"/>
+          <a:chExt cx="0" cy="0"/>
+        </a:xfrm>
+      </p:grpSpPr>
+      <p:sp>
+        <p:nvSpPr>
+          <p:cNvPr id="2" name="Header Placeholder 1"/>
+          <p:cNvSpPr>
+            <a:spLocks noGrp="1"/>
+          </p:cNvSpPr>
+          <p:nvPr>
+            <p:ph type="hdr" sz="quarter"/>
+          </p:nvPr>
+        </p:nvSpPr>
+        <p:spPr>
+          <a:xfrm>
+            <a:off x="0" y="0"/>
+            <a:ext cx="2971800" cy="457200"/>
+          </a:xfrm>
+          <a:prstGeom prst="rect">
+            <a:avLst/>
+          </a:prstGeom>
+        </p:spPr>
+        <p:txBody>
+          <a:bodyPr vert="horz" lIns="91440" tIns="45720" rIns="91440" bIns="45720" rtlCol="0"/>
+          <a:lstStyle>
+            <a:lvl1pPr algn="l">
+              <a:defRPr sz="1200"/>
+            </a:lvl1pPr>
+          </a:lstStyle>
+          <a:p>
+            <a:endParaRPr lang="en-US"/>
+          </a:p>
+        </p:txBody>
+      </p:sp>
+      <p:sp>
+        <p:nvSpPr>
+          <p:cNvPr id="3" name="Date Placeholder 2"/>
+          <p:cNvSpPr>
+            <a:spLocks noGrp="1"/>
+          </p:cNvSpPr>
+          <p:nvPr>
+            <p:ph type="dt" idx="1"/>
+          </p:nvPr>
+        </p:nvSpPr>
+        <p:spPr>
+          <a:xfrm>
+            <a:off x="3884613" y="0"/>
+            <a:ext cx="2971800" cy="457200"/>
+          </a:xfrm>
+          <a:prstGeom prst="rect">
+            <a:avLst/>
+          </a:prstGeom>
+        </p:spPr>
+        <p:txBody>
+          <a:bodyPr vert="horz" lIns="91440" tIns="45720" rIns="91440" bIns="45720" rtlCol="0"/>
+          <a:lstStyle>
+            <a:lvl1pPr algn="r">
+              <a:defRPr sz="1200"/>
+            </a:lvl1pPr>
+          </a:lstStyle>
+          <a:p>
+            <a:fld id="{0F89C1C7-3DCD-1040-A9CF-14679D8B5DDD}" type="datetimeFigureOut">
+              <a:rPr lang="en-US" smtClean="0"/>
+              <a:t>10/17/16</a:t>
+            </a:fld>
+            <a:endParaRPr lang="en-US"/>
+          </a:p>
+        </p:txBody>
+      </p:sp>
+      <p:sp>
+        <p:nvSpPr>
+          <p:cNvPr id="4" name="Slide Image Placeholder 3"/>
+          <p:cNvSpPr>
+            <a:spLocks noGrp="1" noRot="1" noChangeAspect="1"/>
+          </p:cNvSpPr>
+          <p:nvPr>
+            <p:ph type="sldImg" idx="2"/>
+          </p:nvPr>
+        </p:nvSpPr>
+        <p:spPr>
+          <a:xfrm>
+            <a:off x="1143000" y="685800"/>
+            <a:ext cx="4572000" cy="3429000"/>
+          </a:xfrm>
+          <a:prstGeom prst="rect">
+            <a:avLst/>
+          </a:prstGeom>
+          <a:noFill/>
+          <a:ln w="12700">
+            <a:solidFill>
+              <a:prstClr val="black"/>
+            </a:solidFill>
+          </a:ln>
+        </p:spPr>
+        <p:txBody>
+          <a:bodyPr vert="horz" lIns="91440" tIns="45720" rIns="91440" bIns="45720" rtlCol="0" anchor="ctr"/>
+          <a:lstStyle/>
+          <a:p>
+            <a:endParaRPr lang="en-US"/>
+          </a:p>
+        </p:txBody>
+      </p:sp>
+      <p:sp>
+        <p:nvSpPr>
+          <p:cNvPr id="5" name="Notes Placeholder 4"/>
+          <p:cNvSpPr>
+            <a:spLocks noGrp="1"/>
+          </p:cNvSpPr>
+          <p:nvPr>
+            <p:ph type="body" sz="quarter" idx="3"/>
+          </p:nvPr>
+        </p:nvSpPr>
+        <p:spPr>
+          <a:xfrm>
+            <a:off x="685800" y="4343400"/>
+            <a:ext cx="5486400" cy="4114800"/>
+          </a:xfrm>
+          <a:prstGeom prst="rect">
+            <a:avLst/>
+          </a:prstGeom>
+        </p:spPr>
+        <p:txBody>
+          <a:bodyPr vert="horz" lIns="91440" tIns="45720" rIns="91440" bIns="45720" rtlCol="0"/>
+          <a:lstStyle/>
+          <a:p>
+            <a:pPr lvl="0"/>
+            <a:r>
+              <a:rPr lang="en-US" smtClean="0"/>
+              <a:t>Click to edit Master text styles</a:t>
+            </a:r>
+          </a:p>
+          <a:p>
+            <a:pPr lvl="1"/>
+            <a:r>
+              <a:rPr lang="en-US" smtClean="0"/>
+              <a:t>Second level</a:t>
+            </a:r>
+          </a:p>
+          <a:p>
+            <a:pPr lvl="2"/>
+            <a:r>
+              <a:rPr lang="en-US" smtClean="0"/>
+              <a:t>Third level</a:t>
+            </a:r>
+          </a:p>
+          <a:p>
+            <a:pPr lvl="3"/>
+            <a:r>
+              <a:rPr lang="en-US" smtClean="0"/>
+              <a:t>Fourth level</a:t>
+            </a:r>
+          </a:p>
+          <a:p>
+            <a:pPr lvl="4"/>
+            <a:r>
+              <a:rPr lang="en-US" smtClean="0"/>
+              <a:t>Fifth level</a:t>
+            </a:r>
+            <a:endParaRPr lang="en-US"/>
+          </a:p>
+        </p:txBody>
+      </p:sp>
+      <p:sp>
+        <p:nvSpPr>
+          <p:cNvPr id="6" name="Footer Placeholder 5"/>
+          <p:cNvSpPr>
+            <a:spLocks noGrp="1"/>
+          </p:cNvSpPr>
+          <p:nvPr>
+            <p:ph type="ftr" sz="quarter" idx="4"/>
+          </p:nvPr>
+        </p:nvSpPr>
+        <p:spPr>
+          <a:xfrm>
+            <a:off x="0" y="8685213"/>
+            <a:ext cx="2971800" cy="457200"/>
+          </a:xfrm>
+          <a:prstGeom prst="rect">
+            <a:avLst/>
+          </a:prstGeom>
+        </p:spPr>
+        <p:txBody>
+          <a:bodyPr vert="horz" lIns="91440" tIns="45720" rIns="91440" bIns="45720" rtlCol="0" anchor="b"/>
+          <a:lstStyle>
+            <a:lvl1pPr algn="l">
+              <a:defRPr sz="1200"/>
+            </a:lvl1pPr>
+          </a:lstStyle>
+          <a:p>
+            <a:endParaRPr lang="en-US"/>
+          </a:p>
+        </p:txBody>
+      </p:sp>
+      <p:sp>
+        <p:nvSpPr>
+          <p:cNvPr id="7" name="Slide Number Placeholder 6"/>
+          <p:cNvSpPr>
+            <a:spLocks noGrp="1"/>
+          </p:cNvSpPr>
+          <p:nvPr>
+            <p:ph type="sldNum" sz="quarter" idx="5"/>
+          </p:nvPr>
+        </p:nvSpPr>
+        <p:spPr>
+          <a:xfrm>
+            <a:off x="3884613" y="8685213"/>
+            <a:ext cx="2971800" cy="457200"/>
+          </a:xfrm>
+          <a:prstGeom prst="rect">
+            <a:avLst/>
+          </a:prstGeom>
+        </p:spPr>
+        <p:txBody>
+          <a:bodyPr vert="horz" lIns="91440" tIns="45720" rIns="91440" bIns="45720" rtlCol="0" anchor="b"/>
+          <a:lstStyle>
+            <a:lvl1pPr algn="r">
+              <a:defRPr sz="1200"/>
+            </a:lvl1pPr>
+          </a:lstStyle>
+          <a:p>
+            <a:fld id="{BB5E49A5-4136-284D-997B-48E1D791AD67}" type="slidenum">
+              <a:rPr lang="en-US" smtClean="0"/>
+              <a:t>‹#›</a:t>
+            </a:fld>
+            <a:endParaRPr lang="en-US"/>
+          </a:p>
+        </p:txBody>
+      </p:sp>
+    </p:spTree>
+    <p:extLst>
+      <p:ext uri="{BB962C8B-B14F-4D97-AF65-F5344CB8AC3E}">
+        <p14:creationId xmlns:p14="http://schemas.microsoft.com/office/powerpoint/2010/main" val="2623252185"/>
+      </p:ext>
+    </p:extLst>
+  </p:cSld>
+  <p:clrMap bg1="lt1" tx1="dk1" bg2="lt2" tx2="dk2" accent1="accent1" accent2="accent2" accent3="accent3" accent4="accent4" accent5="accent5" accent6="accent6" hlink="hlink" folHlink="folHlink"/>
+  <p:notesStyle>
+    <a:lvl1pPr marL="0" algn="l" defTabSz="457200" rtl="0" eaLnBrk="1" latinLnBrk="0" hangingPunct="1">
+      <a:defRPr sz="1200" kern="1200">
+        <a:solidFill>
+          <a:schemeClr val="tx1"/>
+        </a:solidFill>
+        <a:latin typeface="+mn-lt"/>
+        <a:ea typeface="+mn-ea"/>
+        <a:cs typeface="+mn-cs"/>
+      </a:defRPr>
+    </a:lvl1pPr>
+    <a:lvl2pPr marL="457200" algn="l" defTabSz="457200" rtl="0" eaLnBrk="1" latinLnBrk="0" hangingPunct="1">
+      <a:defRPr sz="1200" kern="1200">
+        <a:solidFill>
+          <a:schemeClr val="tx1"/>
+        </a:solidFill>
+        <a:latin typeface="+mn-lt"/>
+        <a:ea typeface="+mn-ea"/>
+        <a:cs typeface="+mn-cs"/>
+      </a:defRPr>
+    </a:lvl2pPr>
+    <a:lvl3pPr marL="914400" algn="l" defTabSz="457200" rtl="0" eaLnBrk="1" latinLnBrk="0" hangingPunct="1">
+      <a:defRPr sz="1200" kern="1200">
+        <a:solidFill>
+          <a:schemeClr val="tx1"/>
+        </a:solidFill>
+        <a:latin typeface="+mn-lt"/>
+        <a:ea typeface="+mn-ea"/>
+        <a:cs typeface="+mn-cs"/>
+      </a:defRPr>
+    </a:lvl3pPr>
+    <a:lvl4pPr marL="1371600" algn="l" defTabSz="457200" rtl="0" eaLnBrk="1" latinLnBrk="0" hangingPunct="1">
+      <a:defRPr sz="1200" kern="1200">
+        <a:solidFill>
+          <a:schemeClr val="tx1"/>
+        </a:solidFill>
+        <a:latin typeface="+mn-lt"/>
+        <a:ea typeface="+mn-ea"/>
+        <a:cs typeface="+mn-cs"/>
+      </a:defRPr>
+    </a:lvl4pPr>
+    <a:lvl5pPr marL="1828800" algn="l" defTabSz="457200" rtl="0" eaLnBrk="1" latinLnBrk="0" hangingPunct="1">
+      <a:defRPr sz="1200" kern="1200">
+        <a:solidFill>
+          <a:schemeClr val="tx1"/>
+        </a:solidFill>
+        <a:latin typeface="+mn-lt"/>
+        <a:ea typeface="+mn-ea"/>
+        <a:cs typeface="+mn-cs"/>
+      </a:defRPr>
+    </a:lvl5pPr>
+    <a:lvl6pPr marL="2286000" algn="l" defTabSz="457200" rtl="0" eaLnBrk="1" latinLnBrk="0" hangingPunct="1">
+      <a:defRPr sz="1200" kern="1200">
+        <a:solidFill>
+          <a:schemeClr val="tx1"/>
+        </a:solidFill>
+        <a:latin typeface="+mn-lt"/>
+        <a:ea typeface="+mn-ea"/>
+        <a:cs typeface="+mn-cs"/>
+      </a:defRPr>
+    </a:lvl6pPr>
+    <a:lvl7pPr marL="2743200" algn="l" defTabSz="457200" rtl="0" eaLnBrk="1" latinLnBrk="0" hangingPunct="1">
+      <a:defRPr sz="1200" kern="1200">
+        <a:solidFill>
+          <a:schemeClr val="tx1"/>
+        </a:solidFill>
+        <a:latin typeface="+mn-lt"/>
+        <a:ea typeface="+mn-ea"/>
+        <a:cs typeface="+mn-cs"/>
+      </a:defRPr>
+    </a:lvl7pPr>
+    <a:lvl8pPr marL="3200400" algn="l" defTabSz="457200" rtl="0" eaLnBrk="1" latinLnBrk="0" hangingPunct="1">
+      <a:defRPr sz="1200" kern="1200">
+        <a:solidFill>
+          <a:schemeClr val="tx1"/>
+        </a:solidFill>
+        <a:latin typeface="+mn-lt"/>
+        <a:ea typeface="+mn-ea"/>
+        <a:cs typeface="+mn-cs"/>
+      </a:defRPr>
+    </a:lvl8pPr>
+    <a:lvl9pPr marL="3657600" algn="l" defTabSz="457200" rtl="0" eaLnBrk="1" latinLnBrk="0" hangingPunct="1">
+      <a:defRPr sz="1200" kern="1200">
+        <a:solidFill>
+          <a:schemeClr val="tx1"/>
+        </a:solidFill>
+        <a:latin typeface="+mn-lt"/>
+        <a:ea typeface="+mn-ea"/>
+        <a:cs typeface="+mn-cs"/>
+      </a:defRPr>
+    </a:lvl9pPr>
+  </p:notesStyle>
+</p:notesMaster>
+</file>
+
+<file path=ppt/notesSlides/notesSlide1.xml><?xml version="1.0" encoding="utf-8"?>
+<p:notes xmlns:a="http://schemas.openxmlformats.org/drawingml/2006/main" xmlns:p="http://schemas.openxmlformats.org/presentationml/2006/main" xmlns:r="http://schemas.openxmlformats.org/officeDocument/2006/relationships">
+  <p:cSld>
+    <p:spTree>
+      <p:nvGrpSpPr>
+        <p:cNvPr id="1" name=""/>
+        <p:cNvGrpSpPr/>
+        <p:nvPr/>
+      </p:nvGrpSpPr>
+      <p:grpSpPr>
+        <a:xfrm>
+          <a:off x="0" y="0"/>
+          <a:ext cx="0" cy="0"/>
+          <a:chOff x="0" y="0"/>
+          <a:chExt cx="0" cy="0"/>
+        </a:xfrm>
+      </p:grpSpPr>
+      <p:sp>
+        <p:nvSpPr>
+          <p:cNvPr id="2" name="Slide Image Placeholder 1"/>
+          <p:cNvSpPr>
+            <a:spLocks noGrp="1"/>
+          </p:cNvSpPr>
+          <p:nvPr>
+            <p:ph type="sldImg" idx="2"/>
+          </p:nvPr>
+        </p:nvSpPr>
+        <p:spPr/>
+      </p:sp>
+      <p:sp>
+        <p:nvSpPr>
+          <p:cNvPr id="3" name="Notes Placeholder 2"/>
+          <p:cNvSpPr>
+            <a:spLocks noGrp="1"/>
+          </p:cNvSpPr>
+          <p:nvPr>
+            <p:ph type="body" idx="3" sz="quarter"/>
+          </p:nvPr>
+        </p:nvSpPr>
+        <p:spPr/>
+        <p:txBody>
+          <a:bodyPr/>
+          <a:lstStyle/>
+          <a:p>
+            <a:r>
+              <a:t>10秒。不要念标题。</a:t>
+            </a:r>
+          </a:p>
+          <a:p>
+            <a:r>
+              <a:t>「我做的是世界模型方向的复现加实验项目。两条路线都做了，但重点在后面自己设计的实验。」</a:t>
+            </a:r>
+          </a:p>
+        </p:txBody>
+      </p:sp>
+      <p:sp>
+        <p:nvSpPr>
+          <p:cNvPr id="4" name="Slide Number Placeholder 3"/>
+          <p:cNvSpPr>
+            <a:spLocks noGrp="1"/>
+          </p:cNvSpPr>
+          <p:nvPr>
+            <p:ph type="sldNum" idx="5" sz="quarter"/>
+          </p:nvPr>
+        </p:nvSpPr>
+        <p:spPr/>
+      </p:sp>
+    </p:spTree>
+  </p:cSld>
+  <p:clrMapOvr>
+    <a:masterClrMapping/>
+  </p:clrMapOvr>
+</p:notes>
+</file>
+
+<file path=ppt/notesSlides/notesSlide10.xml><?xml version="1.0" encoding="utf-8"?>
+<p:notes xmlns:a="http://schemas.openxmlformats.org/drawingml/2006/main" xmlns:p="http://schemas.openxmlformats.org/presentationml/2006/main" xmlns:r="http://schemas.openxmlformats.org/officeDocument/2006/relationships">
+  <p:cSld>
+    <p:spTree>
+      <p:nvGrpSpPr>
+        <p:cNvPr id="1" name=""/>
+        <p:cNvGrpSpPr/>
+        <p:nvPr/>
+      </p:nvGrpSpPr>
+      <p:grpSpPr>
+        <a:xfrm>
+          <a:off x="0" y="0"/>
+          <a:ext cx="0" cy="0"/>
+          <a:chOff x="0" y="0"/>
+          <a:chExt cx="0" cy="0"/>
+        </a:xfrm>
+      </p:grpSpPr>
+      <p:sp>
+        <p:nvSpPr>
+          <p:cNvPr id="2" name="Slide Image Placeholder 1"/>
+          <p:cNvSpPr>
+            <a:spLocks noGrp="1"/>
+          </p:cNvSpPr>
+          <p:nvPr>
+            <p:ph type="sldImg" idx="2"/>
+          </p:nvPr>
+        </p:nvSpPr>
+        <p:spPr/>
+      </p:sp>
+      <p:sp>
+        <p:nvSpPr>
+          <p:cNvPr id="3" name="Notes Placeholder 2"/>
+          <p:cNvSpPr>
+            <a:spLocks noGrp="1"/>
+          </p:cNvSpPr>
+          <p:nvPr>
+            <p:ph type="body" idx="3" sz="quarter"/>
+          </p:nvPr>
+        </p:nvSpPr>
+        <p:spPr/>
+        <p:txBody>
+          <a:bodyPr/>
+          <a:lstStyle/>
+          <a:p>
+            <a:r>
+              <a:t>60秒。全场高潮，语速放慢。</a:t>
+            </a:r>
+          </a:p>
+          <a:p>
+            <a:r>
+              <a:t>「把SIGReg权重从0.09调到0.001，几乎关掉。结果预测loss掉到0.004——整晚最低，比正常好60倍。」</a:t>
+            </a:r>
+          </a:p>
+          <a:p>
+            <a:r>
+              <a:t>【停】「但这个数字是假的。」【停】</a:t>
+            </a:r>
+          </a:p>
+          <a:p>
+            <a:r>
+              <a:t>「我没有相信它。我写了个脚本，加载checkpoint、编码256帧真实数据、直接测每维标准差——192维里69维方差趋近于零。encoder塌缩了。」</a:t>
+            </a:r>
+          </a:p>
+          <a:p>
+            <a:r>
+              <a:t>「模型找到作弊解：输出常数向量。预测常数当然不费力，所以loss反而好看。这个指标在这里是反向的。」</a:t>
+            </a:r>
+          </a:p>
+          <a:p>
+            <a:r>
+              <a:t>成功率印证：34%，全场最差。</a:t>
+            </a:r>
+          </a:p>
+          <a:p>
+            <a:r>
+              <a:t>三要素缺一不可：数字反常 → 我不信 → 我设计独立测量去验证。</a:t>
+            </a:r>
+          </a:p>
+        </p:txBody>
+      </p:sp>
+      <p:sp>
+        <p:nvSpPr>
+          <p:cNvPr id="4" name="Slide Number Placeholder 3"/>
+          <p:cNvSpPr>
+            <a:spLocks noGrp="1"/>
+          </p:cNvSpPr>
+          <p:nvPr>
+            <p:ph type="sldNum" idx="5" sz="quarter"/>
+          </p:nvPr>
+        </p:nvSpPr>
+        <p:spPr/>
+      </p:sp>
+    </p:spTree>
+  </p:cSld>
+  <p:clrMapOvr>
+    <a:masterClrMapping/>
+  </p:clrMapOvr>
+</p:notes>
+</file>
+
+<file path=ppt/notesSlides/notesSlide11.xml><?xml version="1.0" encoding="utf-8"?>
+<p:notes xmlns:a="http://schemas.openxmlformats.org/drawingml/2006/main" xmlns:p="http://schemas.openxmlformats.org/presentationml/2006/main" xmlns:r="http://schemas.openxmlformats.org/officeDocument/2006/relationships">
+  <p:cSld>
+    <p:spTree>
+      <p:nvGrpSpPr>
+        <p:cNvPr id="1" name=""/>
+        <p:cNvGrpSpPr/>
+        <p:nvPr/>
+      </p:nvGrpSpPr>
+      <p:grpSpPr>
+        <a:xfrm>
+          <a:off x="0" y="0"/>
+          <a:ext cx="0" cy="0"/>
+          <a:chOff x="0" y="0"/>
+          <a:chExt cx="0" cy="0"/>
+        </a:xfrm>
+      </p:grpSpPr>
+      <p:sp>
+        <p:nvSpPr>
+          <p:cNvPr id="2" name="Slide Image Placeholder 1"/>
+          <p:cNvSpPr>
+            <a:spLocks noGrp="1"/>
+          </p:cNvSpPr>
+          <p:nvPr>
+            <p:ph type="sldImg" idx="2"/>
+          </p:nvPr>
+        </p:nvSpPr>
+        <p:spPr/>
+      </p:sp>
+      <p:sp>
+        <p:nvSpPr>
+          <p:cNvPr id="3" name="Notes Placeholder 2"/>
+          <p:cNvSpPr>
+            <a:spLocks noGrp="1"/>
+          </p:cNvSpPr>
+          <p:nvPr>
+            <p:ph type="body" idx="3" sz="quarter"/>
+          </p:nvPr>
+        </p:nvSpPr>
+        <p:spPr/>
+        <p:txBody>
+          <a:bodyPr/>
+          <a:lstStyle/>
+          <a:p>
+            <a:r>
+              <a:t>50秒。</a:t>
+            </a:r>
+          </a:p>
+          <a:p>
+            <a:r>
+              <a:t>看sigreg_loss那一列：塌缩时50.75，是健康情况的十倍。</a:t>
+            </a:r>
+          </a:p>
+          <a:p>
+            <a:r>
+              <a:t>「正则项一直在报警，它完全检测到了塌缩。但权重只有0.001，贡献只有0.05；而模型靠塌缩把预测误差从0.27降到0.004，净赚0.26。」</a:t>
+            </a:r>
+          </a:p>
+          <a:p>
+            <a:r>
+              <a:t>【重】「它不是失灵，是被架空了——出价出不过。」</a:t>
+            </a:r>
+          </a:p>
+          <a:p>
+            <a:r>
+              <a:t>【加分：现场心算】总loss 0.0548 = 预测0.004 + 0.001×50.75。严丝合缝。</a:t>
+            </a:r>
+          </a:p>
+          <a:p>
+            <a:r>
+              <a:t>另一头10倍权重不塌缩但压太紧，成功率38%。倒U，论文的0.09在顶点。</a:t>
+            </a:r>
+          </a:p>
+        </p:txBody>
+      </p:sp>
+      <p:sp>
+        <p:nvSpPr>
+          <p:cNvPr id="4" name="Slide Number Placeholder 3"/>
+          <p:cNvSpPr>
+            <a:spLocks noGrp="1"/>
+          </p:cNvSpPr>
+          <p:nvPr>
+            <p:ph type="sldNum" idx="5" sz="quarter"/>
+          </p:nvPr>
+        </p:nvSpPr>
+        <p:spPr/>
+      </p:sp>
+    </p:spTree>
+  </p:cSld>
+  <p:clrMapOvr>
+    <a:masterClrMapping/>
+  </p:clrMapOvr>
+</p:notes>
+</file>
+
+<file path=ppt/notesSlides/notesSlide12.xml><?xml version="1.0" encoding="utf-8"?>
+<p:notes xmlns:a="http://schemas.openxmlformats.org/drawingml/2006/main" xmlns:p="http://schemas.openxmlformats.org/presentationml/2006/main" xmlns:r="http://schemas.openxmlformats.org/officeDocument/2006/relationships">
+  <p:cSld>
+    <p:spTree>
+      <p:nvGrpSpPr>
+        <p:cNvPr id="1" name=""/>
+        <p:cNvGrpSpPr/>
+        <p:nvPr/>
+      </p:nvGrpSpPr>
+      <p:grpSpPr>
+        <a:xfrm>
+          <a:off x="0" y="0"/>
+          <a:ext cx="0" cy="0"/>
+          <a:chOff x="0" y="0"/>
+          <a:chExt cx="0" cy="0"/>
+        </a:xfrm>
+      </p:grpSpPr>
+      <p:sp>
+        <p:nvSpPr>
+          <p:cNvPr id="2" name="Slide Image Placeholder 1"/>
+          <p:cNvSpPr>
+            <a:spLocks noGrp="1"/>
+          </p:cNvSpPr>
+          <p:nvPr>
+            <p:ph type="sldImg" idx="2"/>
+          </p:nvPr>
+        </p:nvSpPr>
+        <p:spPr/>
+      </p:sp>
+      <p:sp>
+        <p:nvSpPr>
+          <p:cNvPr id="3" name="Notes Placeholder 2"/>
+          <p:cNvSpPr>
+            <a:spLocks noGrp="1"/>
+          </p:cNvSpPr>
+          <p:nvPr>
+            <p:ph type="body" idx="3" sz="quarter"/>
+          </p:nvPr>
+        </p:nvSpPr>
+        <p:spPr/>
+        <p:txBody>
+          <a:bodyPr/>
+          <a:lstStyle/>
+          <a:p>
+            <a:r>
+              <a:t>30秒。收结论，别拖。</a:t>
+            </a:r>
+          </a:p>
+          <a:p>
+            <a:r>
+              <a:t>「六个checkpoint放一起，横轴loss对数轴跨三个数量级，纵轴成功率。」</a:t>
+            </a:r>
+          </a:p>
+          <a:p>
+            <a:r>
+              <a:t>「如果loss是可靠代理，应该是向右下的趋势线。【停】它没有趋势。」</a:t>
+            </a:r>
+          </a:p>
+          <a:p>
+            <a:r>
+              <a:t>「loss最低那个是塌缩模型，规划几乎最差；规划最好的甚至不是LeWM。」</a:t>
+            </a:r>
+          </a:p>
+        </p:txBody>
+      </p:sp>
+      <p:sp>
+        <p:nvSpPr>
+          <p:cNvPr id="4" name="Slide Number Placeholder 3"/>
+          <p:cNvSpPr>
+            <a:spLocks noGrp="1"/>
+          </p:cNvSpPr>
+          <p:nvPr>
+            <p:ph type="sldNum" idx="5" sz="quarter"/>
+          </p:nvPr>
+        </p:nvSpPr>
+        <p:spPr/>
+      </p:sp>
+    </p:spTree>
+  </p:cSld>
+  <p:clrMapOvr>
+    <a:masterClrMapping/>
+  </p:clrMapOvr>
+</p:notes>
+</file>
+
+<file path=ppt/notesSlides/notesSlide13.xml><?xml version="1.0" encoding="utf-8"?>
+<p:notes xmlns:a="http://schemas.openxmlformats.org/drawingml/2006/main" xmlns:p="http://schemas.openxmlformats.org/presentationml/2006/main" xmlns:r="http://schemas.openxmlformats.org/officeDocument/2006/relationships">
+  <p:cSld>
+    <p:spTree>
+      <p:nvGrpSpPr>
+        <p:cNvPr id="1" name=""/>
+        <p:cNvGrpSpPr/>
+        <p:nvPr/>
+      </p:nvGrpSpPr>
+      <p:grpSpPr>
+        <a:xfrm>
+          <a:off x="0" y="0"/>
+          <a:ext cx="0" cy="0"/>
+          <a:chOff x="0" y="0"/>
+          <a:chExt cx="0" cy="0"/>
+        </a:xfrm>
+      </p:grpSpPr>
+      <p:sp>
+        <p:nvSpPr>
+          <p:cNvPr id="2" name="Slide Image Placeholder 1"/>
+          <p:cNvSpPr>
+            <a:spLocks noGrp="1"/>
+          </p:cNvSpPr>
+          <p:nvPr>
+            <p:ph type="sldImg" idx="2"/>
+          </p:nvPr>
+        </p:nvSpPr>
+        <p:spPr/>
+      </p:sp>
+      <p:sp>
+        <p:nvSpPr>
+          <p:cNvPr id="3" name="Notes Placeholder 2"/>
+          <p:cNvSpPr>
+            <a:spLocks noGrp="1"/>
+          </p:cNvSpPr>
+          <p:nvPr>
+            <p:ph type="body" idx="3" sz="quarter"/>
+          </p:nvPr>
+        </p:nvSpPr>
+        <p:spPr/>
+        <p:txBody>
+          <a:bodyPr/>
+          <a:lstStyle/>
+          <a:p>
+            <a:r>
+              <a:t>25秒。时间紧可跳。</a:t>
+            </a:r>
+          </a:p>
+          <a:p>
+            <a:r>
+              <a:t>「手写版证明我理解组件，规模上另外跑了官方DreamerV3在walker-walk，接近任务天花板。两条线分工：一条证明理解，一条拿真实曲线。」</a:t>
+            </a:r>
+          </a:p>
+        </p:txBody>
+      </p:sp>
+      <p:sp>
+        <p:nvSpPr>
+          <p:cNvPr id="4" name="Slide Number Placeholder 3"/>
+          <p:cNvSpPr>
+            <a:spLocks noGrp="1"/>
+          </p:cNvSpPr>
+          <p:nvPr>
+            <p:ph type="sldNum" idx="5" sz="quarter"/>
+          </p:nvPr>
+        </p:nvSpPr>
+        <p:spPr/>
+      </p:sp>
+    </p:spTree>
+  </p:cSld>
+  <p:clrMapOvr>
+    <a:masterClrMapping/>
+  </p:clrMapOvr>
+</p:notes>
+</file>
+
+<file path=ppt/notesSlides/notesSlide14.xml><?xml version="1.0" encoding="utf-8"?>
+<p:notes xmlns:a="http://schemas.openxmlformats.org/drawingml/2006/main" xmlns:p="http://schemas.openxmlformats.org/presentationml/2006/main" xmlns:r="http://schemas.openxmlformats.org/officeDocument/2006/relationships">
+  <p:cSld>
+    <p:spTree>
+      <p:nvGrpSpPr>
+        <p:cNvPr id="1" name=""/>
+        <p:cNvGrpSpPr/>
+        <p:nvPr/>
+      </p:nvGrpSpPr>
+      <p:grpSpPr>
+        <a:xfrm>
+          <a:off x="0" y="0"/>
+          <a:ext cx="0" cy="0"/>
+          <a:chOff x="0" y="0"/>
+          <a:chExt cx="0" cy="0"/>
+        </a:xfrm>
+      </p:grpSpPr>
+      <p:sp>
+        <p:nvSpPr>
+          <p:cNvPr id="2" name="Slide Image Placeholder 1"/>
+          <p:cNvSpPr>
+            <a:spLocks noGrp="1"/>
+          </p:cNvSpPr>
+          <p:nvPr>
+            <p:ph type="sldImg" idx="2"/>
+          </p:nvPr>
+        </p:nvSpPr>
+        <p:spPr/>
+      </p:sp>
+      <p:sp>
+        <p:nvSpPr>
+          <p:cNvPr id="3" name="Notes Placeholder 2"/>
+          <p:cNvSpPr>
+            <a:spLocks noGrp="1"/>
+          </p:cNvSpPr>
+          <p:nvPr>
+            <p:ph type="body" idx="3" sz="quarter"/>
+          </p:nvPr>
+        </p:nvSpPr>
+        <p:spPr/>
+        <p:txBody>
+          <a:bodyPr/>
+          <a:lstStyle/>
+          <a:p>
+            <a:r>
+              <a:t>40秒。看岗位决定讲不讲——工程岗讲，研究岗一句带过。</a:t>
+            </a:r>
+          </a:p>
+          <a:p>
+            <a:r>
+              <a:t>坑1：软链torch复用，包管理器顺着软链把另一个项目的torch就地升级了，而它还有跑了一天的进程在跑（靠Linux对已打开inode的保护才没崩）。</a:t>
+            </a:r>
+          </a:p>
+          <a:p>
+            <a:r>
+              <a:t>坑2：原计划扫latent dimension直接崩——那参数不是自由的，和编码器宽度硬绑定。失败本身加深了理解。</a:t>
+            </a:r>
+          </a:p>
+          <a:p>
+            <a:r>
+              <a:t>坑3：终端日志卡住一小时以为挂了，其实是stdout缓冲，指标文件早跑过去了。</a:t>
+            </a:r>
+          </a:p>
+        </p:txBody>
+      </p:sp>
+      <p:sp>
+        <p:nvSpPr>
+          <p:cNvPr id="4" name="Slide Number Placeholder 3"/>
+          <p:cNvSpPr>
+            <a:spLocks noGrp="1"/>
+          </p:cNvSpPr>
+          <p:nvPr>
+            <p:ph type="sldNum" idx="5" sz="quarter"/>
+          </p:nvPr>
+        </p:nvSpPr>
+        <p:spPr/>
+      </p:sp>
+    </p:spTree>
+  </p:cSld>
+  <p:clrMapOvr>
+    <a:masterClrMapping/>
+  </p:clrMapOvr>
+</p:notes>
+</file>
+
+<file path=ppt/notesSlides/notesSlide15.xml><?xml version="1.0" encoding="utf-8"?>
+<p:notes xmlns:a="http://schemas.openxmlformats.org/drawingml/2006/main" xmlns:p="http://schemas.openxmlformats.org/presentationml/2006/main" xmlns:r="http://schemas.openxmlformats.org/officeDocument/2006/relationships">
+  <p:cSld>
+    <p:spTree>
+      <p:nvGrpSpPr>
+        <p:cNvPr id="1" name=""/>
+        <p:cNvGrpSpPr/>
+        <p:nvPr/>
+      </p:nvGrpSpPr>
+      <p:grpSpPr>
+        <a:xfrm>
+          <a:off x="0" y="0"/>
+          <a:ext cx="0" cy="0"/>
+          <a:chOff x="0" y="0"/>
+          <a:chExt cx="0" cy="0"/>
+        </a:xfrm>
+      </p:grpSpPr>
+      <p:sp>
+        <p:nvSpPr>
+          <p:cNvPr id="2" name="Slide Image Placeholder 1"/>
+          <p:cNvSpPr>
+            <a:spLocks noGrp="1"/>
+          </p:cNvSpPr>
+          <p:nvPr>
+            <p:ph type="sldImg" idx="2"/>
+          </p:nvPr>
+        </p:nvSpPr>
+        <p:spPr/>
+      </p:sp>
+      <p:sp>
+        <p:nvSpPr>
+          <p:cNvPr id="3" name="Notes Placeholder 2"/>
+          <p:cNvSpPr>
+            <a:spLocks noGrp="1"/>
+          </p:cNvSpPr>
+          <p:nvPr>
+            <p:ph type="body" idx="3" sz="quarter"/>
+          </p:nvPr>
+        </p:nvSpPr>
+        <p:spPr/>
+        <p:txBody>
+          <a:bodyPr/>
+          <a:lstStyle/>
+          <a:p>
+            <a:r>
+              <a:t>45秒。决定最后印象。</a:t>
+            </a:r>
+          </a:p>
+          <a:p>
+            <a:r>
+              <a:t>站得住：塌缩那组，18点差距 + 独立机制测量佐证——唯一有两类独立证据的结论。</a:t>
+            </a:r>
+          </a:p>
+          <a:p>
+            <a:r>
+              <a:t>站不住：其余单seed、900步、50条评估，小于10点一律当噪声，包括我自己的h=1 vs h=3。</a:t>
+            </a:r>
+          </a:p>
+          <a:p>
+            <a:r>
+              <a:t>也没做Dreamer vs LeWM正面对比——目标函数和评估指标不共享，硬凑需要我没搭的共同任务定义。</a:t>
+            </a:r>
+          </a:p>
+          <a:p>
+            <a:r>
+              <a:t>【停】下一步：先补seed；horizon扫远；最想做的是把死维度数做成训练期实时监控——几秒就能算，能抓到loss藏起来的塌缩。</a:t>
+            </a:r>
+          </a:p>
+        </p:txBody>
+      </p:sp>
+      <p:sp>
+        <p:nvSpPr>
+          <p:cNvPr id="4" name="Slide Number Placeholder 3"/>
+          <p:cNvSpPr>
+            <a:spLocks noGrp="1"/>
+          </p:cNvSpPr>
+          <p:nvPr>
+            <p:ph type="sldNum" idx="5" sz="quarter"/>
+          </p:nvPr>
+        </p:nvSpPr>
+        <p:spPr/>
+      </p:sp>
+    </p:spTree>
+  </p:cSld>
+  <p:clrMapOvr>
+    <a:masterClrMapping/>
+  </p:clrMapOvr>
+</p:notes>
+</file>
+
+<file path=ppt/notesSlides/notesSlide2.xml><?xml version="1.0" encoding="utf-8"?>
+<p:notes xmlns:a="http://schemas.openxmlformats.org/drawingml/2006/main" xmlns:p="http://schemas.openxmlformats.org/presentationml/2006/main" xmlns:r="http://schemas.openxmlformats.org/officeDocument/2006/relationships">
+  <p:cSld>
+    <p:spTree>
+      <p:nvGrpSpPr>
+        <p:cNvPr id="1" name=""/>
+        <p:cNvGrpSpPr/>
+        <p:nvPr/>
+      </p:nvGrpSpPr>
+      <p:grpSpPr>
+        <a:xfrm>
+          <a:off x="0" y="0"/>
+          <a:ext cx="0" cy="0"/>
+          <a:chOff x="0" y="0"/>
+          <a:chExt cx="0" cy="0"/>
+        </a:xfrm>
+      </p:grpSpPr>
+      <p:sp>
+        <p:nvSpPr>
+          <p:cNvPr id="2" name="Slide Image Placeholder 1"/>
+          <p:cNvSpPr>
+            <a:spLocks noGrp="1"/>
+          </p:cNvSpPr>
+          <p:nvPr>
+            <p:ph type="sldImg" idx="2"/>
+          </p:nvPr>
+        </p:nvSpPr>
+        <p:spPr/>
+      </p:sp>
+      <p:sp>
+        <p:nvSpPr>
+          <p:cNvPr id="3" name="Notes Placeholder 2"/>
+          <p:cNvSpPr>
+            <a:spLocks noGrp="1"/>
+          </p:cNvSpPr>
+          <p:nvPr>
+            <p:ph type="body" idx="3" sz="quarter"/>
+          </p:nvPr>
+        </p:nvSpPr>
+        <p:spPr/>
+        <p:txBody>
+          <a:bodyPr/>
+          <a:lstStyle/>
+          <a:p>
+            <a:r>
+              <a:t>90秒。全场地基，值得花时间。</a:t>
+            </a:r>
+          </a:p>
+          <a:p>
+            <a:r>
+              <a:t>核心：世界模型=在脑子里建模拟器，先预演再行动，省真实交互。</a:t>
+            </a:r>
+          </a:p>
+          <a:p>
+            <a:r>
+              <a:t>两条路线：Dreamer要重建像素（浪费在无关细节）；JEPA不重建（但有塌缩风险）。</a:t>
+            </a:r>
+          </a:p>
+          <a:p>
+            <a:r>
+              <a:t>【必须埋伏笔】「如果目标只是预测下一个向量要准，有个作弊解——让encoder对任何输入都输出同一个常数，loss直接趋近0。模型赢了，任务输了。这叫表征塌缩。记住它，我最重要的实验就围绕它。」</a:t>
+            </a:r>
+          </a:p>
+          <a:p>
+            <a:r>
+              <a:t>这里省30秒，第10页要多花2分钟解释。</a:t>
+            </a:r>
+          </a:p>
+        </p:txBody>
+      </p:sp>
+      <p:sp>
+        <p:nvSpPr>
+          <p:cNvPr id="4" name="Slide Number Placeholder 3"/>
+          <p:cNvSpPr>
+            <a:spLocks noGrp="1"/>
+          </p:cNvSpPr>
+          <p:nvPr>
+            <p:ph type="sldNum" idx="5" sz="quarter"/>
+          </p:nvPr>
+        </p:nvSpPr>
+        <p:spPr/>
+      </p:sp>
+    </p:spTree>
+  </p:cSld>
+  <p:clrMapOvr>
+    <a:masterClrMapping/>
+  </p:clrMapOvr>
+</p:notes>
+</file>
+
+<file path=ppt/notesSlides/notesSlide3.xml><?xml version="1.0" encoding="utf-8"?>
+<p:notes xmlns:a="http://schemas.openxmlformats.org/drawingml/2006/main" xmlns:p="http://schemas.openxmlformats.org/presentationml/2006/main" xmlns:r="http://schemas.openxmlformats.org/officeDocument/2006/relationships">
+  <p:cSld>
+    <p:spTree>
+      <p:nvGrpSpPr>
+        <p:cNvPr id="1" name=""/>
+        <p:cNvGrpSpPr/>
+        <p:nvPr/>
+      </p:nvGrpSpPr>
+      <p:grpSpPr>
+        <a:xfrm>
+          <a:off x="0" y="0"/>
+          <a:ext cx="0" cy="0"/>
+          <a:chOff x="0" y="0"/>
+          <a:chExt cx="0" cy="0"/>
+        </a:xfrm>
+      </p:grpSpPr>
+      <p:sp>
+        <p:nvSpPr>
+          <p:cNvPr id="2" name="Slide Image Placeholder 1"/>
+          <p:cNvSpPr>
+            <a:spLocks noGrp="1"/>
+          </p:cNvSpPr>
+          <p:nvPr>
+            <p:ph type="sldImg" idx="2"/>
+          </p:nvPr>
+        </p:nvSpPr>
+        <p:spPr/>
+      </p:sp>
+      <p:sp>
+        <p:nvSpPr>
+          <p:cNvPr id="3" name="Notes Placeholder 2"/>
+          <p:cNvSpPr>
+            <a:spLocks noGrp="1"/>
+          </p:cNvSpPr>
+          <p:nvPr>
+            <p:ph type="body" idx="3" sz="quarter"/>
+          </p:nvPr>
+        </p:nvSpPr>
+        <p:spPr/>
+        <p:txBody>
+          <a:bodyPr/>
+          <a:lstStyle/>
+          <a:p>
+            <a:r>
+              <a:t>20秒。这页只是路标。三件事：手写Dreamer、跑通LeWM、三组受控实验。翻页。</a:t>
+            </a:r>
+          </a:p>
+        </p:txBody>
+      </p:sp>
+      <p:sp>
+        <p:nvSpPr>
+          <p:cNvPr id="4" name="Slide Number Placeholder 3"/>
+          <p:cNvSpPr>
+            <a:spLocks noGrp="1"/>
+          </p:cNvSpPr>
+          <p:nvPr>
+            <p:ph type="sldNum" idx="5" sz="quarter"/>
+          </p:nvPr>
+        </p:nvSpPr>
+        <p:spPr/>
+      </p:sp>
+    </p:spTree>
+  </p:cSld>
+  <p:clrMapOvr>
+    <a:masterClrMapping/>
+  </p:clrMapOvr>
+</p:notes>
+</file>
+
+<file path=ppt/notesSlides/notesSlide4.xml><?xml version="1.0" encoding="utf-8"?>
+<p:notes xmlns:a="http://schemas.openxmlformats.org/drawingml/2006/main" xmlns:p="http://schemas.openxmlformats.org/presentationml/2006/main" xmlns:r="http://schemas.openxmlformats.org/officeDocument/2006/relationships">
+  <p:cSld>
+    <p:spTree>
+      <p:nvGrpSpPr>
+        <p:cNvPr id="1" name=""/>
+        <p:cNvGrpSpPr/>
+        <p:nvPr/>
+      </p:nvGrpSpPr>
+      <p:grpSpPr>
+        <a:xfrm>
+          <a:off x="0" y="0"/>
+          <a:ext cx="0" cy="0"/>
+          <a:chOff x="0" y="0"/>
+          <a:chExt cx="0" cy="0"/>
+        </a:xfrm>
+      </p:grpSpPr>
+      <p:sp>
+        <p:nvSpPr>
+          <p:cNvPr id="2" name="Slide Image Placeholder 1"/>
+          <p:cNvSpPr>
+            <a:spLocks noGrp="1"/>
+          </p:cNvSpPr>
+          <p:nvPr>
+            <p:ph type="sldImg" idx="2"/>
+          </p:nvPr>
+        </p:nvSpPr>
+        <p:spPr/>
+      </p:sp>
+      <p:sp>
+        <p:nvSpPr>
+          <p:cNvPr id="3" name="Notes Placeholder 2"/>
+          <p:cNvSpPr>
+            <a:spLocks noGrp="1"/>
+          </p:cNvSpPr>
+          <p:nvPr>
+            <p:ph type="body" idx="3" sz="quarter"/>
+          </p:nvPr>
+        </p:nvSpPr>
+        <p:spPr/>
+        <p:txBody>
+          <a:bodyPr/>
+          <a:lstStyle/>
+          <a:p>
+            <a:r>
+              <a:t>40秒。</a:t>
+            </a:r>
+          </a:p>
+          <a:p>
+            <a:r>
+              <a:t>「没跑现成仓库，从零写的，670行单文件——没办法躲在别人的train.py后面。」</a:t>
+            </a:r>
+          </a:p>
+          <a:p>
+            <a:r>
+              <a:t>【主动降低本页重要性】「这个结果本身不重要，是教科书预期结果。下一页那个才是我想给你看的。」</a:t>
+            </a:r>
+          </a:p>
+        </p:txBody>
+      </p:sp>
+      <p:sp>
+        <p:nvSpPr>
+          <p:cNvPr id="4" name="Slide Number Placeholder 3"/>
+          <p:cNvSpPr>
+            <a:spLocks noGrp="1"/>
+          </p:cNvSpPr>
+          <p:nvPr>
+            <p:ph type="sldNum" idx="5" sz="quarter"/>
+          </p:nvPr>
+        </p:nvSpPr>
+        <p:spPr/>
+      </p:sp>
+    </p:spTree>
+  </p:cSld>
+  <p:clrMapOvr>
+    <a:masterClrMapping/>
+  </p:clrMapOvr>
+</p:notes>
+</file>
+
+<file path=ppt/notesSlides/notesSlide5.xml><?xml version="1.0" encoding="utf-8"?>
+<p:notes xmlns:a="http://schemas.openxmlformats.org/drawingml/2006/main" xmlns:p="http://schemas.openxmlformats.org/presentationml/2006/main" xmlns:r="http://schemas.openxmlformats.org/officeDocument/2006/relationships">
+  <p:cSld>
+    <p:spTree>
+      <p:nvGrpSpPr>
+        <p:cNvPr id="1" name=""/>
+        <p:cNvGrpSpPr/>
+        <p:nvPr/>
+      </p:nvGrpSpPr>
+      <p:grpSpPr>
+        <a:xfrm>
+          <a:off x="0" y="0"/>
+          <a:ext cx="0" cy="0"/>
+          <a:chOff x="0" y="0"/>
+          <a:chExt cx="0" cy="0"/>
+        </a:xfrm>
+      </p:grpSpPr>
+      <p:sp>
+        <p:nvSpPr>
+          <p:cNvPr id="2" name="Slide Image Placeholder 1"/>
+          <p:cNvSpPr>
+            <a:spLocks noGrp="1"/>
+          </p:cNvSpPr>
+          <p:nvPr>
+            <p:ph type="sldImg" idx="2"/>
+          </p:nvPr>
+        </p:nvSpPr>
+        <p:spPr/>
+      </p:sp>
+      <p:sp>
+        <p:nvSpPr>
+          <p:cNvPr id="3" name="Notes Placeholder 2"/>
+          <p:cNvSpPr>
+            <a:spLocks noGrp="1"/>
+          </p:cNvSpPr>
+          <p:nvPr>
+            <p:ph type="body" idx="3" sz="quarter"/>
+          </p:nvPr>
+        </p:nvSpPr>
+        <p:spPr/>
+        <p:txBody>
+          <a:bodyPr/>
+          <a:lstStyle/>
+          <a:p>
+            <a:r>
+              <a:t>50秒。Dreamer部分唯一值得细讲的一页。</a:t>
+            </a:r>
+          </a:p>
+          <a:p>
+            <a:r>
+              <a:t>「策略从头到尾没见过真实状态，完全在想象里训练。那万一模型编了个奖励很高但不存在的世界呢？」</a:t>
+            </a:r>
+          </a:p>
+          <a:p>
+            <a:r>
+              <a:t>左图KL稳在0.8，free bits=1.0在起作用，没塌缩也没爆炸。</a:t>
+            </a:r>
+          </a:p>
+          <a:p>
+            <a:r>
+              <a:t>右图关键：想象内部算的λ-return从0涨到70+，和真实回报同步。</a:t>
+            </a:r>
+          </a:p>
+          <a:p>
+            <a:r>
+              <a:t>「如果它自己涨得高但真实表现不动，就是自我欺骗。这图证明没发生。」</a:t>
+            </a:r>
+          </a:p>
+          <a:p>
+            <a:r>
+              <a:t>可能追问 free bits：给KL设下限，防止随机变量被压成不携带信息，同VAE后验塌缩。</a:t>
+            </a:r>
+          </a:p>
+        </p:txBody>
+      </p:sp>
+      <p:sp>
+        <p:nvSpPr>
+          <p:cNvPr id="4" name="Slide Number Placeholder 3"/>
+          <p:cNvSpPr>
+            <a:spLocks noGrp="1"/>
+          </p:cNvSpPr>
+          <p:nvPr>
+            <p:ph type="sldNum" idx="5" sz="quarter"/>
+          </p:nvPr>
+        </p:nvSpPr>
+        <p:spPr/>
+      </p:sp>
+    </p:spTree>
+  </p:cSld>
+  <p:clrMapOvr>
+    <a:masterClrMapping/>
+  </p:clrMapOvr>
+</p:notes>
+</file>
+
+<file path=ppt/notesSlides/notesSlide6.xml><?xml version="1.0" encoding="utf-8"?>
+<p:notes xmlns:a="http://schemas.openxmlformats.org/drawingml/2006/main" xmlns:p="http://schemas.openxmlformats.org/presentationml/2006/main" xmlns:r="http://schemas.openxmlformats.org/officeDocument/2006/relationships">
+  <p:cSld>
+    <p:spTree>
+      <p:nvGrpSpPr>
+        <p:cNvPr id="1" name=""/>
+        <p:cNvGrpSpPr/>
+        <p:nvPr/>
+      </p:nvGrpSpPr>
+      <p:grpSpPr>
+        <a:xfrm>
+          <a:off x="0" y="0"/>
+          <a:ext cx="0" cy="0"/>
+          <a:chOff x="0" y="0"/>
+          <a:chExt cx="0" cy="0"/>
+        </a:xfrm>
+      </p:grpSpPr>
+      <p:sp>
+        <p:nvSpPr>
+          <p:cNvPr id="2" name="Slide Image Placeholder 1"/>
+          <p:cNvSpPr>
+            <a:spLocks noGrp="1"/>
+          </p:cNvSpPr>
+          <p:nvPr>
+            <p:ph type="sldImg" idx="2"/>
+          </p:nvPr>
+        </p:nvSpPr>
+        <p:spPr/>
+      </p:sp>
+      <p:sp>
+        <p:nvSpPr>
+          <p:cNvPr id="3" name="Notes Placeholder 2"/>
+          <p:cNvSpPr>
+            <a:spLocks noGrp="1"/>
+          </p:cNvSpPr>
+          <p:nvPr>
+            <p:ph type="body" idx="3" sz="quarter"/>
+          </p:nvPr>
+        </p:nvSpPr>
+        <p:spPr/>
+        <p:txBody>
+          <a:bodyPr/>
+          <a:lstStyle/>
+          <a:p>
+            <a:r>
+              <a:t>40秒。</a:t>
+            </a:r>
+          </a:p>
+          <a:p>
+            <a:r>
+              <a:t>86%是后面所有数字的参照基准。</a:t>
+            </a:r>
+          </a:p>
+          <a:p>
+            <a:r>
+              <a:t>重点讲右边那个「4小时」：不是花在科研上，是装环境。四处断裂——缺swig、datasets五年前版本、transformers 5.x重命名ViT权重导致checkpoint加载不了、HDF5被静默import失败关掉。</a:t>
+            </a:r>
+          </a:p>
+          <a:p>
+            <a:r>
+              <a:t>「复现类文章通常略过这段，但这恰恰是真正卡住人的地方。」</a:t>
+            </a:r>
+          </a:p>
+        </p:txBody>
+      </p:sp>
+      <p:sp>
+        <p:nvSpPr>
+          <p:cNvPr id="4" name="Slide Number Placeholder 3"/>
+          <p:cNvSpPr>
+            <a:spLocks noGrp="1"/>
+          </p:cNvSpPr>
+          <p:nvPr>
+            <p:ph type="sldNum" idx="5" sz="quarter"/>
+          </p:nvPr>
+        </p:nvSpPr>
+        <p:spPr/>
+      </p:sp>
+    </p:spTree>
+  </p:cSld>
+  <p:clrMapOvr>
+    <a:masterClrMapping/>
+  </p:clrMapOvr>
+</p:notes>
+</file>
+
+<file path=ppt/notesSlides/notesSlide7.xml><?xml version="1.0" encoding="utf-8"?>
+<p:notes xmlns:a="http://schemas.openxmlformats.org/drawingml/2006/main" xmlns:p="http://schemas.openxmlformats.org/presentationml/2006/main" xmlns:r="http://schemas.openxmlformats.org/officeDocument/2006/relationships">
+  <p:cSld>
+    <p:spTree>
+      <p:nvGrpSpPr>
+        <p:cNvPr id="1" name=""/>
+        <p:cNvGrpSpPr/>
+        <p:nvPr/>
+      </p:nvGrpSpPr>
+      <p:grpSpPr>
+        <a:xfrm>
+          <a:off x="0" y="0"/>
+          <a:ext cx="0" cy="0"/>
+          <a:chOff x="0" y="0"/>
+          <a:chExt cx="0" cy="0"/>
+        </a:xfrm>
+      </p:grpSpPr>
+      <p:sp>
+        <p:nvSpPr>
+          <p:cNvPr id="2" name="Slide Image Placeholder 1"/>
+          <p:cNvSpPr>
+            <a:spLocks noGrp="1"/>
+          </p:cNvSpPr>
+          <p:nvPr>
+            <p:ph type="sldImg" idx="2"/>
+          </p:nvPr>
+        </p:nvSpPr>
+        <p:spPr/>
+      </p:sp>
+      <p:sp>
+        <p:nvSpPr>
+          <p:cNvPr id="3" name="Notes Placeholder 2"/>
+          <p:cNvSpPr>
+            <a:spLocks noGrp="1"/>
+          </p:cNvSpPr>
+          <p:nvPr>
+            <p:ph type="body" idx="3" sz="quarter"/>
+          </p:nvPr>
+        </p:nvSpPr>
+        <p:spPr/>
+        <p:txBody>
+          <a:bodyPr/>
+          <a:lstStyle/>
+          <a:p>
+            <a:r>
+              <a:t>15秒。必须停下来，让对方意识到叙事切换。</a:t>
+            </a:r>
+          </a:p>
+          <a:p>
+            <a:r>
+              <a:t>「以上都是复现别人的。【停】接下来是我自己设计的。」</a:t>
+            </a:r>
+          </a:p>
+          <a:p>
+            <a:r>
+              <a:t>【别省这句】「三组实验共用同一份数据、同一个encoder、同一个优化器、同样900步、同样50条episode——每组只动一个变量。」</a:t>
+            </a:r>
+          </a:p>
+        </p:txBody>
+      </p:sp>
+      <p:sp>
+        <p:nvSpPr>
+          <p:cNvPr id="4" name="Slide Number Placeholder 3"/>
+          <p:cNvSpPr>
+            <a:spLocks noGrp="1"/>
+          </p:cNvSpPr>
+          <p:nvPr>
+            <p:ph type="sldNum" idx="5" sz="quarter"/>
+          </p:nvPr>
+        </p:nvSpPr>
+        <p:spPr/>
+      </p:sp>
+    </p:spTree>
+  </p:cSld>
+  <p:clrMapOvr>
+    <a:masterClrMapping/>
+  </p:clrMapOvr>
+</p:notes>
+</file>
+
+<file path=ppt/notesSlides/notesSlide8.xml><?xml version="1.0" encoding="utf-8"?>
+<p:notes xmlns:a="http://schemas.openxmlformats.org/drawingml/2006/main" xmlns:p="http://schemas.openxmlformats.org/presentationml/2006/main" xmlns:r="http://schemas.openxmlformats.org/officeDocument/2006/relationships">
+  <p:cSld>
+    <p:spTree>
+      <p:nvGrpSpPr>
+        <p:cNvPr id="1" name=""/>
+        <p:cNvGrpSpPr/>
+        <p:nvPr/>
+      </p:nvGrpSpPr>
+      <p:grpSpPr>
+        <a:xfrm>
+          <a:off x="0" y="0"/>
+          <a:ext cx="0" cy="0"/>
+          <a:chOff x="0" y="0"/>
+          <a:chExt cx="0" cy="0"/>
+        </a:xfrm>
+      </p:grpSpPr>
+      <p:sp>
+        <p:nvSpPr>
+          <p:cNvPr id="2" name="Slide Image Placeholder 1"/>
+          <p:cNvSpPr>
+            <a:spLocks noGrp="1"/>
+          </p:cNvSpPr>
+          <p:nvPr>
+            <p:ph type="sldImg" idx="2"/>
+          </p:nvPr>
+        </p:nvSpPr>
+        <p:spPr/>
+      </p:sp>
+      <p:sp>
+        <p:nvSpPr>
+          <p:cNvPr id="3" name="Notes Placeholder 2"/>
+          <p:cNvSpPr>
+            <a:spLocks noGrp="1"/>
+          </p:cNvSpPr>
+          <p:nvPr>
+            <p:ph type="body" idx="3" sz="quarter"/>
+          </p:nvPr>
+        </p:nvSpPr>
+        <p:spPr/>
+        <p:txBody>
+          <a:bodyPr/>
+          <a:lstStyle/>
+          <a:p>
+            <a:r>
+              <a:t>60秒。</a:t>
+            </a:r>
+          </a:p>
+          <a:p>
+            <a:r>
+              <a:t>扫history_size 1/3/5，3是论文默认。左图loss单调下降（符合直觉），右图成功率没跟上。</a:t>
+            </a:r>
+          </a:p>
+          <a:p>
+            <a:r>
+              <a:t>h=1→h=3：loss改善，成功率反而掉2个点。</a:t>
+            </a:r>
+          </a:p>
+          <a:p>
+            <a:r>
+              <a:t>【最能体现统计素养的一句，主动说】「这两个点的差距我认为就是噪声。50条episode、p≈0.5，二项标准误约7个百分点。我能下的结论只有h=5更好。」</a:t>
+            </a:r>
+          </a:p>
+          <a:p>
+            <a:r>
+              <a:t>「但正是这个错位让我起疑，才有后面两组实验。」</a:t>
+            </a:r>
+          </a:p>
+          <a:p>
+            <a:r>
+              <a:t>追问「为什么不多跑seed」：时间限制，这是最明显短板，README里也这么写的，给我一周补seed是第一优先。</a:t>
+            </a:r>
+          </a:p>
+        </p:txBody>
+      </p:sp>
+      <p:sp>
+        <p:nvSpPr>
+          <p:cNvPr id="4" name="Slide Number Placeholder 3"/>
+          <p:cNvSpPr>
+            <a:spLocks noGrp="1"/>
+          </p:cNvSpPr>
+          <p:nvPr>
+            <p:ph type="sldNum" idx="5" sz="quarter"/>
+          </p:nvPr>
+        </p:nvSpPr>
+        <p:spPr/>
+      </p:sp>
+    </p:spTree>
+  </p:cSld>
+  <p:clrMapOvr>
+    <a:masterClrMapping/>
+  </p:clrMapOvr>
+</p:notes>
+</file>
+
+<file path=ppt/notesSlides/notesSlide9.xml><?xml version="1.0" encoding="utf-8"?>
+<p:notes xmlns:a="http://schemas.openxmlformats.org/drawingml/2006/main" xmlns:p="http://schemas.openxmlformats.org/presentationml/2006/main" xmlns:r="http://schemas.openxmlformats.org/officeDocument/2006/relationships">
+  <p:cSld>
+    <p:spTree>
+      <p:nvGrpSpPr>
+        <p:cNvPr id="1" name=""/>
+        <p:cNvGrpSpPr/>
+        <p:nvPr/>
+      </p:nvGrpSpPr>
+      <p:grpSpPr>
+        <a:xfrm>
+          <a:off x="0" y="0"/>
+          <a:ext cx="0" cy="0"/>
+          <a:chOff x="0" y="0"/>
+          <a:chExt cx="0" cy="0"/>
+        </a:xfrm>
+      </p:grpSpPr>
+      <p:sp>
+        <p:nvSpPr>
+          <p:cNvPr id="2" name="Slide Image Placeholder 1"/>
+          <p:cNvSpPr>
+            <a:spLocks noGrp="1"/>
+          </p:cNvSpPr>
+          <p:nvPr>
+            <p:ph type="sldImg" idx="2"/>
+          </p:nvPr>
+        </p:nvSpPr>
+        <p:spPr/>
+      </p:sp>
+      <p:sp>
+        <p:nvSpPr>
+          <p:cNvPr id="3" name="Notes Placeholder 2"/>
+          <p:cNvSpPr>
+            <a:spLocks noGrp="1"/>
+          </p:cNvSpPr>
+          <p:nvPr>
+            <p:ph type="body" idx="3" sz="quarter"/>
+          </p:nvPr>
+        </p:nvSpPr>
+        <p:spPr/>
+        <p:txBody>
+          <a:bodyPr/>
+          <a:lstStyle/>
+          <a:p>
+            <a:r>
+              <a:t>60秒。</a:t>
+            </a:r>
+          </a:p>
+          <a:p>
+            <a:r>
+              <a:t>PLDM构造函数签名和接口与LeWM一致，只改配置里两个_target_路径就能塞进同一循环和规划器。</a:t>
+            </a:r>
+          </a:p>
+          <a:p>
+            <a:r>
+              <a:t>结果：PLDM预测更差(0.298 vs 0.266)，规划反而高14个点(66% vs 52%)。</a:t>
+            </a:r>
+          </a:p>
+          <a:p>
+            <a:r>
+              <a:t>查过不是塌缩造成的——两者embedding都健康，没死维度。</a:t>
+            </a:r>
+          </a:p>
+          <a:p>
+            <a:r>
+              <a:t>【两个caveat必须主动说】(1)单seed，14点对7pp标准误，是「值得注意」不是「已证实」；(2)训的是PLDM架构+LeWM训练配方，不是PLDM原方法，所以不能当作对PLDM的复现引用。</a:t>
+            </a:r>
+          </a:p>
+        </p:txBody>
+      </p:sp>
+      <p:sp>
+        <p:nvSpPr>
+          <p:cNvPr id="4" name="Slide Number Placeholder 3"/>
+          <p:cNvSpPr>
+            <a:spLocks noGrp="1"/>
+          </p:cNvSpPr>
+          <p:nvPr>
+            <p:ph type="sldNum" idx="5" sz="quarter"/>
+          </p:nvPr>
+        </p:nvSpPr>
+        <p:spPr/>
+      </p:sp>
+    </p:spTree>
+  </p:cSld>
+  <p:clrMapOvr>
+    <a:masterClrMapping/>
+  </p:clrMapOvr>
+</p:notes>
 </file>
 
 <file path=ppt/slideLayouts/slideLayout1.xml><?xml version="1.0" encoding="utf-8"?>
@@ -4793,7 +6433,7 @@
                 </a:solidFill>
                 <a:latin typeface="Consolas"/>
               </a:rPr>
-              <a:t>961</a:t>
+              <a:t>970</a:t>
             </a:r>
           </a:p>
           <a:p>
@@ -4812,7 +6452,7 @@
                 </a:solidFill>
                 <a:latin typeface="微软雅黑"/>
               </a:rPr>
-              <a:t>535k 步时的评估回报（满分约 1000）</a:t>
+              <a:t>545k 步时的评估回报（满分约 1000）</a:t>
             </a:r>
           </a:p>
         </p:txBody>
@@ -9205,4 +10845,324 @@
   </a:objectDefaults>
   <a:extraClrSchemeLst/>
 </a:theme>
+</file>
+
+<file path=ppt/theme/theme2.xml><?xml version="1.0" encoding="utf-8"?>
+<a:theme xmlns:a="http://schemas.openxmlformats.org/drawingml/2006/main" name="Office Theme">
+  <a:themeElements>
+    <a:clrScheme name="Office">
+      <a:dk1>
+        <a:sysClr val="windowText" lastClr="000000"/>
+      </a:dk1>
+      <a:lt1>
+        <a:sysClr val="window" lastClr="FFFFFF"/>
+      </a:lt1>
+      <a:dk2>
+        <a:srgbClr val="1F497D"/>
+      </a:dk2>
+      <a:lt2>
+        <a:srgbClr val="EEECE1"/>
+      </a:lt2>
+      <a:accent1>
+        <a:srgbClr val="4F81BD"/>
+      </a:accent1>
+      <a:accent2>
+        <a:srgbClr val="C0504D"/>
+      </a:accent2>
+      <a:accent3>
+        <a:srgbClr val="9BBB59"/>
+      </a:accent3>
+      <a:accent4>
+        <a:srgbClr val="8064A2"/>
+      </a:accent4>
+      <a:accent5>
+        <a:srgbClr val="4BACC6"/>
+      </a:accent5>
+      <a:accent6>
+        <a:srgbClr val="F79646"/>
+      </a:accent6>
+      <a:hlink>
+        <a:srgbClr val="0000FF"/>
+      </a:hlink>
+      <a:folHlink>
+        <a:srgbClr val="800080"/>
+      </a:folHlink>
+    </a:clrScheme>
+    <a:fontScheme name="Office">
+      <a:majorFont>
+        <a:latin typeface="Calibri"/>
+        <a:ea typeface=""/>
+        <a:cs typeface=""/>
+        <a:font script="Jpan" typeface="ＭＳ Ｐゴシック"/>
+        <a:font script="Hang" typeface="맑은 고딕"/>
+        <a:font script="Hans" typeface="宋体"/>
+        <a:font script="Hant" typeface="新細明體"/>
+        <a:font script="Arab" typeface="Times New Roman"/>
+        <a:font script="Hebr" typeface="Times New Roman"/>
+        <a:font script="Thai" typeface="Angsana New"/>
+        <a:font script="Ethi" typeface="Nyala"/>
+        <a:font script="Beng" typeface="Vrinda"/>
+        <a:font script="Gujr" typeface="Shruti"/>
+        <a:font script="Khmr" typeface="MoolBoran"/>
+        <a:font script="Knda" typeface="Tunga"/>
+        <a:font script="Guru" typeface="Raavi"/>
+        <a:font script="Cans" typeface="Euphemia"/>
+        <a:font script="Cher" typeface="Plantagenet Cherokee"/>
+        <a:font script="Yiii" typeface="Microsoft Yi Baiti"/>
+        <a:font script="Tibt" typeface="Microsoft Himalaya"/>
+        <a:font script="Thaa" typeface="MV Boli"/>
+        <a:font script="Deva" typeface="Mangal"/>
+        <a:font script="Telu" typeface="Gautami"/>
+        <a:font script="Taml" typeface="Latha"/>
+        <a:font script="Syrc" typeface="Estrangelo Edessa"/>
+        <a:font script="Orya" typeface="Kalinga"/>
+        <a:font script="Mlym" typeface="Kartika"/>
+        <a:font script="Laoo" typeface="DokChampa"/>
+        <a:font script="Sinh" typeface="Iskoola Pota"/>
+        <a:font script="Mong" typeface="Mongolian Baiti"/>
+        <a:font script="Viet" typeface="Times New Roman"/>
+        <a:font script="Uigh" typeface="Microsoft Uighur"/>
+        <a:font script="Geor" typeface="Sylfaen"/>
+      </a:majorFont>
+      <a:minorFont>
+        <a:latin typeface="Calibri"/>
+        <a:ea typeface=""/>
+        <a:cs typeface=""/>
+        <a:font script="Jpan" typeface="ＭＳ Ｐゴシック"/>
+        <a:font script="Hang" typeface="맑은 고딕"/>
+        <a:font script="Hans" typeface="宋体"/>
+        <a:font script="Hant" typeface="新細明體"/>
+        <a:font script="Arab" typeface="Arial"/>
+        <a:font script="Hebr" typeface="Arial"/>
+        <a:font script="Thai" typeface="Cordia New"/>
+        <a:font script="Ethi" typeface="Nyala"/>
+        <a:font script="Beng" typeface="Vrinda"/>
+        <a:font script="Gujr" typeface="Shruti"/>
+        <a:font script="Khmr" typeface="DaunPenh"/>
+        <a:font script="Knda" typeface="Tunga"/>
+        <a:font script="Guru" typeface="Raavi"/>
+        <a:font script="Cans" typeface="Euphemia"/>
+        <a:font script="Cher" typeface="Plantagenet Cherokee"/>
+        <a:font script="Yiii" typeface="Microsoft Yi Baiti"/>
+        <a:font script="Tibt" typeface="Microsoft Himalaya"/>
+        <a:font script="Thaa" typeface="MV Boli"/>
+        <a:font script="Deva" typeface="Mangal"/>
+        <a:font script="Telu" typeface="Gautami"/>
+        <a:font script="Taml" typeface="Latha"/>
+        <a:font script="Syrc" typeface="Estrangelo Edessa"/>
+        <a:font script="Orya" typeface="Kalinga"/>
+        <a:font script="Mlym" typeface="Kartika"/>
+        <a:font script="Laoo" typeface="DokChampa"/>
+        <a:font script="Sinh" typeface="Iskoola Pota"/>
+        <a:font script="Mong" typeface="Mongolian Baiti"/>
+        <a:font script="Viet" typeface="Arial"/>
+        <a:font script="Uigh" typeface="Microsoft Uighur"/>
+        <a:font script="Geor" typeface="Sylfaen"/>
+      </a:minorFont>
+    </a:fontScheme>
+    <a:fmtScheme name="Office">
+      <a:fillStyleLst>
+        <a:solidFill>
+          <a:schemeClr val="phClr"/>
+        </a:solidFill>
+        <a:gradFill rotWithShape="1">
+          <a:gsLst>
+            <a:gs pos="0">
+              <a:schemeClr val="phClr">
+                <a:tint val="50000"/>
+                <a:satMod val="300000"/>
+              </a:schemeClr>
+            </a:gs>
+            <a:gs pos="35000">
+              <a:schemeClr val="phClr">
+                <a:tint val="37000"/>
+                <a:satMod val="300000"/>
+              </a:schemeClr>
+            </a:gs>
+            <a:gs pos="100000">
+              <a:schemeClr val="phClr">
+                <a:tint val="15000"/>
+                <a:satMod val="350000"/>
+              </a:schemeClr>
+            </a:gs>
+          </a:gsLst>
+          <a:lin ang="16200000" scaled="1"/>
+        </a:gradFill>
+        <a:gradFill rotWithShape="1">
+          <a:gsLst>
+            <a:gs pos="0">
+              <a:schemeClr val="phClr">
+                <a:tint val="100000"/>
+                <a:shade val="100000"/>
+                <a:satMod val="130000"/>
+              </a:schemeClr>
+            </a:gs>
+            <a:gs pos="100000">
+              <a:schemeClr val="phClr">
+                <a:tint val="50000"/>
+                <a:shade val="100000"/>
+                <a:satMod val="350000"/>
+              </a:schemeClr>
+            </a:gs>
+          </a:gsLst>
+          <a:lin ang="16200000" scaled="0"/>
+        </a:gradFill>
+      </a:fillStyleLst>
+      <a:lnStyleLst>
+        <a:ln w="9525" cap="flat" cmpd="sng" algn="ctr">
+          <a:solidFill>
+            <a:schemeClr val="phClr">
+              <a:shade val="95000"/>
+              <a:satMod val="105000"/>
+            </a:schemeClr>
+          </a:solidFill>
+          <a:prstDash val="solid"/>
+        </a:ln>
+        <a:ln w="25400" cap="flat" cmpd="sng" algn="ctr">
+          <a:solidFill>
+            <a:schemeClr val="phClr"/>
+          </a:solidFill>
+          <a:prstDash val="solid"/>
+        </a:ln>
+        <a:ln w="38100" cap="flat" cmpd="sng" algn="ctr">
+          <a:solidFill>
+            <a:schemeClr val="phClr"/>
+          </a:solidFill>
+          <a:prstDash val="solid"/>
+        </a:ln>
+      </a:lnStyleLst>
+      <a:effectStyleLst>
+        <a:effectStyle>
+          <a:effectLst>
+            <a:outerShdw blurRad="40000" dist="20000" dir="5400000" rotWithShape="0">
+              <a:srgbClr val="000000">
+                <a:alpha val="38000"/>
+              </a:srgbClr>
+            </a:outerShdw>
+          </a:effectLst>
+        </a:effectStyle>
+        <a:effectStyle>
+          <a:effectLst>
+            <a:outerShdw blurRad="40000" dist="23000" dir="5400000" rotWithShape="0">
+              <a:srgbClr val="000000">
+                <a:alpha val="35000"/>
+              </a:srgbClr>
+            </a:outerShdw>
+          </a:effectLst>
+        </a:effectStyle>
+        <a:effectStyle>
+          <a:effectLst>
+            <a:outerShdw blurRad="40000" dist="23000" dir="5400000" rotWithShape="0">
+              <a:srgbClr val="000000">
+                <a:alpha val="35000"/>
+              </a:srgbClr>
+            </a:outerShdw>
+          </a:effectLst>
+          <a:scene3d>
+            <a:camera prst="orthographicFront">
+              <a:rot lat="0" lon="0" rev="0"/>
+            </a:camera>
+            <a:lightRig rig="threePt" dir="t">
+              <a:rot lat="0" lon="0" rev="1200000"/>
+            </a:lightRig>
+          </a:scene3d>
+          <a:sp3d>
+            <a:bevelT w="63500" h="25400"/>
+          </a:sp3d>
+        </a:effectStyle>
+      </a:effectStyleLst>
+      <a:bgFillStyleLst>
+        <a:solidFill>
+          <a:schemeClr val="phClr"/>
+        </a:solidFill>
+        <a:gradFill rotWithShape="1">
+          <a:gsLst>
+            <a:gs pos="0">
+              <a:schemeClr val="phClr">
+                <a:tint val="40000"/>
+                <a:satMod val="350000"/>
+              </a:schemeClr>
+            </a:gs>
+            <a:gs pos="40000">
+              <a:schemeClr val="phClr">
+                <a:tint val="45000"/>
+                <a:shade val="99000"/>
+                <a:satMod val="350000"/>
+              </a:schemeClr>
+            </a:gs>
+            <a:gs pos="100000">
+              <a:schemeClr val="phClr">
+                <a:shade val="20000"/>
+                <a:satMod val="255000"/>
+              </a:schemeClr>
+            </a:gs>
+          </a:gsLst>
+          <a:path path="circle">
+            <a:fillToRect l="50000" t="-80000" r="50000" b="180000"/>
+          </a:path>
+        </a:gradFill>
+        <a:gradFill rotWithShape="1">
+          <a:gsLst>
+            <a:gs pos="0">
+              <a:schemeClr val="phClr">
+                <a:tint val="80000"/>
+                <a:satMod val="300000"/>
+              </a:schemeClr>
+            </a:gs>
+            <a:gs pos="100000">
+              <a:schemeClr val="phClr">
+                <a:shade val="30000"/>
+                <a:satMod val="200000"/>
+              </a:schemeClr>
+            </a:gs>
+          </a:gsLst>
+          <a:path path="circle">
+            <a:fillToRect l="50000" t="50000" r="50000" b="50000"/>
+          </a:path>
+        </a:gradFill>
+      </a:bgFillStyleLst>
+    </a:fmtScheme>
+  </a:themeElements>
+  <a:objectDefaults>
+    <a:spDef>
+      <a:spPr/>
+      <a:bodyPr/>
+      <a:lstStyle/>
+      <a:style>
+        <a:lnRef idx="1">
+          <a:schemeClr val="accent1"/>
+        </a:lnRef>
+        <a:fillRef idx="3">
+          <a:schemeClr val="accent1"/>
+        </a:fillRef>
+        <a:effectRef idx="2">
+          <a:schemeClr val="accent1"/>
+        </a:effectRef>
+        <a:fontRef idx="minor">
+          <a:schemeClr val="lt1"/>
+        </a:fontRef>
+      </a:style>
+    </a:spDef>
+    <a:lnDef>
+      <a:spPr/>
+      <a:bodyPr/>
+      <a:lstStyle/>
+      <a:style>
+        <a:lnRef idx="2">
+          <a:schemeClr val="accent1"/>
+        </a:lnRef>
+        <a:fillRef idx="0">
+          <a:schemeClr val="accent1"/>
+        </a:fillRef>
+        <a:effectRef idx="1">
+          <a:schemeClr val="accent1"/>
+        </a:effectRef>
+        <a:fontRef idx="minor">
+          <a:schemeClr val="tx1"/>
+        </a:fontRef>
+      </a:style>
+    </a:lnDef>
+  </a:objectDefaults>
+  <a:extraClrSchemeLst/>
+</a:theme>
 </file>
</xml_diff>

<commit_message>
Retract the experiment 2 result
The two 'architectures' are one architecture. pldm/module.py and
lewm/module.py in stable_worldmodel are byte-identical; the top-level files
differ only in rollout inference details. train.py never seeds Manager either,
so the two runs started from different weights -- the sanity-check loss differs
before training, 5.147 against 5.001. And 14 points is z=1.44, p=0.15, with the
interval crossing zero.

So it measured run-to-run variance, not architecture. Kept, because that is the
noise floor this repo never had: ~15 points, which is larger than every gap
here except the released checkpoint against mine.

Consequences, applied throughout: the SIGReg claim is now split into what is
measured (collapse: 270x variance drop, 69 dead dims) and what is merely
consistent (the 52%->34% drop, p=0.064). significance.py runs all six tests.
Slides and speaker notes rewritten for the retraction rather than dropped.
</commit_message>
<xml_diff>
--- a/slides/世界模型的两条路线.pptx
+++ b/slides/世界模型的两条路线.pptx
@@ -1031,27 +1031,32 @@
           <a:lstStyle/>
           <a:p>
             <a:r>
-              <a:t>45秒。决定最后印象。</a:t>
-            </a:r>
-          </a:p>
-          <a:p>
-            <a:r>
-              <a:t>站得住：塌缩那组，18点差距 + 独立机制测量佐证——唯一有两类独立证据的结论。</a:t>
-            </a:r>
-          </a:p>
-          <a:p>
-            <a:r>
-              <a:t>站不住：其余单seed、900步、50条评估，小于10点一律当噪声，包括我自己的h=1 vs h=3。</a:t>
-            </a:r>
-          </a:p>
-          <a:p>
-            <a:r>
-              <a:t>也没做Dreamer vs LeWM正面对比——目标函数和评估指标不共享，硬凑需要我没搭的共同任务定义。</a:t>
-            </a:r>
-          </a:p>
-          <a:p>
-            <a:r>
-              <a:t>【停】下一步：先补seed；horizon扫远；最想做的是把死维度数做成训练期实时监控——几秒就能算，能抓到loss藏起来的塌缩。</a:t>
+              <a:t>50秒。决定最后印象。要讲得干脆，不要显得沮丧。</a:t>
+            </a:r>
+          </a:p>
+          <a:p>
+            <a:r>
+              <a:t>站得住的只有一样：塌缩本身。embedding标准差差270倍、死维度69对0——直接测量，没有噪声解释空间。</a:t>
+            </a:r>
+          </a:p>
+          <a:p>
+            <a:r>
+              <a:t>站不住的：六组成功率对比只有一组显著，噪声底约15个点，连SIGReg那18个点都是p=0.064。</a:t>
+            </a:r>
+          </a:p>
+          <a:p>
+            <a:r>
+              <a:t>实验二更是直接搞错了——以为在比架构，其实是同一个实现。</a:t>
+            </a:r>
+          </a:p>
+          <a:p>
+            <a:r>
+              <a:t>【关键的收尾】「所以我下一步的优先级被这个错误改写了：不是去扫更多超参数，而是先把评估规模做够——3到5个seed、每次200条以上episode。在那之前，扫什么都分辨不出来。」</a:t>
+            </a:r>
+          </a:p>
+          <a:p>
+            <a:r>
+              <a:t>这句话比任何实验结果都能说明你懂怎么做研究。</a:t>
             </a:r>
           </a:p>
         </p:txBody>
@@ -1716,27 +1721,32 @@
           <a:lstStyle/>
           <a:p>
             <a:r>
-              <a:t>60秒。</a:t>
-            </a:r>
-          </a:p>
-          <a:p>
-            <a:r>
-              <a:t>PLDM构造函数签名和接口与LeWM一致，只改配置里两个_target_路径就能塞进同一循环和规划器。</a:t>
-            </a:r>
-          </a:p>
-          <a:p>
-            <a:r>
-              <a:t>结果：PLDM预测更差(0.298 vs 0.266)，规划反而高14个点(66% vs 52%)。</a:t>
-            </a:r>
-          </a:p>
-          <a:p>
-            <a:r>
-              <a:t>查过不是塌缩造成的——两者embedding都健康，没死维度。</a:t>
-            </a:r>
-          </a:p>
-          <a:p>
-            <a:r>
-              <a:t>【两个caveat必须主动说】(1)单seed，14点对7pp标准误，是「值得注意」不是「已证实」；(2)训的是PLDM架构+LeWM训练配方，不是PLDM原方法，所以不能当作对PLDM的复现引用。</a:t>
+              <a:t>70秒。这页是主动认错，讲法很关键——不要辩解，要干脆。</a:t>
+            </a:r>
+          </a:p>
+          <a:p>
+            <a:r>
+              <a:t>「我原本想做架构对比。跑出来PLDM预测更差却规划更好，我一度以为抓到了一个漂亮的反例。」</a:t>
+            </a:r>
+          </a:p>
+          <a:p>
+            <a:r>
+              <a:t>【停】「但它不成立。」</a:t>
+            </a:r>
+          </a:p>
+          <a:p>
+            <a:r>
+              <a:t>三条依次说：(1)diff发现两个module.py逐字节相同，从来就不是架构对比；(2)train.py没给Manager传seed，两次初始权重不同——训练开始前sanity loss就是5.147 vs 5.001；(3)14个点 z=1.44 p=0.15，CI跨过0。</a:t>
+            </a:r>
+          </a:p>
+          <a:p>
+            <a:r>
+              <a:t>【转折，这才是价值】「所以它实际测的是重跑方差：同架构同数据同配方，只是初始化不同，成功率就能差14个点。这反而给了我一把尺子——15个点以内的差距都不能当结论，包括我自己另外两组实验里的差距。」</a:t>
+            </a:r>
+          </a:p>
+          <a:p>
+            <a:r>
+              <a:t>如果被问「那你怎么发现的」：老实说是被问到「官方不是说LeWM比PLDM好吗」之后才去diff的。这个回答比假装自己主动发现更可信。</a:t>
             </a:r>
           </a:p>
         </p:txBody>
@@ -6433,7 +6443,7 @@
                 </a:solidFill>
                 <a:latin typeface="Consolas"/>
               </a:rPr>
-              <a:t>970</a:t>
+              <a:t>949</a:t>
             </a:r>
           </a:p>
           <a:p>
@@ -6452,7 +6462,7 @@
                 </a:solidFill>
                 <a:latin typeface="微软雅黑"/>
               </a:rPr>
-              <a:t>545k 步时的评估回报（满分约 1000）</a:t>
+              <a:t>555k 步时的评估回报（满分约 1000）</a:t>
             </a:r>
           </a:p>
         </p:txBody>
@@ -7086,7 +7096,7 @@
                 </a:solidFill>
                 <a:latin typeface="微软雅黑"/>
               </a:rPr>
-              <a:t>λ=0.001 的塌缩：18 个点的成功率差距，并且有一个独立的机制测量指向同一方向。</a:t>
+              <a:t>塌缩本身：embedding 标准差 0.0012 对 0.325，差 270 倍；死维度 69 对 0。这是直接测量，不是统计推断，没有噪声解释空间。</a:t>
             </a:r>
           </a:p>
           <a:p>
@@ -7105,7 +7115,7 @@
                 </a:solidFill>
                 <a:latin typeface="微软雅黑"/>
               </a:rPr>
-              <a:t>官方 checkpoint 的 86%，对比我 900 步训练的所有模型。</a:t>
+              <a:t>官方 checkpoint 的 86%，对比我 900 步训练的所有模型（p&lt;0.001，唯一显著的一组）。</a:t>
             </a:r>
           </a:p>
         </p:txBody>
@@ -7214,7 +7224,26 @@
                 </a:solidFill>
                 <a:latin typeface="微软雅黑"/>
               </a:rPr>
-              <a:t>单 seed、900 步、50 条评估。任何小于 10 个点的差距都是噪声——h=1 vs h=3、PLDM vs h=5 都在此列。</a:t>
+              <a:t>六组成功率对比里只有一组显著，经验噪声底约 15 个百分点——包括 SIGReg 那组的 18 个点（p=0.064）。</a:t>
+            </a:r>
+          </a:p>
+          <a:p>
+            <a:pPr>
+              <a:lnSpc>
+                <a:spcPct val="145000"/>
+              </a:lnSpc>
+              <a:spcAft>
+                <a:spcPts val="900"/>
+              </a:spcAft>
+            </a:pPr>
+            <a:r>
+              <a:rPr sz="1250" b="0">
+                <a:solidFill>
+                  <a:srgbClr val="4A463B"/>
+                </a:solidFill>
+                <a:latin typeface="微软雅黑"/>
+              </a:rPr>
+              <a:t>实验二我直接搞错了：以为在比架构，其实两者是同一个实现。</a:t>
             </a:r>
           </a:p>
           <a:p>
@@ -7246,7 +7275,7 @@
         </p:nvSpPr>
         <p:spPr>
           <a:xfrm>
-            <a:off x="777240" y="4389120"/>
+            <a:off x="777240" y="4526280"/>
             <a:ext cx="10637215" cy="1280160"/>
           </a:xfrm>
           <a:prstGeom prst="rect">
@@ -7275,7 +7304,7 @@
                 </a:solidFill>
                 <a:latin typeface="微软雅黑"/>
               </a:rPr>
-              <a:t>下一步：先补到 3–5 个 seed 再谈其余结论；把 h 扫到 7–8 看收益在哪里饱和；以及把死维度数做成训练期的实时监控——它便宜，而且能抓到 loss 曲线藏起来的塌缩。</a:t>
+              <a:t>下一步的优先级被实验二改写了：不是扫更多超参数，而是先把评估规模做够——3–5 个 seed、每次 200 条以上 episode。在那之前，扫什么都分辨不出来。</a:t>
             </a:r>
           </a:p>
         </p:txBody>
@@ -10026,7 +10055,7 @@
                 </a:solidFill>
                 <a:latin typeface="微软雅黑"/>
               </a:rPr>
-              <a:t>实验二 —— loss 到底能不能给模型排序？</a:t>
+              <a:t>实验二 —— 这一组我做错了</a:t>
             </a:r>
           </a:p>
         </p:txBody>
@@ -10039,8 +10068,8 @@
         </p:nvSpPr>
         <p:spPr>
           <a:xfrm>
-            <a:off x="777240" y="1371600"/>
-            <a:ext cx="10637215" cy="640080"/>
+            <a:off x="777240" y="1325880"/>
+            <a:ext cx="10637215" cy="548640"/>
           </a:xfrm>
           <a:prstGeom prst="rect">
             <a:avLst/>
@@ -10068,7 +10097,7 @@
                 </a:solidFill>
                 <a:latin typeface="微软雅黑"/>
               </a:rPr>
-              <a:t>PLDM 的构造函数签名和接口与 LeWM 完全一致，所以只改配置里两个 _target_ 路径，就能塞进同一个训练循环和同一个规划器。同预算、同评估。</a:t>
+              <a:t>原计划：固定预算只换架构，把 PLDM 塞进同一个训练循环和规划器。跑出来 PLDM 预测更差却规划更好，看着像个漂亮的反例。</a:t>
             </a:r>
           </a:p>
         </p:txBody>
@@ -10082,8 +10111,8 @@
           <p:nvPr/>
         </p:nvGraphicFramePr>
         <p:xfrm>
-          <a:off x="777240" y="2286000"/>
-          <a:ext cx="8229599" cy="1097280"/>
+          <a:off x="777240" y="2057400"/>
+          <a:ext cx="7680958" cy="1097280"/>
         </p:xfrm>
         <a:graphic>
           <a:graphicData uri="http://schemas.openxmlformats.org/drawingml/2006/table">
@@ -10092,10 +10121,10 @@
                 <a:tableStyleId>{5C22544A-7EE6-4342-B048-85BDC9FD1C3A}</a:tableStyleId>
               </a:tblPr>
               <a:tblGrid>
-                <a:gridCol w="2519265"/>
-                <a:gridCol w="2015412"/>
-                <a:gridCol w="2015412"/>
-                <a:gridCol w="1679510"/>
+                <a:gridCol w="2351314"/>
+                <a:gridCol w="1881051"/>
+                <a:gridCol w="1881051"/>
+                <a:gridCol w="1567542"/>
               </a:tblGrid>
               <a:tr h="365760">
                 <a:tc>
@@ -10190,7 +10219,7 @@
                     <a:p>
                       <a:pPr algn="l"/>
                       <a:r>
-                        <a:rPr sz="1300" b="0">
+                        <a:rPr sz="1200" b="0">
                           <a:solidFill>
                             <a:srgbClr val="17150F"/>
                           </a:solidFill>
@@ -10213,7 +10242,7 @@
                     <a:p>
                       <a:pPr algn="r"/>
                       <a:r>
-                        <a:rPr sz="1300" b="0">
+                        <a:rPr sz="1200" b="0">
                           <a:solidFill>
                             <a:srgbClr val="17150F"/>
                           </a:solidFill>
@@ -10236,7 +10265,7 @@
                     <a:p>
                       <a:pPr algn="r"/>
                       <a:r>
-                        <a:rPr sz="1300" b="0">
+                        <a:rPr sz="1200" b="0">
                           <a:solidFill>
                             <a:srgbClr val="17150F"/>
                           </a:solidFill>
@@ -10259,7 +10288,7 @@
                     <a:p>
                       <a:pPr algn="r"/>
                       <a:r>
-                        <a:rPr sz="1300" b="0">
+                        <a:rPr sz="1200" b="0">
                           <a:solidFill>
                             <a:srgbClr val="17150F"/>
                           </a:solidFill>
@@ -10284,7 +10313,7 @@
                     <a:p>
                       <a:pPr algn="l"/>
                       <a:r>
-                        <a:rPr sz="1300" b="1">
+                        <a:rPr sz="1200" b="0">
                           <a:solidFill>
                             <a:srgbClr val="17150F"/>
                           </a:solidFill>
@@ -10296,7 +10325,7 @@
                   </a:txBody>
                   <a:tcPr marL="118872" marR="118872" marT="36576" marB="36576" anchor="ctr">
                     <a:solidFill>
-                      <a:srgbClr val="E8F3EA"/>
+                      <a:srgbClr val="FFFFFF"/>
                     </a:solidFill>
                   </a:tcPr>
                 </a:tc>
@@ -10307,7 +10336,7 @@
                     <a:p>
                       <a:pPr algn="r"/>
                       <a:r>
-                        <a:rPr sz="1300" b="1">
+                        <a:rPr sz="1200" b="0">
                           <a:solidFill>
                             <a:srgbClr val="17150F"/>
                           </a:solidFill>
@@ -10319,7 +10348,7 @@
                   </a:txBody>
                   <a:tcPr marL="118872" marR="118872" marT="36576" marB="36576" anchor="ctr">
                     <a:solidFill>
-                      <a:srgbClr val="E8F3EA"/>
+                      <a:srgbClr val="FFFFFF"/>
                     </a:solidFill>
                   </a:tcPr>
                 </a:tc>
@@ -10330,7 +10359,7 @@
                     <a:p>
                       <a:pPr algn="r"/>
                       <a:r>
-                        <a:rPr sz="1300" b="1">
+                        <a:rPr sz="1200" b="0">
                           <a:solidFill>
                             <a:srgbClr val="17150F"/>
                           </a:solidFill>
@@ -10342,7 +10371,7 @@
                   </a:txBody>
                   <a:tcPr marL="118872" marR="118872" marT="36576" marB="36576" anchor="ctr">
                     <a:solidFill>
-                      <a:srgbClr val="E8F3EA"/>
+                      <a:srgbClr val="FFFFFF"/>
                     </a:solidFill>
                   </a:tcPr>
                 </a:tc>
@@ -10353,7 +10382,7 @@
                     <a:p>
                       <a:pPr algn="r"/>
                       <a:r>
-                        <a:rPr sz="1300" b="1">
+                        <a:rPr sz="1200" b="0">
                           <a:solidFill>
                             <a:srgbClr val="17150F"/>
                           </a:solidFill>
@@ -10365,7 +10394,7 @@
                   </a:txBody>
                   <a:tcPr marL="118872" marR="118872" marT="36576" marB="36576" anchor="ctr">
                     <a:solidFill>
-                      <a:srgbClr val="E8F3EA"/>
+                      <a:srgbClr val="FFFFFF"/>
                     </a:solidFill>
                   </a:tcPr>
                 </a:tc>
@@ -10382,8 +10411,8 @@
         </p:nvSpPr>
         <p:spPr>
           <a:xfrm>
-            <a:off x="777240" y="4114800"/>
-            <a:ext cx="10637215" cy="1371600"/>
+            <a:off x="777240" y="3657600"/>
+            <a:ext cx="10637215" cy="2103120"/>
           </a:xfrm>
           <a:prstGeom prst="rect">
             <a:avLst/>
@@ -10401,17 +10430,17 @@
                 <a:spcPct val="145000"/>
               </a:lnSpc>
               <a:spcAft>
-                <a:spcPts val="500"/>
-              </a:spcAft>
-            </a:pPr>
-            <a:r>
-              <a:rPr sz="1300" b="1">
-                <a:solidFill>
-                  <a:srgbClr val="17150F"/>
+                <a:spcPts val="600"/>
+              </a:spcAft>
+            </a:pPr>
+            <a:r>
+              <a:rPr sz="1400" b="1">
+                <a:solidFill>
+                  <a:srgbClr val="C8402E"/>
                 </a:solidFill>
                 <a:latin typeface="微软雅黑"/>
               </a:rPr>
-              <a:t>预测更差，规划更好。两者 embedding 都健康（没有死维度），所以这不是塌缩造成的假象。</a:t>
+              <a:t>但它不成立。事后 diff 发现三件事：</a:t>
             </a:r>
           </a:p>
           <a:p>
@@ -10420,6 +10449,63 @@
                 <a:spcPct val="145000"/>
               </a:lnSpc>
               <a:spcAft>
+                <a:spcPts val="400"/>
+              </a:spcAft>
+            </a:pPr>
+            <a:r>
+              <a:rPr sz="1250" b="0">
+                <a:solidFill>
+                  <a:srgbClr val="4A463B"/>
+                </a:solidFill>
+                <a:latin typeface="微软雅黑"/>
+              </a:rPr>
+              <a:t>1.  pldm/module.py 和 lewm/module.py 逐字节相同——从来就不是架构对比</a:t>
+            </a:r>
+          </a:p>
+          <a:p>
+            <a:pPr>
+              <a:lnSpc>
+                <a:spcPct val="145000"/>
+              </a:lnSpc>
+              <a:spcAft>
+                <a:spcPts val="400"/>
+              </a:spcAft>
+            </a:pPr>
+            <a:r>
+              <a:rPr sz="1250" b="0">
+                <a:solidFill>
+                  <a:srgbClr val="4A463B"/>
+                </a:solidFill>
+                <a:latin typeface="微软雅黑"/>
+              </a:rPr>
+              <a:t>2.  train.py 没给 Manager 传 seed，两次初始权重不同（训练开始前 sanity loss 就是 5.147 vs 5.001）</a:t>
+            </a:r>
+          </a:p>
+          <a:p>
+            <a:pPr>
+              <a:lnSpc>
+                <a:spcPct val="145000"/>
+              </a:lnSpc>
+              <a:spcAft>
+                <a:spcPts val="1000"/>
+              </a:spcAft>
+            </a:pPr>
+            <a:r>
+              <a:rPr sz="1250" b="0">
+                <a:solidFill>
+                  <a:srgbClr val="4A463B"/>
+                </a:solidFill>
+                <a:latin typeface="微软雅黑"/>
+              </a:rPr>
+              <a:t>3.  14 个点：z = 1.44，p = 0.15，95% CI [-5, +33] 跨过 0</a:t>
+            </a:r>
+          </a:p>
+          <a:p>
+            <a:pPr>
+              <a:lnSpc>
+                <a:spcPct val="145000"/>
+              </a:lnSpc>
+              <a:spcAft>
                 <a:spcPts val="600"/>
               </a:spcAft>
             </a:pPr>
@@ -10430,7 +10516,7 @@
                 </a:solidFill>
                 <a:latin typeface="微软雅黑"/>
               </a:rPr>
-              <a:t>单 seed、14 个点对 7pp 标准误——是“值得注意”，不是“已证实”。另外这训的是 PLDM 的架构配 LeWM 的训练配方，不是 PLDM 自己的，所以不能当作对 PLDM 论文的复现来引用。</a:t>
+              <a:t>所以它实际是一次意外的重跑方差测量：同架构、同数据、同配方，仅初始化不同，成功率相差 14 个百分点。这给了整个项目一把尺子——15 个百分点以内的差距都不能当结论。</a:t>
             </a:r>
           </a:p>
         </p:txBody>

</xml_diff>

<commit_message>
Rebuild all three decks around experiment 4
Seventeen slides now. Experiment 2's slide was still telling the first,
wrong version of that story; it now says the design varied the wrong thing
and reports the redone three-seed result and the +-17pp seed variance.
Two new slides carry experiment 4: the low-variance metrics and the r=0.89
scale relationship, then the confound that runs through experiments 1 and 3
and the fact that SIGReg's own statistic never moves.

Slides 8, 10 and 11 no longer close on conclusions the last two slides
withdraw - they hand forward the orderings (52/54/64, 34/52/38) instead.
Slide 12 ends on the question rather than an answer. The limits slide
separates what is a direct measurement from what is withdrawn, and states
the intervention experiment that would be needed to make experiment 4 causal.

Speaker notes rewritten for every changed slide. The English deck also gets
the @page rule the Chinese one already had, so it exports to PDF at 1280x720.
</commit_message>
<xml_diff>
--- a/slides/世界模型的两条路线.pptx
+++ b/slides/世界模型的两条路线.pptx
@@ -20,6 +20,8 @@
     <p:sldId id="268" r:id="rId19"/>
     <p:sldId id="269" r:id="rId20"/>
     <p:sldId id="270" r:id="rId21"/>
+    <p:sldId id="271" r:id="rId22"/>
+    <p:sldId id="272" r:id="rId23"/>
   </p:sldIdLst>
   <p:sldSz cx="12191695" cy="6858000" type="screen4x3"/>
   <p:notesSz cx="6858000" cy="9144000"/>
@@ -521,7 +523,7 @@
           </a:p>
           <a:p>
             <a:r>
-              <a:t>「我做的是世界模型方向的复现加实验项目。两条路线都做了，但重点在后面自己设计的实验。」</a:t>
+              <a:t>「我做的是世界模型方向的复现加实验项目。两条路线都做了，但重点在后面自己设计的实验——尤其是最后一组，它推翻了我前面三组的结论。」</a:t>
             </a:r>
           </a:p>
         </p:txBody>
@@ -591,7 +593,7 @@
           <a:lstStyle/>
           <a:p>
             <a:r>
-              <a:t>60秒。全场高潮，语速放慢。</a:t>
+              <a:t>60秒。语速放慢。</a:t>
             </a:r>
           </a:p>
           <a:p>
@@ -616,12 +618,12 @@
           </a:p>
           <a:p>
             <a:r>
-              <a:t>成功率印证：34%，全场最差。</a:t>
-            </a:r>
-          </a:p>
-          <a:p>
-            <a:r>
               <a:t>三要素缺一不可：数字反常 → 我不信 → 我设计独立测量去验证。</a:t>
+            </a:r>
+          </a:p>
+          <a:p>
+            <a:r>
+              <a:t>【同样别急着下结论】成功率34%只是印证，第四组会说明它为什么低——原因和我当时想的不一样。</a:t>
             </a:r>
           </a:p>
         </p:txBody>
@@ -719,6 +721,11 @@
               <a:t>另一头10倍权重不塌缩但压太紧，成功率38%。倒U，论文的0.09在顶点。</a:t>
             </a:r>
           </a:p>
+          <a:p>
+            <a:r>
+              <a:t>【记住这个倒U的形状：34、52、38。下一页之后要用。】</a:t>
+            </a:r>
+          </a:p>
         </p:txBody>
       </p:sp>
       <p:sp>
@@ -786,22 +793,22 @@
           <a:lstStyle/>
           <a:p>
             <a:r>
-              <a:t>30秒。收结论，别拖。</a:t>
-            </a:r>
-          </a:p>
-          <a:p>
-            <a:r>
-              <a:t>「六个checkpoint放一起，横轴loss对数轴跨三个数量级，纵轴成功率。」</a:t>
-            </a:r>
-          </a:p>
-          <a:p>
-            <a:r>
-              <a:t>「如果loss是可靠代理，应该是向右下的趋势线。【停】它没有趋势。」</a:t>
-            </a:r>
-          </a:p>
-          <a:p>
-            <a:r>
-              <a:t>「loss最低那个是塌缩模型，规划几乎最差；规划最好的甚至不是LeWM。」</a:t>
+              <a:t>35秒。这页是转折点，不是结论页。</a:t>
+            </a:r>
+          </a:p>
+          <a:p>
+            <a:r>
+              <a:t>「六个checkpoint放一起，横轴loss对数轴跨三个数量级，纵轴成功率。如果loss是可靠代理，应该有一条向右下的趋势线。【停】没有。」</a:t>
+            </a:r>
+          </a:p>
+          <a:p>
+            <a:r>
+              <a:t>【把它变成问题】「那我手上就只剩一个成功率指标，而它的噪声是±17个点。与其再多跑seed硬扛噪声，我想换个问题：到底什么决定规划成不成功？」</a:t>
+            </a:r>
+          </a:p>
+          <a:p>
+            <a:r>
+              <a:t>这句话是第四组实验的动机，一定要说出来。</a:t>
             </a:r>
           </a:p>
         </p:txBody>
@@ -871,12 +878,47 @@
           <a:lstStyle/>
           <a:p>
             <a:r>
-              <a:t>25秒。时间紧可跳。</a:t>
-            </a:r>
-          </a:p>
-          <a:p>
-            <a:r>
-              <a:t>「手写版证明我理解组件，规模上另外跑了官方DreamerV3在walker-walk，接近任务天花板。两条线分工：一条证明理解，一条拿真实曲线。」</a:t>
+              <a:t>80秒。全场最重要的一页。</a:t>
+            </a:r>
+          </a:p>
+          <a:p>
+            <a:r>
+              <a:t>「第四组不训练任何新模型——在已有的12个checkpoint上，换一批低方差指标，3000帧留出数据。」</a:t>
+            </a:r>
+          </a:p>
+          <a:p>
+            <a:r>
+              <a:t>四个指标：Epps-Pulley正态性（SIGReg自己声称要优化的东西）、岭回归探针embedding→智能体位置的留出R²（论文自己的probing口径）、有效秩、embedding绝对尺度。</a:t>
+            </a:r>
+          </a:p>
+          <a:p>
+            <a:r>
+              <a:t>【先说可信度】「指标先在已知分布上校准过：真高斯给0.5，4维线性流形嵌进192维给170，有效秩还原到3.93。」</a:t>
+            </a:r>
+          </a:p>
+          <a:p>
+            <a:r>
+              <a:t>【结果】「只有一个指标和成功率相关：embedding的绝对尺度，r=0.89，t=5.85。而物理探针R²是+0.24、有效秩−0.22、离高斯距离−0.30，全部不显著。」</a:t>
+            </a:r>
+          </a:p>
+          <a:p>
+            <a:r>
+              <a:t>【一句话总结，慢】「表征里有多少物理信息，几乎不决定它能不能规划；表征有多大才决定。」</a:t>
+            </a:r>
+          </a:p>
+          <a:p>
+            <a:r>
+              <a:t>机制：CEM靠比较embedding空间的距离选动作。信号缩小而predictor误差不变，代价地形就被噪声淹没。</a:t>
+            </a:r>
+          </a:p>
+          <a:p>
+            <a:r>
+              <a:t>【回头改自己的结论】「这直接推翻我在实验三写的解释：塌缩那个checkpoint探针R²是0.467，健康的是0.497——位置信息几乎完好。塌缩毁掉的不是信息，是信噪比。」</a:t>
+            </a:r>
+          </a:p>
+          <a:p>
+            <a:r>
+              <a:t>右下那个孤点是官方checkpoint：尺度0.032、有效秩1.66，却86%。所以「尺度决定」只在欠训练模型里成立。</a:t>
             </a:r>
           </a:p>
         </p:txBody>
@@ -946,22 +988,42 @@
           <a:lstStyle/>
           <a:p>
             <a:r>
-              <a:t>40秒。看岗位决定讲不讲——工程岗讲，研究岗一句带过。</a:t>
-            </a:r>
-          </a:p>
-          <a:p>
-            <a:r>
-              <a:t>坑1：软链torch复用，包管理器顺着软链把另一个项目的torch就地升级了，而它还有跑了一天的进程在跑（靠Linux对已打开inode的保护才没崩）。</a:t>
-            </a:r>
-          </a:p>
-          <a:p>
-            <a:r>
-              <a:t>坑2：原计划扫latent dimension直接崩——那参数不是自由的，和编码器宽度硬绑定。失败本身加深了理解。</a:t>
-            </a:r>
-          </a:p>
-          <a:p>
-            <a:r>
-              <a:t>坑3：终端日志卡住一小时以为挂了，其实是stdout缓冲，指标文件早跑过去了。</a:t>
+              <a:t>70秒。认错的第二层，也是整个项目的方法论落点。</a:t>
+            </a:r>
+          </a:p>
+          <a:p>
+            <a:r>
+              <a:t>【左图】「实验一的成功率排序52、54、64，和它们的尺度排序0.319、0.348、0.389完全一致。」</a:t>
+            </a:r>
+          </a:p>
+          <a:p>
+            <a:r>
+              <a:t>「实验三成功率的倒U——34、52、38，和尺度的倒U——0.0012、0.319、0.116，同一个形状。」</a:t>
+            </a:r>
+          </a:p>
+          <a:p>
+            <a:r>
+              <a:t>【停，说重话】「三组实验拧的是三个不同的旋钮，但都落到同一个中介变量上。我以为在测三件事，其实一直在测同一件事。」</a:t>
+            </a:r>
+          </a:p>
+          <a:p>
+            <a:r>
+              <a:t>【最有价值的一句】「关键是：加seed救不了这些实验。跑45个seed只会得到一个混杂量的精确估计。问题不在功效，在设计。」</a:t>
+            </a:r>
+          </a:p>
+          <a:p>
+            <a:r>
+              <a:t>【右图，顺带的收获】「SIGReg的高斯性统计量在1000倍权重扫描里是1206、1206、1206，纹丝不动。参照值：真高斯0.5，4维线性流形170。」</a:t>
+            </a:r>
+          </a:p>
+          <a:p>
+            <a:r>
+              <a:t>「所以它实际起的作用是维持embedding尺度，不是高斯化。论文命名的机制和实际生效的机制不是一回事。」</a:t>
+            </a:r>
+          </a:p>
+          <a:p>
+            <a:r>
+              <a:t>被问「这是不是你实现错了」：可能，但同一个式子在已知分布上校准是对的，而且它确实随λ改变了尺度——该动的量动了，声称的量没动。这是我目前能给的最诚实的说法。</a:t>
             </a:r>
           </a:p>
         </p:txBody>
@@ -1031,32 +1093,192 @@
           <a:lstStyle/>
           <a:p>
             <a:r>
-              <a:t>50秒。决定最后印象。要讲得干脆，不要显得沮丧。</a:t>
-            </a:r>
-          </a:p>
-          <a:p>
-            <a:r>
-              <a:t>站得住的只有一样：塌缩本身。embedding标准差差270倍、死维度69对0——直接测量，没有噪声解释空间。</a:t>
-            </a:r>
-          </a:p>
-          <a:p>
-            <a:r>
-              <a:t>站不住的：六组成功率对比只有一组显著，噪声底约15个点，连SIGReg那18个点都是p=0.064。</a:t>
-            </a:r>
-          </a:p>
-          <a:p>
-            <a:r>
-              <a:t>实验二更是直接搞错了——以为在比架构，其实是同一个实现。</a:t>
-            </a:r>
-          </a:p>
-          <a:p>
-            <a:r>
-              <a:t>【关键的收尾】「所以我下一步的优先级被这个错误改写了：不是去扫更多超参数，而是先把评估规模做够——3到5个seed、每次200条以上episode。在那之前，扫什么都分辨不出来。」</a:t>
-            </a:r>
-          </a:p>
-          <a:p>
-            <a:r>
-              <a:t>这句话比任何实验结果都能说明你懂怎么做研究。</a:t>
+              <a:t>25秒。时间紧可跳。</a:t>
+            </a:r>
+          </a:p>
+          <a:p>
+            <a:r>
+              <a:t>「手写版证明我理解组件，规模上另外跑了官方DreamerV3在walker-walk，接近任务天花板。两条线分工：一条证明理解，一条拿真实曲线。」</a:t>
+            </a:r>
+          </a:p>
+        </p:txBody>
+      </p:sp>
+      <p:sp>
+        <p:nvSpPr>
+          <p:cNvPr id="4" name="Slide Number Placeholder 3"/>
+          <p:cNvSpPr>
+            <a:spLocks noGrp="1"/>
+          </p:cNvSpPr>
+          <p:nvPr>
+            <p:ph type="sldNum" idx="5" sz="quarter"/>
+          </p:nvPr>
+        </p:nvSpPr>
+        <p:spPr/>
+      </p:sp>
+    </p:spTree>
+  </p:cSld>
+  <p:clrMapOvr>
+    <a:masterClrMapping/>
+  </p:clrMapOvr>
+</p:notes>
+</file>
+
+<file path=ppt/notesSlides/notesSlide16.xml><?xml version="1.0" encoding="utf-8"?>
+<p:notes xmlns:a="http://schemas.openxmlformats.org/drawingml/2006/main" xmlns:p="http://schemas.openxmlformats.org/presentationml/2006/main" xmlns:r="http://schemas.openxmlformats.org/officeDocument/2006/relationships">
+  <p:cSld>
+    <p:spTree>
+      <p:nvGrpSpPr>
+        <p:cNvPr id="1" name=""/>
+        <p:cNvGrpSpPr/>
+        <p:nvPr/>
+      </p:nvGrpSpPr>
+      <p:grpSpPr>
+        <a:xfrm>
+          <a:off x="0" y="0"/>
+          <a:ext cx="0" cy="0"/>
+          <a:chOff x="0" y="0"/>
+          <a:chExt cx="0" cy="0"/>
+        </a:xfrm>
+      </p:grpSpPr>
+      <p:sp>
+        <p:nvSpPr>
+          <p:cNvPr id="2" name="Slide Image Placeholder 1"/>
+          <p:cNvSpPr>
+            <a:spLocks noGrp="1"/>
+          </p:cNvSpPr>
+          <p:nvPr>
+            <p:ph type="sldImg" idx="2"/>
+          </p:nvPr>
+        </p:nvSpPr>
+        <p:spPr/>
+      </p:sp>
+      <p:sp>
+        <p:nvSpPr>
+          <p:cNvPr id="3" name="Notes Placeholder 2"/>
+          <p:cNvSpPr>
+            <a:spLocks noGrp="1"/>
+          </p:cNvSpPr>
+          <p:nvPr>
+            <p:ph type="body" idx="3" sz="quarter"/>
+          </p:nvPr>
+        </p:nvSpPr>
+        <p:spPr/>
+        <p:txBody>
+          <a:bodyPr/>
+          <a:lstStyle/>
+          <a:p>
+            <a:r>
+              <a:t>40秒。看岗位决定讲不讲——工程岗讲，研究岗一句带过。</a:t>
+            </a:r>
+          </a:p>
+          <a:p>
+            <a:r>
+              <a:t>坑1：软链torch复用，包管理器顺着软链把另一个项目的torch就地升级了，而它还有跑了一天的进程在跑（靠Linux对已打开inode的保护才没崩）。</a:t>
+            </a:r>
+          </a:p>
+          <a:p>
+            <a:r>
+              <a:t>坑2：原计划扫latent dimension直接崩——那参数不是自由的，和编码器宽度硬绑定。失败本身加深了理解。</a:t>
+            </a:r>
+          </a:p>
+          <a:p>
+            <a:r>
+              <a:t>坑3：终端日志卡住一小时以为挂了，其实是stdout缓冲，指标文件早跑过去了。</a:t>
+            </a:r>
+          </a:p>
+        </p:txBody>
+      </p:sp>
+      <p:sp>
+        <p:nvSpPr>
+          <p:cNvPr id="4" name="Slide Number Placeholder 3"/>
+          <p:cNvSpPr>
+            <a:spLocks noGrp="1"/>
+          </p:cNvSpPr>
+          <p:nvPr>
+            <p:ph type="sldNum" idx="5" sz="quarter"/>
+          </p:nvPr>
+        </p:nvSpPr>
+        <p:spPr/>
+      </p:sp>
+    </p:spTree>
+  </p:cSld>
+  <p:clrMapOvr>
+    <a:masterClrMapping/>
+  </p:clrMapOvr>
+</p:notes>
+</file>
+
+<file path=ppt/notesSlides/notesSlide17.xml><?xml version="1.0" encoding="utf-8"?>
+<p:notes xmlns:a="http://schemas.openxmlformats.org/drawingml/2006/main" xmlns:p="http://schemas.openxmlformats.org/presentationml/2006/main" xmlns:r="http://schemas.openxmlformats.org/officeDocument/2006/relationships">
+  <p:cSld>
+    <p:spTree>
+      <p:nvGrpSpPr>
+        <p:cNvPr id="1" name=""/>
+        <p:cNvGrpSpPr/>
+        <p:nvPr/>
+      </p:nvGrpSpPr>
+      <p:grpSpPr>
+        <a:xfrm>
+          <a:off x="0" y="0"/>
+          <a:ext cx="0" cy="0"/>
+          <a:chOff x="0" y="0"/>
+          <a:chExt cx="0" cy="0"/>
+        </a:xfrm>
+      </p:grpSpPr>
+      <p:sp>
+        <p:nvSpPr>
+          <p:cNvPr id="2" name="Slide Image Placeholder 1"/>
+          <p:cNvSpPr>
+            <a:spLocks noGrp="1"/>
+          </p:cNvSpPr>
+          <p:nvPr>
+            <p:ph type="sldImg" idx="2"/>
+          </p:nvPr>
+        </p:nvSpPr>
+        <p:spPr/>
+      </p:sp>
+      <p:sp>
+        <p:nvSpPr>
+          <p:cNvPr id="3" name="Notes Placeholder 2"/>
+          <p:cNvSpPr>
+            <a:spLocks noGrp="1"/>
+          </p:cNvSpPr>
+          <p:nvPr>
+            <p:ph type="body" idx="3" sz="quarter"/>
+          </p:nvPr>
+        </p:nvSpPr>
+        <p:spPr/>
+        <p:txBody>
+          <a:bodyPr/>
+          <a:lstStyle/>
+          <a:p>
+            <a:r>
+              <a:t>60秒。决定最后印象。干脆，不要显得沮丧——被推翻的是结论，不是能力。</a:t>
+            </a:r>
+          </a:p>
+          <a:p>
+            <a:r>
+              <a:t>站得住的三样都是直接测量：塌缩本身（标准差差270倍、死维度69对0）、尺度与成功率的相关（r=0.89、t=5.85）、SIGReg的高斯统计量在1000倍扫描下不动。</a:t>
+            </a:r>
+          </a:p>
+          <a:p>
+            <a:r>
+              <a:t>站不住的：前三组的成功率结论全部作废，因为它们测的是同一个混杂变量。</a:t>
+            </a:r>
+          </a:p>
+          <a:p>
+            <a:r>
+              <a:t>【主动说出第四组自己的短板，这比等对方问出来强得多】「第四组也只是观测，不是干预。n=11，而且是相关。要证明尺度真的导致规划成败，得做干预实验——在评估时人为把embedding乘以一个系数，看成功率跟不跟着走。这是显然的下一步，我没做。」</a:t>
+            </a:r>
+          </a:p>
+          <a:p>
+            <a:r>
+              <a:t>还有一条边界：官方checkpoint尺度0.032却拿86%，说明这条规律在训练充分之后就不成立了。</a:t>
+            </a:r>
+          </a:p>
+          <a:p>
+            <a:r>
+              <a:t>【收尾】「所以下一步的优先级被改写了两次：第一次是从『扫更多超参数』改成『先把评估规模做够』，第二次是从那里改成『先搞清楚主指标被什么决定』。回头看，第四组应该是第一组。」</a:t>
             </a:r>
           </a:p>
         </p:txBody>
@@ -1141,7 +1363,7 @@
           </a:p>
           <a:p>
             <a:r>
-              <a:t>【必须埋伏笔】「如果目标只是预测下一个向量要准，有个作弊解——让encoder对任何输入都输出同一个常数，loss直接趋近0。模型赢了，任务输了。这叫表征塌缩。记住它，我最重要的实验就围绕它。」</a:t>
+              <a:t>【必须埋伏笔】「如果目标只是预测下一个向量要准，有个作弊解——让encoder对任何输入都输出同一个常数，loss直接趋近0。模型赢了，任务输了。这叫表征塌缩。记住它，后面一半的内容都围绕它。」</a:t>
             </a:r>
           </a:p>
           <a:p>
@@ -1216,7 +1438,12 @@
           <a:lstStyle/>
           <a:p>
             <a:r>
-              <a:t>20秒。这页只是路标。三件事：手写Dreamer、跑通LeWM、三组受控实验。翻页。</a:t>
+              <a:t>20秒。这页只是路标。三件事：手写Dreamer、跑通LeWM、四组受控实验。</a:t>
+            </a:r>
+          </a:p>
+          <a:p>
+            <a:r>
+              <a:t>【提一句】「第四组是诊断前三组的，最后你会看到前三组的结论被它推翻了。」翻页。</a:t>
             </a:r>
           </a:p>
         </p:txBody>
@@ -1556,7 +1783,12 @@
           </a:p>
           <a:p>
             <a:r>
-              <a:t>【别省这句】「三组实验共用同一份数据、同一个encoder、同一个优化器、同样900步、同样50条episode——每组只动一个变量。」</a:t>
+              <a:t>【别省这句】「四组实验共用同一份数据、同一个encoder、同一个优化器、同样900步、同样50条episode——每组只动一个变量。【停】至少我当时是这么以为的。」</a:t>
+            </a:r>
+          </a:p>
+          <a:p>
+            <a:r>
+              <a:t>最后半句是钩子，别漏。</a:t>
             </a:r>
           </a:p>
         </p:txBody>
@@ -1626,7 +1858,7 @@
           <a:lstStyle/>
           <a:p>
             <a:r>
-              <a:t>60秒。</a:t>
+              <a:t>50秒。语气要中立，别把它讲成一个结论。</a:t>
             </a:r>
           </a:p>
           <a:p>
@@ -1641,17 +1873,12 @@
           </a:p>
           <a:p>
             <a:r>
-              <a:t>【最能体现统计素养的一句，主动说】「这两个点的差距我认为就是噪声。50条episode、p≈0.5，二项标准误约7个百分点。我能下的结论只有h=5更好。」</a:t>
-            </a:r>
-          </a:p>
-          <a:p>
-            <a:r>
-              <a:t>「但正是这个错位让我起疑，才有后面两组实验。」</a:t>
-            </a:r>
-          </a:p>
-          <a:p>
-            <a:r>
-              <a:t>追问「为什么不多跑seed」：时间限制，这是最明显短板，README里也这么写的，给我一周补seed是第一优先。</a:t>
+              <a:t>【统计素养，主动说】「50条episode、p≈0.5，二项标准误约7个百分点，这一对就是噪声。」</a:t>
+            </a:r>
+          </a:p>
+          <a:p>
+            <a:r>
+              <a:t>【重要：不要在这页下结论】「当时我留下的结论是h=5更好。第四组实验会告诉你这个结论也不成立——先记着这个成功率排序：52、54、64。」</a:t>
             </a:r>
           </a:p>
         </p:txBody>
@@ -1721,32 +1948,47 @@
           <a:lstStyle/>
           <a:p>
             <a:r>
-              <a:t>70秒。这页是主动认错，讲法很关键——不要辩解，要干脆。</a:t>
-            </a:r>
-          </a:p>
-          <a:p>
-            <a:r>
-              <a:t>「我原本想做架构对比。跑出来PLDM预测更差却规划更好，我一度以为抓到了一个漂亮的反例。」</a:t>
-            </a:r>
-          </a:p>
-          <a:p>
-            <a:r>
-              <a:t>【停】「但它不成立。」</a:t>
-            </a:r>
-          </a:p>
-          <a:p>
-            <a:r>
-              <a:t>三条依次说：(1)diff发现两个module.py逐字节相同，从来就不是架构对比；(2)train.py没给Manager传seed，两次初始权重不同——训练开始前sanity loss就是5.147 vs 5.001；(3)14个点 z=1.44 p=0.15，CI跨过0。</a:t>
-            </a:r>
-          </a:p>
-          <a:p>
-            <a:r>
-              <a:t>【转折，这才是价值】「所以它实际测的是重跑方差：同架构同数据同配方，只是初始化不同，成功率就能差14个点。这反而给了我一把尺子——15个点以内的差距都不能当结论，包括我自己另外两组实验里的差距。」</a:t>
-            </a:r>
-          </a:p>
-          <a:p>
-            <a:r>
-              <a:t>如果被问「那你怎么发现的」：老实说是被问到「官方不是说LeWM比PLDM好吗」之后才去diff的。这个回答比假装自己主动发现更可信。</a:t>
+              <a:t>70秒。主动认错，讲法很关键——干脆，不辩解，而且要讲清「错在哪一层」。</a:t>
+            </a:r>
+          </a:p>
+          <a:p>
+            <a:r>
+              <a:t>「原计划是固定预算只换架构，把PLDM和LeWM对比。」</a:t>
+            </a:r>
+          </a:p>
+          <a:p>
+            <a:r>
+              <a:t>【停】「但这个设计本身是错的。JEPA是一个方法家族，家族成员共享架构，区别在anti-collapse loss。」</a:t>
+            </a:r>
+          </a:p>
+          <a:p>
+            <a:r>
+              <a:t>「我只换了模型类，loss还是LeWM的SIGReg——等于两臂跑的是同一个方法。证据很硬：两份训练日志都在报sigreg_loss，真PLDM不该有这一项。」</a:t>
+            </a:r>
+          </a:p>
+          <a:p>
+            <a:r>
+              <a:t>还有第二个bug：train.py没给Manager传seed，两次初始权重不同。</a:t>
+            </a:r>
+          </a:p>
+          <a:p>
+            <a:r>
+              <a:t>【重做】「所以我重写了训练脚本，只换loss，补上seed，每臂跑3个seed。」</a:t>
+            </a:r>
+          </a:p>
+          <a:p>
+            <a:r>
+              <a:t>结果：LeWM 55.3%，PLDM 43.3%，t=0.87，置信区间跨过0。方向对得上论文，但完全不显著。</a:t>
+            </a:r>
+          </a:p>
+          <a:p>
+            <a:r>
+              <a:t>【真正的产出】「重做的价值不在这个对比，在那个标准差：同配置同数据，只换seed，成功率能从36%到70%——±17个百分点。要在80%功效下测出10个点的差异，每臂需要约45个seed。我有1个。」</a:t>
+            </a:r>
+          </a:p>
+          <a:p>
+            <a:r>
+              <a:t>被问「怎么发现的」：老实说是被追问「官方不是说LeWM更好吗」之后才去diff的。比假装主动发现可信。</a:t>
             </a:r>
           </a:p>
         </p:txBody>
@@ -4929,7 +5171,7 @@
                 </a:solidFill>
                 <a:latin typeface="Consolas"/>
               </a:rPr>
-              <a:t>1 / 15</a:t>
+              <a:t>1 / 17</a:t>
             </a:r>
           </a:p>
         </p:txBody>
@@ -5124,7 +5366,7 @@
                 </a:solidFill>
                 <a:latin typeface="微软雅黑"/>
               </a:rPr>
-              <a:t>encoder 塌缩会让预测任务变得极其简单，这个指标在这里是反向的。</a:t>
+              <a:t>encoder 塌缩会让预测任务变得极其简单，这个指标在这里是反向的。成功率 34% 只是印证——它为什么低，第 13 页给的答案和我当时想的不一样。</a:t>
             </a:r>
           </a:p>
         </p:txBody>
@@ -5208,7 +5450,7 @@
                 </a:solidFill>
                 <a:latin typeface="Consolas"/>
               </a:rPr>
-              <a:t>10 / 15</a:t>
+              <a:t>10 / 17</a:t>
             </a:r>
           </a:p>
         </p:txBody>
@@ -5946,7 +6188,7 @@
                 </a:solidFill>
                 <a:latin typeface="微软雅黑"/>
               </a:rPr>
-              <a:t>另一头是过度正则：不塌缩，但 embedding 被压得太紧（标准差 0.325 → 0.115），区分状态的能力变弱。论文选的 0.09 正好落在这个倒 U 的顶点。</a:t>
+              <a:t>另一头是过度正则：不塌缩，但 embedding 被压得太紧（标准差 0.325 → 0.115），区分状态的能力变弱。论文选的 0.09 正好落在这个倒 U 的顶点。记住成功率的这个形状：34 / 52 / 38。</a:t>
             </a:r>
           </a:p>
         </p:txBody>
@@ -6030,7 +6272,7 @@
                 </a:solidFill>
                 <a:latin typeface="Consolas"/>
               </a:rPr>
-              <a:t>11 / 15</a:t>
+              <a:t>11 / 17</a:t>
             </a:r>
           </a:p>
         </p:txBody>
@@ -6183,7 +6425,7 @@
                 </a:solidFill>
                 <a:latin typeface="微软雅黑"/>
               </a:rPr>
-              <a:t>loss 最低的那个点是塌缩模型；规划最好的那个甚至不是 LeWM。</a:t>
+              <a:t>于是我手上只剩成功率这一个指标，而它的噪声是 ±17 个百分点。与其再多跑 seed 硬扛噪声，不如换一个问题：到底是什么决定规划成不成功？</a:t>
             </a:r>
           </a:p>
         </p:txBody>
@@ -6267,7 +6509,7 @@
                 </a:solidFill>
                 <a:latin typeface="Consolas"/>
               </a:rPr>
-              <a:t>12 / 15</a:t>
+              <a:t>12 / 17</a:t>
             </a:r>
           </a:p>
         </p:txBody>
@@ -6335,7 +6577,7 @@
                 </a:solidFill>
                 <a:latin typeface="微软雅黑"/>
               </a:rPr>
-              <a:t>规模验证 —— DreamerV3 在 DMC walker-walk</a:t>
+              <a:t>实验四 —— 换一批噪声小得多的指标</a:t>
             </a:r>
           </a:p>
         </p:txBody>
@@ -6348,8 +6590,8 @@
         </p:nvSpPr>
         <p:spPr>
           <a:xfrm>
-            <a:off x="777240" y="1325880"/>
-            <a:ext cx="10637215" cy="457200"/>
+            <a:off x="777240" y="1298448"/>
+            <a:ext cx="10637215" cy="777240"/>
           </a:xfrm>
           <a:prstGeom prst="rect">
             <a:avLst/>
@@ -6367,24 +6609,43 @@
                 <a:spcPct val="145000"/>
               </a:lnSpc>
               <a:spcAft>
+                <a:spcPts val="400"/>
+              </a:spcAft>
+            </a:pPr>
+            <a:r>
+              <a:rPr sz="1250" b="0">
+                <a:solidFill>
+                  <a:srgbClr val="4A463B"/>
+                </a:solidFill>
+                <a:latin typeface="微软雅黑"/>
+              </a:rPr>
+              <a:t>不训练任何新模型：在已有的 12 个 checkpoint 上、3000 帧留出数据上测四个量——Epps-Pulley 正态性（SIGReg 声称要优化的东西）、岭回归探针 embedding → 智能体位置的留出 R²（论文自己的 probing 口径）、有效秩、embedding 的绝对尺度。</a:t>
+            </a:r>
+          </a:p>
+          <a:p>
+            <a:pPr>
+              <a:lnSpc>
+                <a:spcPct val="145000"/>
+              </a:lnSpc>
+              <a:spcAft>
                 <a:spcPts val="600"/>
               </a:spcAft>
             </a:pPr>
             <a:r>
-              <a:rPr sz="1300" b="0">
-                <a:solidFill>
-                  <a:srgbClr val="4A463B"/>
+              <a:rPr sz="1200" b="0">
+                <a:solidFill>
+                  <a:srgbClr val="8D8779"/>
                 </a:solidFill>
                 <a:latin typeface="微软雅黑"/>
               </a:rPr>
-              <a:t>手写版证明我理解每个组件；这一条是官方实现在真实基准上的完整曲线。</a:t>
+              <a:t>指标先在已知分布上校准：真·各向同性高斯给 0.5，4 维线性流形嵌入 192 维给 170.6，有效秩还原到 3.93。</a:t>
             </a:r>
           </a:p>
         </p:txBody>
       </p:sp>
       <p:pic>
         <p:nvPicPr>
-          <p:cNvPr id="4" name="Picture 3" descr="dreamerv3_walker.png"/>
+          <p:cNvPr id="4" name="Picture 3" descr="exp4_scale_vs_success.png"/>
           <p:cNvPicPr>
             <a:picLocks noChangeAspect="1"/>
           </p:cNvPicPr>
@@ -6398,8 +6659,8 @@
         </p:blipFill>
         <p:spPr>
           <a:xfrm>
-            <a:off x="3476606" y="1874519"/>
-            <a:ext cx="5238483" cy="2834640"/>
+            <a:off x="3241205" y="2468880"/>
+            <a:ext cx="5709285" cy="2468880"/>
           </a:xfrm>
           <a:prstGeom prst="rect">
             <a:avLst/>
@@ -6414,8 +6675,8 @@
         </p:nvSpPr>
         <p:spPr>
           <a:xfrm>
-            <a:off x="777240" y="4937760"/>
-            <a:ext cx="3108960" cy="1097280"/>
+            <a:off x="777240" y="5074920"/>
+            <a:ext cx="10637215" cy="1234440"/>
           </a:xfrm>
           <a:prstGeom prst="rect">
             <a:avLst/>
@@ -6430,39 +6691,39 @@
           <a:p>
             <a:pPr algn="l">
               <a:lnSpc>
-                <a:spcPct val="100000"/>
-              </a:lnSpc>
-              <a:spcAft>
-                <a:spcPts val="200"/>
-              </a:spcAft>
-            </a:pPr>
-            <a:r>
-              <a:rPr sz="3400" b="1">
+                <a:spcPct val="145000"/>
+              </a:lnSpc>
+              <a:spcAft>
+                <a:spcPts val="500"/>
+              </a:spcAft>
+            </a:pPr>
+            <a:r>
+              <a:rPr sz="1400" b="1">
                 <a:solidFill>
                   <a:srgbClr val="17150F"/>
                 </a:solidFill>
-                <a:latin typeface="Consolas"/>
-              </a:rPr>
-              <a:t>949</a:t>
+                <a:latin typeface="微软雅黑"/>
+              </a:rPr>
+              <a:t>表征里有多少物理信息，几乎不决定它能不能规划；表征有多大才决定。</a:t>
             </a:r>
           </a:p>
           <a:p>
             <a:pPr>
               <a:lnSpc>
-                <a:spcPct val="130000"/>
-              </a:lnSpc>
-              <a:spcAft>
-                <a:spcPts val="0"/>
-              </a:spcAft>
-            </a:pPr>
-            <a:r>
-              <a:rPr sz="1100" b="0">
+                <a:spcPct val="145000"/>
+              </a:lnSpc>
+              <a:spcAft>
+                <a:spcPts val="600"/>
+              </a:spcAft>
+            </a:pPr>
+            <a:r>
+              <a:rPr sz="1150" b="0">
                 <a:solidFill>
                   <a:srgbClr val="8D8779"/>
                 </a:solidFill>
                 <a:latin typeface="微软雅黑"/>
               </a:rPr>
-              <a:t>555k 步时的评估回报（满分约 1000）</a:t>
+              <a:t>尺度 r = +0.89（t = 5.85）；探针 R² +0.24、有效秩 −0.22、离高斯距离 −0.30，全部不显著。CEM 靠比较 embedding 空间里的距离选动作——信号缩小而 predictor 误差不变，代价地形就被噪声淹没。这也推翻了我在实验三给的解释：塌缩那个 checkpoint 探针 R² 是 0.467，健康的是 0.497，位置信息几乎完好。塌缩毁掉的不是信息，是信噪比。</a:t>
             </a:r>
           </a:p>
         </p:txBody>
@@ -6475,8 +6736,8 @@
         </p:nvSpPr>
         <p:spPr>
           <a:xfrm>
-            <a:off x="4069080" y="5029200"/>
-            <a:ext cx="7315200" cy="822960"/>
+            <a:off x="777240" y="6291072"/>
+            <a:ext cx="9539935" cy="292608"/>
           </a:xfrm>
           <a:prstGeom prst="rect">
             <a:avLst/>
@@ -6498,13 +6759,13 @@
               </a:spcAft>
             </a:pPr>
             <a:r>
-              <a:rPr sz="1200" b="0">
+              <a:rPr sz="950" b="0">
                 <a:solidFill>
                   <a:srgbClr val="8D8779"/>
                 </a:solidFill>
-                <a:latin typeface="微软雅黑"/>
-              </a:rPr>
-              <a:t>曲线仍在上升，重新生成可刷新数值。</a:t>
+                <a:latin typeface="Consolas"/>
+              </a:rPr>
+              <a:t>03_experiments/exp4_representation/</a:t>
             </a:r>
           </a:p>
         </p:txBody>
@@ -6517,8 +6778,8 @@
         </p:nvSpPr>
         <p:spPr>
           <a:xfrm>
-            <a:off x="777240" y="6291072"/>
-            <a:ext cx="9539935" cy="292608"/>
+            <a:off x="10317175" y="6291072"/>
+            <a:ext cx="1097280" cy="292608"/>
           </a:xfrm>
           <a:prstGeom prst="rect">
             <a:avLst/>
@@ -6531,7 +6792,7 @@
           </a:bodyPr>
           <a:lstStyle/>
           <a:p>
-            <a:pPr algn="l">
+            <a:pPr algn="r">
               <a:lnSpc>
                 <a:spcPct val="145000"/>
               </a:lnSpc>
@@ -6546,49 +6807,7 @@
                 </a:solidFill>
                 <a:latin typeface="Consolas"/>
               </a:rPr>
-              <a:t>05_dreamerv3_scale/</a:t>
-            </a:r>
-          </a:p>
-        </p:txBody>
-      </p:sp>
-      <p:sp>
-        <p:nvSpPr>
-          <p:cNvPr id="8" name="TextBox 7"/>
-          <p:cNvSpPr txBox="1"/>
-          <p:nvPr/>
-        </p:nvSpPr>
-        <p:spPr>
-          <a:xfrm>
-            <a:off x="10317175" y="6291072"/>
-            <a:ext cx="1097280" cy="292608"/>
-          </a:xfrm>
-          <a:prstGeom prst="rect">
-            <a:avLst/>
-          </a:prstGeom>
-          <a:noFill/>
-        </p:spPr>
-        <p:txBody>
-          <a:bodyPr wrap="square" anchor="t">
-            <a:spAutoFit/>
-          </a:bodyPr>
-          <a:lstStyle/>
-          <a:p>
-            <a:pPr algn="r">
-              <a:lnSpc>
-                <a:spcPct val="145000"/>
-              </a:lnSpc>
-              <a:spcAft>
-                <a:spcPts val="600"/>
-              </a:spcAft>
-            </a:pPr>
-            <a:r>
-              <a:rPr sz="950" b="0">
-                <a:solidFill>
-                  <a:srgbClr val="8D8779"/>
-                </a:solidFill>
-                <a:latin typeface="Consolas"/>
-              </a:rPr>
-              <a:t>13 / 15</a:t>
+              <a:t>13 / 17</a:t>
             </a:r>
           </a:p>
         </p:txBody>
@@ -6656,21 +6875,45 @@
                 </a:solidFill>
                 <a:latin typeface="微软雅黑"/>
               </a:rPr>
-              <a:t>真正花掉时间的地方</a:t>
-            </a:r>
-          </a:p>
-        </p:txBody>
-      </p:sp>
-      <p:sp>
-        <p:nvSpPr>
-          <p:cNvPr id="3" name="TextBox 2"/>
+              <a:t>于是：前三组实验测的是同一个变量</a:t>
+            </a:r>
+          </a:p>
+        </p:txBody>
+      </p:sp>
+      <p:pic>
+        <p:nvPicPr>
+          <p:cNvPr id="3" name="Picture 2" descr="exp4_confound.png"/>
+          <p:cNvPicPr>
+            <a:picLocks noChangeAspect="1"/>
+          </p:cNvPicPr>
+          <p:nvPr/>
+        </p:nvPicPr>
+        <p:blipFill>
+          <a:blip r:embed="rId2"/>
+          <a:stretch>
+            <a:fillRect/>
+          </a:stretch>
+        </p:blipFill>
+        <p:spPr>
+          <a:xfrm>
+            <a:off x="2839815" y="1325880"/>
+            <a:ext cx="6512065" cy="2651760"/>
+          </a:xfrm>
+          <a:prstGeom prst="rect">
+            <a:avLst/>
+          </a:prstGeom>
+        </p:spPr>
+      </p:pic>
+      <p:sp>
+        <p:nvSpPr>
+          <p:cNvPr id="4" name="TextBox 3"/>
           <p:cNvSpPr txBox="1"/>
           <p:nvPr/>
         </p:nvSpPr>
         <p:spPr>
           <a:xfrm>
-            <a:off x="777240" y="1554480"/>
-            <a:ext cx="10637215" cy="3474720"/>
+            <a:off x="777240" y="4206240"/>
+            <a:ext cx="10637215" cy="2194560"/>
           </a:xfrm>
           <a:prstGeom prst="rect">
             <a:avLst/>
@@ -6688,17 +6931,17 @@
                 <a:spcPct val="145000"/>
               </a:lnSpc>
               <a:spcAft>
-                <a:spcPts val="300"/>
-              </a:spcAft>
-            </a:pPr>
-            <a:r>
-              <a:rPr sz="1400" b="1">
-                <a:solidFill>
-                  <a:srgbClr val="17150F"/>
+                <a:spcPts val="700"/>
+              </a:spcAft>
+            </a:pPr>
+            <a:r>
+              <a:rPr sz="1300" b="0">
+                <a:solidFill>
+                  <a:srgbClr val="4A463B"/>
                 </a:solidFill>
                 <a:latin typeface="微软雅黑"/>
               </a:rPr>
-              <a:t>把 torch 软链进别人的 venv 复用。</a:t>
+              <a:t>实验一的成功率排序（52 / 54 / 64）与它们的尺度排序（0.319 / 0.348 / 0.389）完全一致；实验三成功率的倒 U（34 / 52 / 38）与尺度的倒 U（0.0012 / 0.319 / 0.116）同形。三个不同的旋钮，落到同一个中介变量上。</a:t>
             </a:r>
           </a:p>
           <a:p>
@@ -6707,17 +6950,17 @@
                 <a:spcPct val="145000"/>
               </a:lnSpc>
               <a:spcAft>
-                <a:spcPts val="1400"/>
-              </a:spcAft>
-            </a:pPr>
-            <a:r>
-              <a:rPr sz="1250" b="0">
-                <a:solidFill>
-                  <a:srgbClr val="4A463B"/>
+                <a:spcPts val="900"/>
+              </a:spcAft>
+            </a:pPr>
+            <a:r>
+              <a:rPr sz="1350" b="1">
+                <a:solidFill>
+                  <a:srgbClr val="C8402E"/>
                 </a:solidFill>
                 <a:latin typeface="微软雅黑"/>
               </a:rPr>
-              <a:t>uv 在处理一个没锁版本的 torch&gt;=2 时顺着软链写穿了，悄悄把另一个项目的 torch 从 2.7 升到 2.14，而那个项目当时还有个跑了一天的进程在跑。</a:t>
+              <a:t>加 seed 救不了这些实验——45 个 seed 只会得到一个混杂量的精确估计。问题不在功效，在设计。</a:t>
             </a:r>
           </a:p>
           <a:p>
@@ -6726,88 +6969,31 @@
                 <a:spcPct val="145000"/>
               </a:lnSpc>
               <a:spcAft>
-                <a:spcPts val="300"/>
-              </a:spcAft>
-            </a:pPr>
-            <a:r>
-              <a:rPr sz="1400" b="1">
-                <a:solidFill>
-                  <a:srgbClr val="17150F"/>
+                <a:spcPts val="600"/>
+              </a:spcAft>
+            </a:pPr>
+            <a:r>
+              <a:rPr sz="1200" b="0">
+                <a:solidFill>
+                  <a:srgbClr val="8D8779"/>
                 </a:solidFill>
                 <a:latin typeface="微软雅黑"/>
               </a:rPr>
-              <a:t>embed_dim 不是自由超参数。</a:t>
-            </a:r>
-          </a:p>
-          <a:p>
-            <a:pPr>
-              <a:lnSpc>
-                <a:spcPct val="145000"/>
-              </a:lnSpc>
-              <a:spcAft>
-                <a:spcPts val="1400"/>
-              </a:spcAft>
-            </a:pPr>
-            <a:r>
-              <a:rPr sz="1250" b="0">
-                <a:solidFill>
-                  <a:srgbClr val="4A463B"/>
-                </a:solidFill>
-                <a:latin typeface="微软雅黑"/>
-              </a:rPr>
-              <a:t>projector 的输入宽度取自它，而 ViT-tiny 的宽度固定在 192。我原计划的第一个消融直接崩在矩阵维度上——要正经扫它必须同步缩放骨干网络，那就不再是单变量消融了。</a:t>
-            </a:r>
-          </a:p>
-          <a:p>
-            <a:pPr>
-              <a:lnSpc>
-                <a:spcPct val="145000"/>
-              </a:lnSpc>
-              <a:spcAft>
-                <a:spcPts val="300"/>
-              </a:spcAft>
-            </a:pPr>
-            <a:r>
-              <a:rPr sz="1400" b="1">
-                <a:solidFill>
-                  <a:srgbClr val="17150F"/>
-                </a:solidFill>
-                <a:latin typeface="微软雅黑"/>
-              </a:rPr>
-              <a:t>stdout 缓冲藏了两小时进度。</a:t>
-            </a:r>
-          </a:p>
-          <a:p>
-            <a:pPr>
-              <a:lnSpc>
-                <a:spcPct val="145000"/>
-              </a:lnSpc>
-              <a:spcAft>
-                <a:spcPts val="1400"/>
-              </a:spcAft>
-            </a:pPr>
-            <a:r>
-              <a:rPr sz="1250" b="0">
-                <a:solidFill>
-                  <a:srgbClr val="4A463B"/>
-                </a:solidFill>
-                <a:latin typeface="微软雅黑"/>
-              </a:rPr>
-              <a:t>终端日志卡在 45000 步一个多小时，而显式落盘的 metrics.jsonl 早就过了 80000 步。</a:t>
-            </a:r>
-          </a:p>
-        </p:txBody>
-      </p:sp>
-      <p:sp>
-        <p:nvSpPr>
-          <p:cNvPr id="4" name="TextBox 3"/>
+              <a:t>顺带的收获（右图）：整个 1000 倍权重扫描里，SIGReg 的高斯性统计量是 1206 / 1206 / 1206，纹丝不动，而真高斯是 0.5、4 维线性流形是 170。它实际维持的是 embedding 尺度，不是高斯化——论文命名的机制和实际生效的机制不是一回事。</a:t>
+            </a:r>
+          </a:p>
+        </p:txBody>
+      </p:sp>
+      <p:sp>
+        <p:nvSpPr>
+          <p:cNvPr id="5" name="TextBox 4"/>
           <p:cNvSpPr txBox="1"/>
           <p:nvPr/>
         </p:nvSpPr>
         <p:spPr>
           <a:xfrm>
-            <a:off x="777240" y="5394960"/>
-            <a:ext cx="10637215" cy="548640"/>
+            <a:off x="777240" y="6291072"/>
+            <a:ext cx="9539935" cy="292608"/>
           </a:xfrm>
           <a:prstGeom prst="rect">
             <a:avLst/>
@@ -6829,27 +7015,27 @@
               </a:spcAft>
             </a:pPr>
             <a:r>
-              <a:rPr sz="1200" b="0">
+              <a:rPr sz="950" b="0">
                 <a:solidFill>
                   <a:srgbClr val="8D8779"/>
                 </a:solidFill>
-                <a:latin typeface="微软雅黑"/>
-              </a:rPr>
-              <a:t>完整记录在仓库的 engineering log 里。写下来是因为——出问题的地方，恰恰是没人愿意写下来的地方。</a:t>
-            </a:r>
-          </a:p>
-        </p:txBody>
-      </p:sp>
-      <p:sp>
-        <p:nvSpPr>
-          <p:cNvPr id="5" name="TextBox 4"/>
+                <a:latin typeface="Consolas"/>
+              </a:rPr>
+              <a:t>03_experiments/exp4_representation/</a:t>
+            </a:r>
+          </a:p>
+        </p:txBody>
+      </p:sp>
+      <p:sp>
+        <p:nvSpPr>
+          <p:cNvPr id="6" name="TextBox 5"/>
           <p:cNvSpPr txBox="1"/>
           <p:nvPr/>
         </p:nvSpPr>
         <p:spPr>
           <a:xfrm>
-            <a:off x="777240" y="6291072"/>
-            <a:ext cx="9539935" cy="292608"/>
+            <a:off x="10317175" y="6291072"/>
+            <a:ext cx="1097280" cy="292608"/>
           </a:xfrm>
           <a:prstGeom prst="rect">
             <a:avLst/>
@@ -6862,7 +7048,7 @@
           </a:bodyPr>
           <a:lstStyle/>
           <a:p>
-            <a:pPr algn="l">
+            <a:pPr algn="r">
               <a:lnSpc>
                 <a:spcPct val="145000"/>
               </a:lnSpc>
@@ -6877,49 +7063,7 @@
                 </a:solidFill>
                 <a:latin typeface="Consolas"/>
               </a:rPr>
-              <a:t>notes/engineering_log.md</a:t>
-            </a:r>
-          </a:p>
-        </p:txBody>
-      </p:sp>
-      <p:sp>
-        <p:nvSpPr>
-          <p:cNvPr id="6" name="TextBox 5"/>
-          <p:cNvSpPr txBox="1"/>
-          <p:nvPr/>
-        </p:nvSpPr>
-        <p:spPr>
-          <a:xfrm>
-            <a:off x="10317175" y="6291072"/>
-            <a:ext cx="1097280" cy="292608"/>
-          </a:xfrm>
-          <a:prstGeom prst="rect">
-            <a:avLst/>
-          </a:prstGeom>
-          <a:noFill/>
-        </p:spPr>
-        <p:txBody>
-          <a:bodyPr wrap="square" anchor="t">
-            <a:spAutoFit/>
-          </a:bodyPr>
-          <a:lstStyle/>
-          <a:p>
-            <a:pPr algn="r">
-              <a:lnSpc>
-                <a:spcPct val="145000"/>
-              </a:lnSpc>
-              <a:spcAft>
-                <a:spcPts val="600"/>
-              </a:spcAft>
-            </a:pPr>
-            <a:r>
-              <a:rPr sz="950" b="0">
-                <a:solidFill>
-                  <a:srgbClr val="8D8779"/>
-                </a:solidFill>
-                <a:latin typeface="Consolas"/>
-              </a:rPr>
-              <a:t>14 / 15</a:t>
+              <a:t>14 / 17</a:t>
             </a:r>
           </a:p>
         </p:txBody>
@@ -6987,6 +7131,658 @@
                 </a:solidFill>
                 <a:latin typeface="微软雅黑"/>
               </a:rPr>
+              <a:t>规模验证 —— DreamerV3 在 DMC walker-walk</a:t>
+            </a:r>
+          </a:p>
+        </p:txBody>
+      </p:sp>
+      <p:sp>
+        <p:nvSpPr>
+          <p:cNvPr id="3" name="TextBox 2"/>
+          <p:cNvSpPr txBox="1"/>
+          <p:nvPr/>
+        </p:nvSpPr>
+        <p:spPr>
+          <a:xfrm>
+            <a:off x="777240" y="1325880"/>
+            <a:ext cx="10637215" cy="457200"/>
+          </a:xfrm>
+          <a:prstGeom prst="rect">
+            <a:avLst/>
+          </a:prstGeom>
+          <a:noFill/>
+        </p:spPr>
+        <p:txBody>
+          <a:bodyPr wrap="square" anchor="t">
+            <a:spAutoFit/>
+          </a:bodyPr>
+          <a:lstStyle/>
+          <a:p>
+            <a:pPr algn="l">
+              <a:lnSpc>
+                <a:spcPct val="145000"/>
+              </a:lnSpc>
+              <a:spcAft>
+                <a:spcPts val="600"/>
+              </a:spcAft>
+            </a:pPr>
+            <a:r>
+              <a:rPr sz="1300" b="0">
+                <a:solidFill>
+                  <a:srgbClr val="4A463B"/>
+                </a:solidFill>
+                <a:latin typeface="微软雅黑"/>
+              </a:rPr>
+              <a:t>手写版证明我理解每个组件；这一条是官方实现在真实基准上的完整曲线。</a:t>
+            </a:r>
+          </a:p>
+        </p:txBody>
+      </p:sp>
+      <p:pic>
+        <p:nvPicPr>
+          <p:cNvPr id="4" name="Picture 3" descr="dreamerv3_walker.png"/>
+          <p:cNvPicPr>
+            <a:picLocks noChangeAspect="1"/>
+          </p:cNvPicPr>
+          <p:nvPr/>
+        </p:nvPicPr>
+        <p:blipFill>
+          <a:blip r:embed="rId2"/>
+          <a:stretch>
+            <a:fillRect/>
+          </a:stretch>
+        </p:blipFill>
+        <p:spPr>
+          <a:xfrm>
+            <a:off x="3476606" y="1874519"/>
+            <a:ext cx="5238483" cy="2834640"/>
+          </a:xfrm>
+          <a:prstGeom prst="rect">
+            <a:avLst/>
+          </a:prstGeom>
+        </p:spPr>
+      </p:pic>
+      <p:sp>
+        <p:nvSpPr>
+          <p:cNvPr id="5" name="TextBox 4"/>
+          <p:cNvSpPr txBox="1"/>
+          <p:nvPr/>
+        </p:nvSpPr>
+        <p:spPr>
+          <a:xfrm>
+            <a:off x="777240" y="4937760"/>
+            <a:ext cx="3108960" cy="1097280"/>
+          </a:xfrm>
+          <a:prstGeom prst="rect">
+            <a:avLst/>
+          </a:prstGeom>
+          <a:noFill/>
+        </p:spPr>
+        <p:txBody>
+          <a:bodyPr wrap="square" anchor="t">
+            <a:spAutoFit/>
+          </a:bodyPr>
+          <a:lstStyle/>
+          <a:p>
+            <a:pPr algn="l">
+              <a:lnSpc>
+                <a:spcPct val="100000"/>
+              </a:lnSpc>
+              <a:spcAft>
+                <a:spcPts val="200"/>
+              </a:spcAft>
+            </a:pPr>
+            <a:r>
+              <a:rPr sz="3400" b="1">
+                <a:solidFill>
+                  <a:srgbClr val="17150F"/>
+                </a:solidFill>
+                <a:latin typeface="Consolas"/>
+              </a:rPr>
+              <a:t>963</a:t>
+            </a:r>
+          </a:p>
+          <a:p>
+            <a:pPr>
+              <a:lnSpc>
+                <a:spcPct val="130000"/>
+              </a:lnSpc>
+              <a:spcAft>
+                <a:spcPts val="0"/>
+              </a:spcAft>
+            </a:pPr>
+            <a:r>
+              <a:rPr sz="1100" b="0">
+                <a:solidFill>
+                  <a:srgbClr val="8D8779"/>
+                </a:solidFill>
+                <a:latin typeface="微软雅黑"/>
+              </a:rPr>
+              <a:t>685k 步时的评估回报（满分约 1000）</a:t>
+            </a:r>
+          </a:p>
+        </p:txBody>
+      </p:sp>
+      <p:sp>
+        <p:nvSpPr>
+          <p:cNvPr id="6" name="TextBox 5"/>
+          <p:cNvSpPr txBox="1"/>
+          <p:nvPr/>
+        </p:nvSpPr>
+        <p:spPr>
+          <a:xfrm>
+            <a:off x="4069080" y="5029200"/>
+            <a:ext cx="7315200" cy="822960"/>
+          </a:xfrm>
+          <a:prstGeom prst="rect">
+            <a:avLst/>
+          </a:prstGeom>
+          <a:noFill/>
+        </p:spPr>
+        <p:txBody>
+          <a:bodyPr wrap="square" anchor="t">
+            <a:spAutoFit/>
+          </a:bodyPr>
+          <a:lstStyle/>
+          <a:p>
+            <a:pPr algn="l">
+              <a:lnSpc>
+                <a:spcPct val="145000"/>
+              </a:lnSpc>
+              <a:spcAft>
+                <a:spcPts val="600"/>
+              </a:spcAft>
+            </a:pPr>
+            <a:r>
+              <a:rPr sz="1200" b="0">
+                <a:solidFill>
+                  <a:srgbClr val="8D8779"/>
+                </a:solidFill>
+                <a:latin typeface="微软雅黑"/>
+              </a:rPr>
+              <a:t>约 30 万步起进入平台期，稳定在满分（约 1000）附近，训练继续跑向 1M。</a:t>
+            </a:r>
+          </a:p>
+        </p:txBody>
+      </p:sp>
+      <p:sp>
+        <p:nvSpPr>
+          <p:cNvPr id="7" name="TextBox 6"/>
+          <p:cNvSpPr txBox="1"/>
+          <p:nvPr/>
+        </p:nvSpPr>
+        <p:spPr>
+          <a:xfrm>
+            <a:off x="777240" y="6291072"/>
+            <a:ext cx="9539935" cy="292608"/>
+          </a:xfrm>
+          <a:prstGeom prst="rect">
+            <a:avLst/>
+          </a:prstGeom>
+          <a:noFill/>
+        </p:spPr>
+        <p:txBody>
+          <a:bodyPr wrap="square" anchor="t">
+            <a:spAutoFit/>
+          </a:bodyPr>
+          <a:lstStyle/>
+          <a:p>
+            <a:pPr algn="l">
+              <a:lnSpc>
+                <a:spcPct val="145000"/>
+              </a:lnSpc>
+              <a:spcAft>
+                <a:spcPts val="600"/>
+              </a:spcAft>
+            </a:pPr>
+            <a:r>
+              <a:rPr sz="950" b="0">
+                <a:solidFill>
+                  <a:srgbClr val="8D8779"/>
+                </a:solidFill>
+                <a:latin typeface="Consolas"/>
+              </a:rPr>
+              <a:t>05_dreamerv3_scale/</a:t>
+            </a:r>
+          </a:p>
+        </p:txBody>
+      </p:sp>
+      <p:sp>
+        <p:nvSpPr>
+          <p:cNvPr id="8" name="TextBox 7"/>
+          <p:cNvSpPr txBox="1"/>
+          <p:nvPr/>
+        </p:nvSpPr>
+        <p:spPr>
+          <a:xfrm>
+            <a:off x="10317175" y="6291072"/>
+            <a:ext cx="1097280" cy="292608"/>
+          </a:xfrm>
+          <a:prstGeom prst="rect">
+            <a:avLst/>
+          </a:prstGeom>
+          <a:noFill/>
+        </p:spPr>
+        <p:txBody>
+          <a:bodyPr wrap="square" anchor="t">
+            <a:spAutoFit/>
+          </a:bodyPr>
+          <a:lstStyle/>
+          <a:p>
+            <a:pPr algn="r">
+              <a:lnSpc>
+                <a:spcPct val="145000"/>
+              </a:lnSpc>
+              <a:spcAft>
+                <a:spcPts val="600"/>
+              </a:spcAft>
+            </a:pPr>
+            <a:r>
+              <a:rPr sz="950" b="0">
+                <a:solidFill>
+                  <a:srgbClr val="8D8779"/>
+                </a:solidFill>
+                <a:latin typeface="Consolas"/>
+              </a:rPr>
+              <a:t>15 / 17</a:t>
+            </a:r>
+          </a:p>
+        </p:txBody>
+      </p:sp>
+    </p:spTree>
+  </p:cSld>
+  <p:clrMapOvr>
+    <a:masterClrMapping/>
+  </p:clrMapOvr>
+</p:sld>
+</file>
+
+<file path=ppt/slides/slide16.xml><?xml version="1.0" encoding="utf-8"?>
+<p:sld xmlns:a="http://schemas.openxmlformats.org/drawingml/2006/main" xmlns:p="http://schemas.openxmlformats.org/presentationml/2006/main" xmlns:r="http://schemas.openxmlformats.org/officeDocument/2006/relationships">
+  <p:cSld>
+    <p:bg>
+      <p:bgPr>
+        <a:solidFill>
+          <a:srgbClr val="FAF9F5"/>
+        </a:solidFill>
+        <a:effectLst/>
+      </p:bgPr>
+    </p:bg>
+    <p:spTree>
+      <p:nvGrpSpPr>
+        <p:cNvPr id="1" name=""/>
+        <p:cNvGrpSpPr/>
+        <p:nvPr/>
+      </p:nvGrpSpPr>
+      <p:grpSpPr/>
+      <p:sp>
+        <p:nvSpPr>
+          <p:cNvPr id="2" name="TextBox 1"/>
+          <p:cNvSpPr txBox="1"/>
+          <p:nvPr/>
+        </p:nvSpPr>
+        <p:spPr>
+          <a:xfrm>
+            <a:off x="777240" y="566928"/>
+            <a:ext cx="10637215" cy="822960"/>
+          </a:xfrm>
+          <a:prstGeom prst="rect">
+            <a:avLst/>
+          </a:prstGeom>
+          <a:noFill/>
+        </p:spPr>
+        <p:txBody>
+          <a:bodyPr wrap="square" anchor="t">
+            <a:spAutoFit/>
+          </a:bodyPr>
+          <a:lstStyle/>
+          <a:p>
+            <a:pPr algn="l">
+              <a:lnSpc>
+                <a:spcPct val="120000"/>
+              </a:lnSpc>
+              <a:spcAft>
+                <a:spcPts val="600"/>
+              </a:spcAft>
+            </a:pPr>
+            <a:r>
+              <a:rPr sz="3000" b="1">
+                <a:solidFill>
+                  <a:srgbClr val="17150F"/>
+                </a:solidFill>
+                <a:latin typeface="微软雅黑"/>
+              </a:rPr>
+              <a:t>真正花掉时间的地方</a:t>
+            </a:r>
+          </a:p>
+        </p:txBody>
+      </p:sp>
+      <p:sp>
+        <p:nvSpPr>
+          <p:cNvPr id="3" name="TextBox 2"/>
+          <p:cNvSpPr txBox="1"/>
+          <p:nvPr/>
+        </p:nvSpPr>
+        <p:spPr>
+          <a:xfrm>
+            <a:off x="777240" y="1554480"/>
+            <a:ext cx="10637215" cy="3474720"/>
+          </a:xfrm>
+          <a:prstGeom prst="rect">
+            <a:avLst/>
+          </a:prstGeom>
+          <a:noFill/>
+        </p:spPr>
+        <p:txBody>
+          <a:bodyPr wrap="square" anchor="t">
+            <a:spAutoFit/>
+          </a:bodyPr>
+          <a:lstStyle/>
+          <a:p>
+            <a:pPr algn="l">
+              <a:lnSpc>
+                <a:spcPct val="145000"/>
+              </a:lnSpc>
+              <a:spcAft>
+                <a:spcPts val="300"/>
+              </a:spcAft>
+            </a:pPr>
+            <a:r>
+              <a:rPr sz="1400" b="1">
+                <a:solidFill>
+                  <a:srgbClr val="17150F"/>
+                </a:solidFill>
+                <a:latin typeface="微软雅黑"/>
+              </a:rPr>
+              <a:t>把 torch 软链进别人的 venv 复用。</a:t>
+            </a:r>
+          </a:p>
+          <a:p>
+            <a:pPr>
+              <a:lnSpc>
+                <a:spcPct val="145000"/>
+              </a:lnSpc>
+              <a:spcAft>
+                <a:spcPts val="1400"/>
+              </a:spcAft>
+            </a:pPr>
+            <a:r>
+              <a:rPr sz="1250" b="0">
+                <a:solidFill>
+                  <a:srgbClr val="4A463B"/>
+                </a:solidFill>
+                <a:latin typeface="微软雅黑"/>
+              </a:rPr>
+              <a:t>uv 在处理一个没锁版本的 torch&gt;=2 时顺着软链写穿了，悄悄把另一个项目的 torch 从 2.7 升到 2.14，而那个项目当时还有个跑了一天的进程在跑。</a:t>
+            </a:r>
+          </a:p>
+          <a:p>
+            <a:pPr>
+              <a:lnSpc>
+                <a:spcPct val="145000"/>
+              </a:lnSpc>
+              <a:spcAft>
+                <a:spcPts val="300"/>
+              </a:spcAft>
+            </a:pPr>
+            <a:r>
+              <a:rPr sz="1400" b="1">
+                <a:solidFill>
+                  <a:srgbClr val="17150F"/>
+                </a:solidFill>
+                <a:latin typeface="微软雅黑"/>
+              </a:rPr>
+              <a:t>embed_dim 不是自由超参数。</a:t>
+            </a:r>
+          </a:p>
+          <a:p>
+            <a:pPr>
+              <a:lnSpc>
+                <a:spcPct val="145000"/>
+              </a:lnSpc>
+              <a:spcAft>
+                <a:spcPts val="1400"/>
+              </a:spcAft>
+            </a:pPr>
+            <a:r>
+              <a:rPr sz="1250" b="0">
+                <a:solidFill>
+                  <a:srgbClr val="4A463B"/>
+                </a:solidFill>
+                <a:latin typeface="微软雅黑"/>
+              </a:rPr>
+              <a:t>projector 的输入宽度取自它，而 ViT-tiny 的宽度固定在 192。我原计划的第一个消融直接崩在矩阵维度上——要正经扫它必须同步缩放骨干网络，那就不再是单变量消融了。</a:t>
+            </a:r>
+          </a:p>
+          <a:p>
+            <a:pPr>
+              <a:lnSpc>
+                <a:spcPct val="145000"/>
+              </a:lnSpc>
+              <a:spcAft>
+                <a:spcPts val="300"/>
+              </a:spcAft>
+            </a:pPr>
+            <a:r>
+              <a:rPr sz="1400" b="1">
+                <a:solidFill>
+                  <a:srgbClr val="17150F"/>
+                </a:solidFill>
+                <a:latin typeface="微软雅黑"/>
+              </a:rPr>
+              <a:t>stdout 缓冲藏了两小时进度。</a:t>
+            </a:r>
+          </a:p>
+          <a:p>
+            <a:pPr>
+              <a:lnSpc>
+                <a:spcPct val="145000"/>
+              </a:lnSpc>
+              <a:spcAft>
+                <a:spcPts val="1400"/>
+              </a:spcAft>
+            </a:pPr>
+            <a:r>
+              <a:rPr sz="1250" b="0">
+                <a:solidFill>
+                  <a:srgbClr val="4A463B"/>
+                </a:solidFill>
+                <a:latin typeface="微软雅黑"/>
+              </a:rPr>
+              <a:t>终端日志卡在 45000 步一个多小时，而显式落盘的 metrics.jsonl 早就过了 80000 步。</a:t>
+            </a:r>
+          </a:p>
+        </p:txBody>
+      </p:sp>
+      <p:sp>
+        <p:nvSpPr>
+          <p:cNvPr id="4" name="TextBox 3"/>
+          <p:cNvSpPr txBox="1"/>
+          <p:nvPr/>
+        </p:nvSpPr>
+        <p:spPr>
+          <a:xfrm>
+            <a:off x="777240" y="5394960"/>
+            <a:ext cx="10637215" cy="548640"/>
+          </a:xfrm>
+          <a:prstGeom prst="rect">
+            <a:avLst/>
+          </a:prstGeom>
+          <a:noFill/>
+        </p:spPr>
+        <p:txBody>
+          <a:bodyPr wrap="square" anchor="t">
+            <a:spAutoFit/>
+          </a:bodyPr>
+          <a:lstStyle/>
+          <a:p>
+            <a:pPr algn="l">
+              <a:lnSpc>
+                <a:spcPct val="145000"/>
+              </a:lnSpc>
+              <a:spcAft>
+                <a:spcPts val="600"/>
+              </a:spcAft>
+            </a:pPr>
+            <a:r>
+              <a:rPr sz="1200" b="0">
+                <a:solidFill>
+                  <a:srgbClr val="8D8779"/>
+                </a:solidFill>
+                <a:latin typeface="微软雅黑"/>
+              </a:rPr>
+              <a:t>完整记录在仓库的 engineering log 里。写下来是因为——出问题的地方，恰恰是没人愿意写下来的地方。</a:t>
+            </a:r>
+          </a:p>
+        </p:txBody>
+      </p:sp>
+      <p:sp>
+        <p:nvSpPr>
+          <p:cNvPr id="5" name="TextBox 4"/>
+          <p:cNvSpPr txBox="1"/>
+          <p:nvPr/>
+        </p:nvSpPr>
+        <p:spPr>
+          <a:xfrm>
+            <a:off x="777240" y="6291072"/>
+            <a:ext cx="9539935" cy="292608"/>
+          </a:xfrm>
+          <a:prstGeom prst="rect">
+            <a:avLst/>
+          </a:prstGeom>
+          <a:noFill/>
+        </p:spPr>
+        <p:txBody>
+          <a:bodyPr wrap="square" anchor="t">
+            <a:spAutoFit/>
+          </a:bodyPr>
+          <a:lstStyle/>
+          <a:p>
+            <a:pPr algn="l">
+              <a:lnSpc>
+                <a:spcPct val="145000"/>
+              </a:lnSpc>
+              <a:spcAft>
+                <a:spcPts val="600"/>
+              </a:spcAft>
+            </a:pPr>
+            <a:r>
+              <a:rPr sz="950" b="0">
+                <a:solidFill>
+                  <a:srgbClr val="8D8779"/>
+                </a:solidFill>
+                <a:latin typeface="Consolas"/>
+              </a:rPr>
+              <a:t>notes/engineering_log.md</a:t>
+            </a:r>
+          </a:p>
+        </p:txBody>
+      </p:sp>
+      <p:sp>
+        <p:nvSpPr>
+          <p:cNvPr id="6" name="TextBox 5"/>
+          <p:cNvSpPr txBox="1"/>
+          <p:nvPr/>
+        </p:nvSpPr>
+        <p:spPr>
+          <a:xfrm>
+            <a:off x="10317175" y="6291072"/>
+            <a:ext cx="1097280" cy="292608"/>
+          </a:xfrm>
+          <a:prstGeom prst="rect">
+            <a:avLst/>
+          </a:prstGeom>
+          <a:noFill/>
+        </p:spPr>
+        <p:txBody>
+          <a:bodyPr wrap="square" anchor="t">
+            <a:spAutoFit/>
+          </a:bodyPr>
+          <a:lstStyle/>
+          <a:p>
+            <a:pPr algn="r">
+              <a:lnSpc>
+                <a:spcPct val="145000"/>
+              </a:lnSpc>
+              <a:spcAft>
+                <a:spcPts val="600"/>
+              </a:spcAft>
+            </a:pPr>
+            <a:r>
+              <a:rPr sz="950" b="0">
+                <a:solidFill>
+                  <a:srgbClr val="8D8779"/>
+                </a:solidFill>
+                <a:latin typeface="Consolas"/>
+              </a:rPr>
+              <a:t>16 / 17</a:t>
+            </a:r>
+          </a:p>
+        </p:txBody>
+      </p:sp>
+    </p:spTree>
+  </p:cSld>
+  <p:clrMapOvr>
+    <a:masterClrMapping/>
+  </p:clrMapOvr>
+</p:sld>
+</file>
+
+<file path=ppt/slides/slide17.xml><?xml version="1.0" encoding="utf-8"?>
+<p:sld xmlns:a="http://schemas.openxmlformats.org/drawingml/2006/main" xmlns:p="http://schemas.openxmlformats.org/presentationml/2006/main" xmlns:r="http://schemas.openxmlformats.org/officeDocument/2006/relationships">
+  <p:cSld>
+    <p:bg>
+      <p:bgPr>
+        <a:solidFill>
+          <a:srgbClr val="FAF9F5"/>
+        </a:solidFill>
+        <a:effectLst/>
+      </p:bgPr>
+    </p:bg>
+    <p:spTree>
+      <p:nvGrpSpPr>
+        <p:cNvPr id="1" name=""/>
+        <p:cNvGrpSpPr/>
+        <p:nvPr/>
+      </p:nvGrpSpPr>
+      <p:grpSpPr/>
+      <p:sp>
+        <p:nvSpPr>
+          <p:cNvPr id="2" name="TextBox 1"/>
+          <p:cNvSpPr txBox="1"/>
+          <p:nvPr/>
+        </p:nvSpPr>
+        <p:spPr>
+          <a:xfrm>
+            <a:off x="777240" y="566928"/>
+            <a:ext cx="10637215" cy="822960"/>
+          </a:xfrm>
+          <a:prstGeom prst="rect">
+            <a:avLst/>
+          </a:prstGeom>
+          <a:noFill/>
+        </p:spPr>
+        <p:txBody>
+          <a:bodyPr wrap="square" anchor="t">
+            <a:spAutoFit/>
+          </a:bodyPr>
+          <a:lstStyle/>
+          <a:p>
+            <a:pPr algn="l">
+              <a:lnSpc>
+                <a:spcPct val="120000"/>
+              </a:lnSpc>
+              <a:spcAft>
+                <a:spcPts val="600"/>
+              </a:spcAft>
+            </a:pPr>
+            <a:r>
+              <a:rPr sz="3000" b="1">
+                <a:solidFill>
+                  <a:srgbClr val="17150F"/>
+                </a:solidFill>
+                <a:latin typeface="微软雅黑"/>
+              </a:rPr>
               <a:t>什么站得住，什么站不住</a:t>
             </a:r>
           </a:p>
@@ -7000,8 +7796,8 @@
         </p:nvSpPr>
         <p:spPr>
           <a:xfrm>
-            <a:off x="777240" y="1463040"/>
-            <a:ext cx="5158587" cy="2651760"/>
+            <a:off x="777240" y="1417320"/>
+            <a:ext cx="5158587" cy="3200400"/>
           </a:xfrm>
           <a:prstGeom prst="roundRect">
             <a:avLst>
@@ -7048,8 +7844,8 @@
         </p:nvSpPr>
         <p:spPr>
           <a:xfrm>
-            <a:off x="1051560" y="1691640"/>
-            <a:ext cx="4609947" cy="2194560"/>
+            <a:off x="1051560" y="1645920"/>
+            <a:ext cx="4609947" cy="2743200"/>
           </a:xfrm>
           <a:prstGeom prst="rect">
             <a:avLst/>
@@ -7077,7 +7873,7 @@
                 </a:solidFill>
                 <a:latin typeface="微软雅黑"/>
               </a:rPr>
-              <a:t>站得住</a:t>
+              <a:t>站得住（都是直接测量）</a:t>
             </a:r>
           </a:p>
           <a:p>
@@ -7086,17 +7882,17 @@
                 <a:spcPct val="145000"/>
               </a:lnSpc>
               <a:spcAft>
-                <a:spcPts val="900"/>
-              </a:spcAft>
-            </a:pPr>
-            <a:r>
-              <a:rPr sz="1250" b="0">
+                <a:spcPts val="800"/>
+              </a:spcAft>
+            </a:pPr>
+            <a:r>
+              <a:rPr sz="1200" b="0">
                 <a:solidFill>
                   <a:srgbClr val="4A463B"/>
                 </a:solidFill>
                 <a:latin typeface="微软雅黑"/>
               </a:rPr>
-              <a:t>塌缩本身：embedding 标准差 0.0012 对 0.325，差 270 倍；死维度 69 对 0。这是直接测量，不是统计推断，没有噪声解释空间。</a:t>
+              <a:t>塌缩本身：embedding 标准差 0.0012 对 0.325，差 270 倍；死维度 69 对 0。没有噪声解释空间。</a:t>
             </a:r>
           </a:p>
           <a:p>
@@ -7105,17 +7901,36 @@
                 <a:spcPct val="145000"/>
               </a:lnSpc>
               <a:spcAft>
-                <a:spcPts val="900"/>
-              </a:spcAft>
-            </a:pPr>
-            <a:r>
-              <a:rPr sz="1250" b="0">
+                <a:spcPts val="800"/>
+              </a:spcAft>
+            </a:pPr>
+            <a:r>
+              <a:rPr sz="1200" b="0">
                 <a:solidFill>
                   <a:srgbClr val="4A463B"/>
                 </a:solidFill>
                 <a:latin typeface="微软雅黑"/>
               </a:rPr>
-              <a:t>官方 checkpoint 的 86%，对比我 900 步训练的所有模型（p&lt;0.001，唯一显著的一组）。</a:t>
+              <a:t>尺度与规划成功率的相关：r = 0.89，t = 5.85，n = 11。</a:t>
+            </a:r>
+          </a:p>
+          <a:p>
+            <a:pPr>
+              <a:lnSpc>
+                <a:spcPct val="145000"/>
+              </a:lnSpc>
+              <a:spcAft>
+                <a:spcPts val="800"/>
+              </a:spcAft>
+            </a:pPr>
+            <a:r>
+              <a:rPr sz="1200" b="0">
+                <a:solidFill>
+                  <a:srgbClr val="4A463B"/>
+                </a:solidFill>
+                <a:latin typeface="微软雅黑"/>
+              </a:rPr>
+              <a:t>SIGReg 的高斯性统计量在 1000 倍权重扫描下完全不动（1206 / 1206 / 1206）。</a:t>
             </a:r>
           </a:p>
         </p:txBody>
@@ -7128,8 +7943,8 @@
         </p:nvSpPr>
         <p:spPr>
           <a:xfrm>
-            <a:off x="6255867" y="1463040"/>
-            <a:ext cx="5158587" cy="2651760"/>
+            <a:off x="6255867" y="1417320"/>
+            <a:ext cx="5158587" cy="3200400"/>
           </a:xfrm>
           <a:prstGeom prst="roundRect">
             <a:avLst>
@@ -7176,8 +7991,8 @@
         </p:nvSpPr>
         <p:spPr>
           <a:xfrm>
-            <a:off x="6530187" y="1691640"/>
-            <a:ext cx="4609947" cy="2194560"/>
+            <a:off x="6530187" y="1645920"/>
+            <a:ext cx="4609947" cy="2743200"/>
           </a:xfrm>
           <a:prstGeom prst="rect">
             <a:avLst/>
@@ -7214,17 +8029,17 @@
                 <a:spcPct val="145000"/>
               </a:lnSpc>
               <a:spcAft>
-                <a:spcPts val="900"/>
-              </a:spcAft>
-            </a:pPr>
-            <a:r>
-              <a:rPr sz="1250" b="0">
+                <a:spcPts val="800"/>
+              </a:spcAft>
+            </a:pPr>
+            <a:r>
+              <a:rPr sz="1200" b="0">
                 <a:solidFill>
                   <a:srgbClr val="4A463B"/>
                 </a:solidFill>
                 <a:latin typeface="微软雅黑"/>
               </a:rPr>
-              <a:t>六组成功率对比里只有一组显著，经验噪声底约 15 个百分点——包括 SIGReg 那组的 18 个点（p=0.064）。</a:t>
+              <a:t>前三组的成功率结论全部作废——它们测的是同一个混杂变量（embedding 尺度）。</a:t>
             </a:r>
           </a:p>
           <a:p>
@@ -7233,17 +8048,17 @@
                 <a:spcPct val="145000"/>
               </a:lnSpc>
               <a:spcAft>
-                <a:spcPts val="900"/>
-              </a:spcAft>
-            </a:pPr>
-            <a:r>
-              <a:rPr sz="1250" b="0">
+                <a:spcPts val="800"/>
+              </a:spcAft>
+            </a:pPr>
+            <a:r>
+              <a:rPr sz="1200" b="0">
                 <a:solidFill>
                   <a:srgbClr val="4A463B"/>
                 </a:solidFill>
                 <a:latin typeface="微软雅黑"/>
               </a:rPr>
-              <a:t>实验二我直接搞错了：以为在比架构，其实两者是同一个实现。</a:t>
+              <a:t>实验四是观测，不是干预。要证明尺度导致规划成败，得在评估时人为缩放 embedding 看成功率跟不跟着走。这是显然的下一步，我没做。</a:t>
             </a:r>
           </a:p>
           <a:p>
@@ -7252,11 +8067,30 @@
                 <a:spcPct val="145000"/>
               </a:lnSpc>
               <a:spcAft>
-                <a:spcPts val="900"/>
-              </a:spcAft>
-            </a:pPr>
-            <a:r>
-              <a:rPr sz="1250" b="0">
+                <a:spcPts val="800"/>
+              </a:spcAft>
+            </a:pPr>
+            <a:r>
+              <a:rPr sz="1200" b="0">
+                <a:solidFill>
+                  <a:srgbClr val="4A463B"/>
+                </a:solidFill>
+                <a:latin typeface="微软雅黑"/>
+              </a:rPr>
+              <a:t>全部结论都在 900 步的欠训练模型上。官方 checkpoint 尺度只有 0.032 却拿 86%——这条规律在训练充分后就不成立。</a:t>
+            </a:r>
+          </a:p>
+          <a:p>
+            <a:pPr>
+              <a:lnSpc>
+                <a:spcPct val="145000"/>
+              </a:lnSpc>
+              <a:spcAft>
+                <a:spcPts val="800"/>
+              </a:spcAft>
+            </a:pPr>
+            <a:r>
+              <a:rPr sz="1200" b="0">
                 <a:solidFill>
                   <a:srgbClr val="4A463B"/>
                 </a:solidFill>
@@ -7275,7 +8109,7 @@
         </p:nvSpPr>
         <p:spPr>
           <a:xfrm>
-            <a:off x="777240" y="4526280"/>
+            <a:off x="777240" y="4983480"/>
             <a:ext cx="10637215" cy="1280160"/>
           </a:xfrm>
           <a:prstGeom prst="rect">
@@ -7304,7 +8138,7 @@
                 </a:solidFill>
                 <a:latin typeface="微软雅黑"/>
               </a:rPr>
-              <a:t>下一步的优先级被实验二改写了：不是扫更多超参数，而是先把评估规模做够——3–5 个 seed、每次 200 条以上 episode。在那之前，扫什么都分辨不出来。</a:t>
+              <a:t>下一步的优先级被改写了两次：先是从“扫更多超参数”改成“把评估规模做够”，再从那里改成“先搞清楚主指标到底被什么决定”。回头看，第四组应该是第一组。</a:t>
             </a:r>
           </a:p>
         </p:txBody>
@@ -7388,7 +8222,7 @@
                 </a:solidFill>
                 <a:latin typeface="Consolas"/>
               </a:rPr>
-              <a:t>15 / 15</a:t>
+              <a:t>17 / 17</a:t>
             </a:r>
           </a:p>
         </p:txBody>
@@ -7867,7 +8701,7 @@
                 </a:solidFill>
                 <a:latin typeface="Consolas"/>
               </a:rPr>
-              <a:t>2 / 15</a:t>
+              <a:t>2 / 17</a:t>
             </a:r>
           </a:p>
         </p:txBody>
@@ -8319,7 +9153,7 @@
                 </a:solidFill>
                 <a:latin typeface="微软雅黑"/>
               </a:rPr>
-              <a:t>三组受控实验。这才是值得讲的部分。</a:t>
+              <a:t>四组受控实验。第四组推翻了前三组的结论——这才是值得讲的部分。</a:t>
             </a:r>
           </a:p>
         </p:txBody>
@@ -8394,7 +9228,7 @@
                 </a:solidFill>
                 <a:latin typeface="Consolas"/>
               </a:rPr>
-              <a:t>3 / 15</a:t>
+              <a:t>3 / 17</a:t>
             </a:r>
           </a:p>
         </p:txBody>
@@ -8786,7 +9620,7 @@
                 </a:solidFill>
                 <a:latin typeface="Consolas"/>
               </a:rPr>
-              <a:t>4 / 15</a:t>
+              <a:t>4 / 17</a:t>
             </a:r>
           </a:p>
         </p:txBody>
@@ -9046,7 +9880,7 @@
                 </a:solidFill>
                 <a:latin typeface="Consolas"/>
               </a:rPr>
-              <a:t>5 / 15</a:t>
+              <a:t>5 / 17</a:t>
             </a:r>
           </a:p>
         </p:txBody>
@@ -9499,7 +10333,7 @@
                 </a:solidFill>
                 <a:latin typeface="Consolas"/>
               </a:rPr>
-              <a:t>6 / 15</a:t>
+              <a:t>6 / 17</a:t>
             </a:r>
           </a:p>
         </p:txBody>
@@ -9624,7 +10458,7 @@
                 </a:solidFill>
                 <a:latin typeface="微软雅黑"/>
               </a:rPr>
-              <a:t>每组实验只动一个变量。</a:t>
+              <a:t>每组实验只动一个变量——至少我当时是这么以为的。</a:t>
             </a:r>
           </a:p>
         </p:txBody>
@@ -9708,7 +10542,7 @@
                 </a:solidFill>
                 <a:latin typeface="Consolas"/>
               </a:rPr>
-              <a:t>7 / 15</a:t>
+              <a:t>7 / 17</a:t>
             </a:r>
           </a:p>
         </p:txBody>
@@ -9903,7 +10737,7 @@
                 </a:solidFill>
                 <a:latin typeface="微软雅黑"/>
               </a:rPr>
-              <a:t>h=1 → h=3 这一步，loss 改善了，成功率反而掉了 2 个点。50 条 episode 的标准误约 7 个百分点，所以这一对就是噪声，我能下的结论只有“h=5 更好”。但正是这个错位，引出了后面两组实验。</a:t>
+              <a:t>h=1 → h=3 这一步，loss 改善了，成功率反而掉了 2 个点。50 条 episode 的标准误约 7 个百分点，所以这一对就是噪声，当时我留下的结论只有“h=5 更好”。记住这个成功率排序：52 / 54 / 64 —— 第 14 页会回来推翻它。</a:t>
             </a:r>
           </a:p>
         </p:txBody>
@@ -9987,7 +10821,7 @@
                 </a:solidFill>
                 <a:latin typeface="Consolas"/>
               </a:rPr>
-              <a:t>8 / 15</a:t>
+              <a:t>8 / 17</a:t>
             </a:r>
           </a:p>
         </p:txBody>
@@ -10055,7 +10889,7 @@
                 </a:solidFill>
                 <a:latin typeface="微软雅黑"/>
               </a:rPr>
-              <a:t>实验二 —— 这一组我做错了</a:t>
+              <a:t>实验二 —— 变量选错了，重做一次</a:t>
             </a:r>
           </a:p>
         </p:txBody>
@@ -10069,7 +10903,7 @@
         <p:spPr>
           <a:xfrm>
             <a:off x="777240" y="1325880"/>
-            <a:ext cx="10637215" cy="548640"/>
+            <a:ext cx="10637215" cy="914400"/>
           </a:xfrm>
           <a:prstGeom prst="rect">
             <a:avLst/>
@@ -10097,322 +10931,40 @@
                 </a:solidFill>
                 <a:latin typeface="微软雅黑"/>
               </a:rPr>
-              <a:t>原计划：固定预算只换架构，把 PLDM 塞进同一个训练循环和规划器。跑出来 PLDM 预测更差却规划更好，看着像个漂亮的反例。</a:t>
-            </a:r>
-          </a:p>
-        </p:txBody>
-      </p:sp>
-      <p:graphicFrame>
-        <p:nvGraphicFramePr>
-          <p:cNvPr id="4" name="Table 3"/>
-          <p:cNvGraphicFramePr>
-            <a:graphicFrameLocks noGrp="1"/>
-          </p:cNvGraphicFramePr>
-          <p:nvPr/>
-        </p:nvGraphicFramePr>
-        <p:xfrm>
-          <a:off x="777240" y="2057400"/>
-          <a:ext cx="7680958" cy="1097280"/>
-        </p:xfrm>
-        <a:graphic>
-          <a:graphicData uri="http://schemas.openxmlformats.org/drawingml/2006/table">
-            <a:tbl>
-              <a:tblPr firstRow="1" bandRow="1">
-                <a:tableStyleId>{5C22544A-7EE6-4342-B048-85BDC9FD1C3A}</a:tableStyleId>
-              </a:tblPr>
-              <a:tblGrid>
-                <a:gridCol w="2351314"/>
-                <a:gridCol w="1881051"/>
-                <a:gridCol w="1881051"/>
-                <a:gridCol w="1567542"/>
-              </a:tblGrid>
-              <a:tr h="365760">
-                <a:tc>
-                  <a:txBody>
-                    <a:bodyPr/>
-                    <a:lstStyle/>
-                    <a:p>
-                      <a:pPr algn="l"/>
-                    </a:p>
-                  </a:txBody>
-                  <a:tcPr marL="118872" marR="118872" marT="36576" marB="36576" anchor="ctr">
-                    <a:solidFill>
-                      <a:srgbClr val="FAF9F5"/>
-                    </a:solidFill>
-                  </a:tcPr>
-                </a:tc>
-                <a:tc>
-                  <a:txBody>
-                    <a:bodyPr/>
-                    <a:lstStyle/>
-                    <a:p>
-                      <a:pPr algn="r"/>
-                      <a:r>
-                        <a:rPr sz="1000" b="0">
-                          <a:solidFill>
-                            <a:srgbClr val="8D8779"/>
-                          </a:solidFill>
-                          <a:latin typeface="微软雅黑"/>
-                        </a:rPr>
-                        <a:t>pred_loss</a:t>
-                      </a:r>
-                    </a:p>
-                  </a:txBody>
-                  <a:tcPr marL="118872" marR="118872" marT="36576" marB="36576" anchor="ctr">
-                    <a:solidFill>
-                      <a:srgbClr val="FAF9F5"/>
-                    </a:solidFill>
-                  </a:tcPr>
-                </a:tc>
-                <a:tc>
-                  <a:txBody>
-                    <a:bodyPr/>
-                    <a:lstStyle/>
-                    <a:p>
-                      <a:pPr algn="r"/>
-                      <a:r>
-                        <a:rPr sz="1000" b="0">
-                          <a:solidFill>
-                            <a:srgbClr val="8D8779"/>
-                          </a:solidFill>
-                          <a:latin typeface="微软雅黑"/>
-                        </a:rPr>
-                        <a:t>规划成功率</a:t>
-                      </a:r>
-                    </a:p>
-                  </a:txBody>
-                  <a:tcPr marL="118872" marR="118872" marT="36576" marB="36576" anchor="ctr">
-                    <a:solidFill>
-                      <a:srgbClr val="FAF9F5"/>
-                    </a:solidFill>
-                  </a:tcPr>
-                </a:tc>
-                <a:tc>
-                  <a:txBody>
-                    <a:bodyPr/>
-                    <a:lstStyle/>
-                    <a:p>
-                      <a:pPr algn="r"/>
-                      <a:r>
-                        <a:rPr sz="1000" b="0">
-                          <a:solidFill>
-                            <a:srgbClr val="8D8779"/>
-                          </a:solidFill>
-                          <a:latin typeface="微软雅黑"/>
-                        </a:rPr>
-                        <a:t>死维度</a:t>
-                      </a:r>
-                    </a:p>
-                  </a:txBody>
-                  <a:tcPr marL="118872" marR="118872" marT="36576" marB="36576" anchor="ctr">
-                    <a:solidFill>
-                      <a:srgbClr val="FAF9F5"/>
-                    </a:solidFill>
-                  </a:tcPr>
-                </a:tc>
-              </a:tr>
-              <a:tr h="365760">
-                <a:tc>
-                  <a:txBody>
-                    <a:bodyPr/>
-                    <a:lstStyle/>
-                    <a:p>
-                      <a:pPr algn="l"/>
-                      <a:r>
-                        <a:rPr sz="1200" b="0">
-                          <a:solidFill>
-                            <a:srgbClr val="17150F"/>
-                          </a:solidFill>
-                          <a:latin typeface="微软雅黑"/>
-                        </a:rPr>
-                        <a:t>LeWM h=3</a:t>
-                      </a:r>
-                    </a:p>
-                  </a:txBody>
-                  <a:tcPr marL="118872" marR="118872" marT="36576" marB="36576" anchor="ctr">
-                    <a:solidFill>
-                      <a:srgbClr val="FFFFFF"/>
-                    </a:solidFill>
-                  </a:tcPr>
-                </a:tc>
-                <a:tc>
-                  <a:txBody>
-                    <a:bodyPr/>
-                    <a:lstStyle/>
-                    <a:p>
-                      <a:pPr algn="r"/>
-                      <a:r>
-                        <a:rPr sz="1200" b="0">
-                          <a:solidFill>
-                            <a:srgbClr val="17150F"/>
-                          </a:solidFill>
-                          <a:latin typeface="Consolas"/>
-                        </a:rPr>
-                        <a:t>0.266</a:t>
-                      </a:r>
-                    </a:p>
-                  </a:txBody>
-                  <a:tcPr marL="118872" marR="118872" marT="36576" marB="36576" anchor="ctr">
-                    <a:solidFill>
-                      <a:srgbClr val="FFFFFF"/>
-                    </a:solidFill>
-                  </a:tcPr>
-                </a:tc>
-                <a:tc>
-                  <a:txBody>
-                    <a:bodyPr/>
-                    <a:lstStyle/>
-                    <a:p>
-                      <a:pPr algn="r"/>
-                      <a:r>
-                        <a:rPr sz="1200" b="0">
-                          <a:solidFill>
-                            <a:srgbClr val="17150F"/>
-                          </a:solidFill>
-                          <a:latin typeface="Consolas"/>
-                        </a:rPr>
-                        <a:t>52%</a:t>
-                      </a:r>
-                    </a:p>
-                  </a:txBody>
-                  <a:tcPr marL="118872" marR="118872" marT="36576" marB="36576" anchor="ctr">
-                    <a:solidFill>
-                      <a:srgbClr val="FFFFFF"/>
-                    </a:solidFill>
-                  </a:tcPr>
-                </a:tc>
-                <a:tc>
-                  <a:txBody>
-                    <a:bodyPr/>
-                    <a:lstStyle/>
-                    <a:p>
-                      <a:pPr algn="r"/>
-                      <a:r>
-                        <a:rPr sz="1200" b="0">
-                          <a:solidFill>
-                            <a:srgbClr val="17150F"/>
-                          </a:solidFill>
-                          <a:latin typeface="Consolas"/>
-                        </a:rPr>
-                        <a:t>0 / 192</a:t>
-                      </a:r>
-                    </a:p>
-                  </a:txBody>
-                  <a:tcPr marL="118872" marR="118872" marT="36576" marB="36576" anchor="ctr">
-                    <a:solidFill>
-                      <a:srgbClr val="FFFFFF"/>
-                    </a:solidFill>
-                  </a:tcPr>
-                </a:tc>
-              </a:tr>
-              <a:tr h="365760">
-                <a:tc>
-                  <a:txBody>
-                    <a:bodyPr/>
-                    <a:lstStyle/>
-                    <a:p>
-                      <a:pPr algn="l"/>
-                      <a:r>
-                        <a:rPr sz="1200" b="0">
-                          <a:solidFill>
-                            <a:srgbClr val="17150F"/>
-                          </a:solidFill>
-                          <a:latin typeface="微软雅黑"/>
-                        </a:rPr>
-                        <a:t>PLDM</a:t>
-                      </a:r>
-                    </a:p>
-                  </a:txBody>
-                  <a:tcPr marL="118872" marR="118872" marT="36576" marB="36576" anchor="ctr">
-                    <a:solidFill>
-                      <a:srgbClr val="FFFFFF"/>
-                    </a:solidFill>
-                  </a:tcPr>
-                </a:tc>
-                <a:tc>
-                  <a:txBody>
-                    <a:bodyPr/>
-                    <a:lstStyle/>
-                    <a:p>
-                      <a:pPr algn="r"/>
-                      <a:r>
-                        <a:rPr sz="1200" b="0">
-                          <a:solidFill>
-                            <a:srgbClr val="17150F"/>
-                          </a:solidFill>
-                          <a:latin typeface="Consolas"/>
-                        </a:rPr>
-                        <a:t>0.298（更差）</a:t>
-                      </a:r>
-                    </a:p>
-                  </a:txBody>
-                  <a:tcPr marL="118872" marR="118872" marT="36576" marB="36576" anchor="ctr">
-                    <a:solidFill>
-                      <a:srgbClr val="FFFFFF"/>
-                    </a:solidFill>
-                  </a:tcPr>
-                </a:tc>
-                <a:tc>
-                  <a:txBody>
-                    <a:bodyPr/>
-                    <a:lstStyle/>
-                    <a:p>
-                      <a:pPr algn="r"/>
-                      <a:r>
-                        <a:rPr sz="1200" b="0">
-                          <a:solidFill>
-                            <a:srgbClr val="17150F"/>
-                          </a:solidFill>
-                          <a:latin typeface="Consolas"/>
-                        </a:rPr>
-                        <a:t>66%（更好）</a:t>
-                      </a:r>
-                    </a:p>
-                  </a:txBody>
-                  <a:tcPr marL="118872" marR="118872" marT="36576" marB="36576" anchor="ctr">
-                    <a:solidFill>
-                      <a:srgbClr val="FFFFFF"/>
-                    </a:solidFill>
-                  </a:tcPr>
-                </a:tc>
-                <a:tc>
-                  <a:txBody>
-                    <a:bodyPr/>
-                    <a:lstStyle/>
-                    <a:p>
-                      <a:pPr algn="r"/>
-                      <a:r>
-                        <a:rPr sz="1200" b="0">
-                          <a:solidFill>
-                            <a:srgbClr val="17150F"/>
-                          </a:solidFill>
-                          <a:latin typeface="Consolas"/>
-                        </a:rPr>
-                        <a:t>0 / 192</a:t>
-                      </a:r>
-                    </a:p>
-                  </a:txBody>
-                  <a:tcPr marL="118872" marR="118872" marT="36576" marB="36576" anchor="ctr">
-                    <a:solidFill>
-                      <a:srgbClr val="FFFFFF"/>
-                    </a:solidFill>
-                  </a:tcPr>
-                </a:tc>
-              </a:tr>
-            </a:tbl>
-          </a:graphicData>
-        </a:graphic>
-      </p:graphicFrame>
-      <p:sp>
-        <p:nvSpPr>
-          <p:cNvPr id="5" name="TextBox 4"/>
+              <a:t>原计划：固定预算只换架构，把 PLDM 和 LeWM 放进同一个训练循环和规划器。跑出来 PLDM 预测更差却规划更好，看着像个漂亮的反例。</a:t>
+            </a:r>
+          </a:p>
+          <a:p>
+            <a:pPr>
+              <a:lnSpc>
+                <a:spcPct val="145000"/>
+              </a:lnSpc>
+              <a:spcAft>
+                <a:spcPts val="600"/>
+              </a:spcAft>
+            </a:pPr>
+            <a:r>
+              <a:rPr sz="1250" b="0">
+                <a:solidFill>
+                  <a:srgbClr val="C8402E"/>
+                </a:solidFill>
+                <a:latin typeface="微软雅黑"/>
+              </a:rPr>
+              <a:t>但这个设计本身就是错的：JEPA 是一个方法家族，成员共享架构，区别在 anti-collapse loss。我只换了模型类、loss 仍然是 LeWM 的 SIGReg——两臂跑的是同一个方法。证据：两份训练日志都在报 sigreg_loss，真正的 PLDM 不该有这一项。</a:t>
+            </a:r>
+          </a:p>
+        </p:txBody>
+      </p:sp>
+      <p:sp>
+        <p:nvSpPr>
+          <p:cNvPr id="4" name="TextBox 3"/>
           <p:cNvSpPr txBox="1"/>
           <p:nvPr/>
         </p:nvSpPr>
         <p:spPr>
           <a:xfrm>
-            <a:off x="777240" y="3657600"/>
-            <a:ext cx="10637215" cy="2103120"/>
+            <a:off x="777240" y="2542032"/>
+            <a:ext cx="10637215" cy="502920"/>
           </a:xfrm>
           <a:prstGeom prst="rect">
             <a:avLst/>
@@ -10434,93 +10986,41 @@
               </a:spcAft>
             </a:pPr>
             <a:r>
-              <a:rPr sz="1400" b="1">
-                <a:solidFill>
-                  <a:srgbClr val="C8402E"/>
+              <a:rPr sz="1250" b="0">
+                <a:solidFill>
+                  <a:srgbClr val="4A463B"/>
                 </a:solidFill>
                 <a:latin typeface="微软雅黑"/>
               </a:rPr>
-              <a:t>但它不成立。事后 diff 发现三件事：</a:t>
-            </a:r>
-          </a:p>
-          <a:p>
-            <a:pPr>
-              <a:lnSpc>
-                <a:spcPct val="145000"/>
-              </a:lnSpc>
-              <a:spcAft>
-                <a:spcPts val="400"/>
-              </a:spcAft>
-            </a:pPr>
-            <a:r>
-              <a:rPr sz="1250" b="0">
-                <a:solidFill>
-                  <a:srgbClr val="4A463B"/>
-                </a:solidFill>
-                <a:latin typeface="微软雅黑"/>
-              </a:rPr>
-              <a:t>1.  pldm/module.py 和 lewm/module.py 逐字节相同——从来就不是架构对比</a:t>
-            </a:r>
-          </a:p>
-          <a:p>
-            <a:pPr>
-              <a:lnSpc>
-                <a:spcPct val="145000"/>
-              </a:lnSpc>
-              <a:spcAft>
-                <a:spcPts val="400"/>
-              </a:spcAft>
-            </a:pPr>
-            <a:r>
-              <a:rPr sz="1250" b="0">
-                <a:solidFill>
-                  <a:srgbClr val="4A463B"/>
-                </a:solidFill>
-                <a:latin typeface="微软雅黑"/>
-              </a:rPr>
-              <a:t>2.  train.py 没给 Manager 传 seed，两次初始权重不同（训练开始前 sanity loss 就是 5.147 vs 5.001）</a:t>
-            </a:r>
-          </a:p>
-          <a:p>
-            <a:pPr>
-              <a:lnSpc>
-                <a:spcPct val="145000"/>
-              </a:lnSpc>
-              <a:spcAft>
-                <a:spcPts val="1000"/>
-              </a:spcAft>
-            </a:pPr>
-            <a:r>
-              <a:rPr sz="1250" b="0">
-                <a:solidFill>
-                  <a:srgbClr val="4A463B"/>
-                </a:solidFill>
-                <a:latin typeface="微软雅黑"/>
-              </a:rPr>
-              <a:t>3.  14 个点：z = 1.44，p = 0.15，95% CI [-5, +33] 跨过 0</a:t>
-            </a:r>
-          </a:p>
-          <a:p>
-            <a:pPr>
-              <a:lnSpc>
-                <a:spcPct val="145000"/>
-              </a:lnSpc>
-              <a:spcAft>
-                <a:spcPts val="600"/>
-              </a:spcAft>
-            </a:pPr>
-            <a:r>
-              <a:rPr sz="1200" b="0">
-                <a:solidFill>
-                  <a:srgbClr val="8D8779"/>
-                </a:solidFill>
-                <a:latin typeface="微软雅黑"/>
-              </a:rPr>
-              <a:t>所以它实际是一次意外的重跑方差测量：同架构、同数据、同配方，仅初始化不同，成功率相差 14 个百分点。这给了整个项目一把尺子——15 个百分点以内的差距都不能当结论。</a:t>
-            </a:r>
-          </a:p>
-        </p:txBody>
-      </p:sp>
+              <a:t>重写训练脚本：架构、数据、预算、规划器全部固定，只换防塌缩机制（SIGReg×1 对 VCReg×4 + 时序对齐 + 逆动力学 = 6 项），补上 Manager 的 seed，每臂 3 个 seed。</a:t>
+            </a:r>
+          </a:p>
+        </p:txBody>
+      </p:sp>
+      <p:pic>
+        <p:nvPicPr>
+          <p:cNvPr id="5" name="Picture 4" descr="exp2_seed_variance.png"/>
+          <p:cNvPicPr>
+            <a:picLocks noChangeAspect="1"/>
+          </p:cNvPicPr>
+          <p:nvPr/>
+        </p:nvPicPr>
+        <p:blipFill>
+          <a:blip r:embed="rId2"/>
+          <a:stretch>
+            <a:fillRect/>
+          </a:stretch>
+        </p:blipFill>
+        <p:spPr>
+          <a:xfrm>
+            <a:off x="3846799" y="3127248"/>
+            <a:ext cx="4498096" cy="1920240"/>
+          </a:xfrm>
+          <a:prstGeom prst="rect">
+            <a:avLst/>
+          </a:prstGeom>
+        </p:spPr>
+      </p:pic>
       <p:sp>
         <p:nvSpPr>
           <p:cNvPr id="6" name="TextBox 5"/>
@@ -10529,8 +11029,8 @@
         </p:nvSpPr>
         <p:spPr>
           <a:xfrm>
-            <a:off x="777240" y="6291072"/>
-            <a:ext cx="9539935" cy="292608"/>
+            <a:off x="777240" y="5257800"/>
+            <a:ext cx="10637215" cy="1005840"/>
           </a:xfrm>
           <a:prstGeom prst="rect">
             <a:avLst/>
@@ -10548,17 +11048,36 @@
                 <a:spcPct val="145000"/>
               </a:lnSpc>
               <a:spcAft>
+                <a:spcPts val="400"/>
+              </a:spcAft>
+            </a:pPr>
+            <a:r>
+              <a:rPr sz="1300" b="1">
+                <a:solidFill>
+                  <a:srgbClr val="17150F"/>
+                </a:solidFill>
+                <a:latin typeface="微软雅黑"/>
+              </a:rPr>
+              <a:t>LeWM 55.3% 对 PLDM 43.3%，t = 0.87，95% CI [-27, +51]。方向和论文一致，但完全不显著。</a:t>
+            </a:r>
+          </a:p>
+          <a:p>
+            <a:pPr>
+              <a:lnSpc>
+                <a:spcPct val="145000"/>
+              </a:lnSpc>
+              <a:spcAft>
                 <a:spcPts val="600"/>
               </a:spcAft>
             </a:pPr>
             <a:r>
-              <a:rPr sz="950" b="0">
+              <a:rPr sz="1200" b="0">
                 <a:solidFill>
                   <a:srgbClr val="8D8779"/>
                 </a:solidFill>
-                <a:latin typeface="Consolas"/>
-              </a:rPr>
-              <a:t>03_experiments/exp2_pldm/</a:t>
+                <a:latin typeface="微软雅黑"/>
+              </a:rPr>
+              <a:t>真正的产出是那个标准差：同配置、同数据，只换 seed，成功率能从 36% 走到 70%——±17 个百分点。要在 80% 功效下测出 10 个点的差异，每臂约需 45 个 seed。我有 1 个。</a:t>
             </a:r>
           </a:p>
         </p:txBody>
@@ -10571,8 +11090,8 @@
         </p:nvSpPr>
         <p:spPr>
           <a:xfrm>
-            <a:off x="10317175" y="6291072"/>
-            <a:ext cx="1097280" cy="292608"/>
+            <a:off x="777240" y="6291072"/>
+            <a:ext cx="9539935" cy="292608"/>
           </a:xfrm>
           <a:prstGeom prst="rect">
             <a:avLst/>
@@ -10585,6 +11104,48 @@
           </a:bodyPr>
           <a:lstStyle/>
           <a:p>
+            <a:pPr algn="l">
+              <a:lnSpc>
+                <a:spcPct val="145000"/>
+              </a:lnSpc>
+              <a:spcAft>
+                <a:spcPts val="600"/>
+              </a:spcAft>
+            </a:pPr>
+            <a:r>
+              <a:rPr sz="950" b="0">
+                <a:solidFill>
+                  <a:srgbClr val="8D8779"/>
+                </a:solidFill>
+                <a:latin typeface="Consolas"/>
+              </a:rPr>
+              <a:t>03_experiments/exp2_pldm/</a:t>
+            </a:r>
+          </a:p>
+        </p:txBody>
+      </p:sp>
+      <p:sp>
+        <p:nvSpPr>
+          <p:cNvPr id="8" name="TextBox 7"/>
+          <p:cNvSpPr txBox="1"/>
+          <p:nvPr/>
+        </p:nvSpPr>
+        <p:spPr>
+          <a:xfrm>
+            <a:off x="10317175" y="6291072"/>
+            <a:ext cx="1097280" cy="292608"/>
+          </a:xfrm>
+          <a:prstGeom prst="rect">
+            <a:avLst/>
+          </a:prstGeom>
+          <a:noFill/>
+        </p:spPr>
+        <p:txBody>
+          <a:bodyPr wrap="square" anchor="t">
+            <a:spAutoFit/>
+          </a:bodyPr>
+          <a:lstStyle/>
+          <a:p>
             <a:pPr algn="r">
               <a:lnSpc>
                 <a:spcPct val="145000"/>
@@ -10600,7 +11161,7 @@
                 </a:solidFill>
                 <a:latin typeface="Consolas"/>
               </a:rPr>
-              <a:t>9 / 15</a:t>
+              <a:t>9 / 17</a:t>
             </a:r>
           </a:p>
         </p:txBody>

</xml_diff>